<commit_message>
update ID00 Lab Setup presentation file
</commit_message>
<xml_diff>
--- a/P2P_Leakage/Presentation/ID00_Lab_Setup.pptx
+++ b/P2P_Leakage/Presentation/ID00_Lab_Setup.pptx
@@ -184,6 +184,1761 @@
 <file path=ppt/changesInfos/changesInfo1.xml><?xml version="1.0" encoding="utf-8"?>
 <pc:chgInfo xmlns:a="http://schemas.openxmlformats.org/drawingml/2006/main" xmlns:r="http://schemas.openxmlformats.org/officeDocument/2006/relationships" xmlns:ac="http://schemas.microsoft.com/office/drawing/2013/main/command" xmlns:pc="http://schemas.microsoft.com/office/powerpoint/2013/main/command">
   <pc:docChgLst>
+    <pc:chgData name="Malcolm Hayward" userId="fd045f5c-b77a-4191-aa2e-0c5f24668c72" providerId="ADAL" clId="{F2B84187-37ED-4459-971D-E4FC052BE502}"/>
+    <pc:docChg chg="undo custSel addSld delSld modSld sldOrd">
+      <pc:chgData name="Malcolm Hayward" userId="fd045f5c-b77a-4191-aa2e-0c5f24668c72" providerId="ADAL" clId="{F2B84187-37ED-4459-971D-E4FC052BE502}" dt="2021-04-23T23:44:22.687" v="12551" actId="20577"/>
+      <pc:docMkLst>
+        <pc:docMk/>
+      </pc:docMkLst>
+      <pc:sldChg chg="modSp mod addCm modCm">
+        <pc:chgData name="Malcolm Hayward" userId="fd045f5c-b77a-4191-aa2e-0c5f24668c72" providerId="ADAL" clId="{F2B84187-37ED-4459-971D-E4FC052BE502}" dt="2021-04-23T23:43:38.083" v="12533"/>
+        <pc:sldMkLst>
+          <pc:docMk/>
+          <pc:sldMk cId="1173531828" sldId="257"/>
+        </pc:sldMkLst>
+        <pc:spChg chg="mod">
+          <ac:chgData name="Malcolm Hayward" userId="fd045f5c-b77a-4191-aa2e-0c5f24668c72" providerId="ADAL" clId="{F2B84187-37ED-4459-971D-E4FC052BE502}" dt="2021-04-17T05:43:01.890" v="10107" actId="20577"/>
+          <ac:spMkLst>
+            <pc:docMk/>
+            <pc:sldMk cId="1173531828" sldId="257"/>
+            <ac:spMk id="3" creationId="{FBACFB0F-0E9A-48D4-97A7-27723CDED9AC}"/>
+          </ac:spMkLst>
+        </pc:spChg>
+      </pc:sldChg>
+      <pc:sldChg chg="modSp mod">
+        <pc:chgData name="Malcolm Hayward" userId="fd045f5c-b77a-4191-aa2e-0c5f24668c72" providerId="ADAL" clId="{F2B84187-37ED-4459-971D-E4FC052BE502}" dt="2021-04-16T06:09:01.570" v="9961" actId="1076"/>
+        <pc:sldMkLst>
+          <pc:docMk/>
+          <pc:sldMk cId="330888168" sldId="258"/>
+        </pc:sldMkLst>
+        <pc:spChg chg="mod">
+          <ac:chgData name="Malcolm Hayward" userId="fd045f5c-b77a-4191-aa2e-0c5f24668c72" providerId="ADAL" clId="{F2B84187-37ED-4459-971D-E4FC052BE502}" dt="2021-04-12T14:52:27.289" v="7584" actId="20577"/>
+          <ac:spMkLst>
+            <pc:docMk/>
+            <pc:sldMk cId="330888168" sldId="258"/>
+            <ac:spMk id="2" creationId="{1D3B01B3-DBAD-4764-BF44-57D5C2C3E788}"/>
+          </ac:spMkLst>
+        </pc:spChg>
+        <pc:spChg chg="mod">
+          <ac:chgData name="Malcolm Hayward" userId="fd045f5c-b77a-4191-aa2e-0c5f24668c72" providerId="ADAL" clId="{F2B84187-37ED-4459-971D-E4FC052BE502}" dt="2021-03-28T19:06:33.581" v="315" actId="20577"/>
+          <ac:spMkLst>
+            <pc:docMk/>
+            <pc:sldMk cId="330888168" sldId="258"/>
+            <ac:spMk id="3" creationId="{B536B83B-5F93-42E4-BC74-98042FCC0898}"/>
+          </ac:spMkLst>
+        </pc:spChg>
+        <pc:picChg chg="mod">
+          <ac:chgData name="Malcolm Hayward" userId="fd045f5c-b77a-4191-aa2e-0c5f24668c72" providerId="ADAL" clId="{F2B84187-37ED-4459-971D-E4FC052BE502}" dt="2021-04-16T06:09:01.570" v="9961" actId="1076"/>
+          <ac:picMkLst>
+            <pc:docMk/>
+            <pc:sldMk cId="330888168" sldId="258"/>
+            <ac:picMk id="9" creationId="{9C85B62B-EF63-40F6-8E48-8BA60687C8F6}"/>
+          </ac:picMkLst>
+        </pc:picChg>
+      </pc:sldChg>
+      <pc:sldChg chg="addSp delSp modSp new mod addCm delCm">
+        <pc:chgData name="Malcolm Hayward" userId="fd045f5c-b77a-4191-aa2e-0c5f24668c72" providerId="ADAL" clId="{F2B84187-37ED-4459-971D-E4FC052BE502}" dt="2021-04-23T23:44:22.687" v="12551" actId="20577"/>
+        <pc:sldMkLst>
+          <pc:docMk/>
+          <pc:sldMk cId="2696214102" sldId="259"/>
+        </pc:sldMkLst>
+        <pc:spChg chg="mod">
+          <ac:chgData name="Malcolm Hayward" userId="fd045f5c-b77a-4191-aa2e-0c5f24668c72" providerId="ADAL" clId="{F2B84187-37ED-4459-971D-E4FC052BE502}" dt="2021-03-28T18:58:55.438" v="72" actId="20577"/>
+          <ac:spMkLst>
+            <pc:docMk/>
+            <pc:sldMk cId="2696214102" sldId="259"/>
+            <ac:spMk id="2" creationId="{72EA782D-BD19-48DD-8DE9-C41B8EA69D07}"/>
+          </ac:spMkLst>
+        </pc:spChg>
+        <pc:spChg chg="mod">
+          <ac:chgData name="Malcolm Hayward" userId="fd045f5c-b77a-4191-aa2e-0c5f24668c72" providerId="ADAL" clId="{F2B84187-37ED-4459-971D-E4FC052BE502}" dt="2021-04-23T23:44:22.687" v="12551" actId="20577"/>
+          <ac:spMkLst>
+            <pc:docMk/>
+            <pc:sldMk cId="2696214102" sldId="259"/>
+            <ac:spMk id="3" creationId="{3862E7A1-A22F-4D0F-A7E9-51C8CDDA6527}"/>
+          </ac:spMkLst>
+        </pc:spChg>
+        <pc:spChg chg="add del mod">
+          <ac:chgData name="Malcolm Hayward" userId="fd045f5c-b77a-4191-aa2e-0c5f24668c72" providerId="ADAL" clId="{F2B84187-37ED-4459-971D-E4FC052BE502}" dt="2021-03-29T13:30:07.929" v="6987" actId="478"/>
+          <ac:spMkLst>
+            <pc:docMk/>
+            <pc:sldMk cId="2696214102" sldId="259"/>
+            <ac:spMk id="4" creationId="{57F1D51E-EC35-418C-9E0B-7889F5251006}"/>
+          </ac:spMkLst>
+        </pc:spChg>
+        <pc:spChg chg="add mod">
+          <ac:chgData name="Malcolm Hayward" userId="fd045f5c-b77a-4191-aa2e-0c5f24668c72" providerId="ADAL" clId="{F2B84187-37ED-4459-971D-E4FC052BE502}" dt="2021-03-30T21:13:47.313" v="7448" actId="12"/>
+          <ac:spMkLst>
+            <pc:docMk/>
+            <pc:sldMk cId="2696214102" sldId="259"/>
+            <ac:spMk id="4" creationId="{D87AE1B0-F910-4DE1-93EC-F2E8AF23907D}"/>
+          </ac:spMkLst>
+        </pc:spChg>
+        <pc:spChg chg="add mod">
+          <ac:chgData name="Malcolm Hayward" userId="fd045f5c-b77a-4191-aa2e-0c5f24668c72" providerId="ADAL" clId="{F2B84187-37ED-4459-971D-E4FC052BE502}" dt="2021-03-30T21:13:23.078" v="7446" actId="12"/>
+          <ac:spMkLst>
+            <pc:docMk/>
+            <pc:sldMk cId="2696214102" sldId="259"/>
+            <ac:spMk id="5" creationId="{2D8008C4-E3C9-4206-BEA1-84962D1EECEC}"/>
+          </ac:spMkLst>
+        </pc:spChg>
+      </pc:sldChg>
+      <pc:sldChg chg="modSp new mod">
+        <pc:chgData name="Malcolm Hayward" userId="fd045f5c-b77a-4191-aa2e-0c5f24668c72" providerId="ADAL" clId="{F2B84187-37ED-4459-971D-E4FC052BE502}" dt="2021-03-29T04:01:22.450" v="5881" actId="20577"/>
+        <pc:sldMkLst>
+          <pc:docMk/>
+          <pc:sldMk cId="2554469295" sldId="260"/>
+        </pc:sldMkLst>
+        <pc:spChg chg="mod">
+          <ac:chgData name="Malcolm Hayward" userId="fd045f5c-b77a-4191-aa2e-0c5f24668c72" providerId="ADAL" clId="{F2B84187-37ED-4459-971D-E4FC052BE502}" dt="2021-03-28T18:59:07.559" v="127" actId="20577"/>
+          <ac:spMkLst>
+            <pc:docMk/>
+            <pc:sldMk cId="2554469295" sldId="260"/>
+            <ac:spMk id="2" creationId="{1A3FC82E-5227-4B5D-B08D-ED3E9E524F6D}"/>
+          </ac:spMkLst>
+        </pc:spChg>
+        <pc:spChg chg="mod">
+          <ac:chgData name="Malcolm Hayward" userId="fd045f5c-b77a-4191-aa2e-0c5f24668c72" providerId="ADAL" clId="{F2B84187-37ED-4459-971D-E4FC052BE502}" dt="2021-03-29T04:01:22.450" v="5881" actId="20577"/>
+          <ac:spMkLst>
+            <pc:docMk/>
+            <pc:sldMk cId="2554469295" sldId="260"/>
+            <ac:spMk id="3" creationId="{3BA30A2E-1BF0-49E4-80D5-BB47E80CBD3E}"/>
+          </ac:spMkLst>
+        </pc:spChg>
+      </pc:sldChg>
+      <pc:sldChg chg="modSp new mod">
+        <pc:chgData name="Malcolm Hayward" userId="fd045f5c-b77a-4191-aa2e-0c5f24668c72" providerId="ADAL" clId="{F2B84187-37ED-4459-971D-E4FC052BE502}" dt="2021-04-17T08:26:22.732" v="11650" actId="20577"/>
+        <pc:sldMkLst>
+          <pc:docMk/>
+          <pc:sldMk cId="1758211574" sldId="261"/>
+        </pc:sldMkLst>
+        <pc:spChg chg="mod">
+          <ac:chgData name="Malcolm Hayward" userId="fd045f5c-b77a-4191-aa2e-0c5f24668c72" providerId="ADAL" clId="{F2B84187-37ED-4459-971D-E4FC052BE502}" dt="2021-03-28T19:17:06.620" v="540" actId="20577"/>
+          <ac:spMkLst>
+            <pc:docMk/>
+            <pc:sldMk cId="1758211574" sldId="261"/>
+            <ac:spMk id="2" creationId="{817FAD62-355E-43DE-95BD-6915F7867A48}"/>
+          </ac:spMkLst>
+        </pc:spChg>
+        <pc:spChg chg="mod">
+          <ac:chgData name="Malcolm Hayward" userId="fd045f5c-b77a-4191-aa2e-0c5f24668c72" providerId="ADAL" clId="{F2B84187-37ED-4459-971D-E4FC052BE502}" dt="2021-04-17T08:26:22.732" v="11650" actId="20577"/>
+          <ac:spMkLst>
+            <pc:docMk/>
+            <pc:sldMk cId="1758211574" sldId="261"/>
+            <ac:spMk id="3" creationId="{689D8F08-8365-4E2C-BFB6-D1790294648E}"/>
+          </ac:spMkLst>
+        </pc:spChg>
+      </pc:sldChg>
+      <pc:sldChg chg="modSp new mod">
+        <pc:chgData name="Malcolm Hayward" userId="fd045f5c-b77a-4191-aa2e-0c5f24668c72" providerId="ADAL" clId="{F2B84187-37ED-4459-971D-E4FC052BE502}" dt="2021-03-29T03:25:38.286" v="5081" actId="20577"/>
+        <pc:sldMkLst>
+          <pc:docMk/>
+          <pc:sldMk cId="651205157" sldId="262"/>
+        </pc:sldMkLst>
+        <pc:spChg chg="mod">
+          <ac:chgData name="Malcolm Hayward" userId="fd045f5c-b77a-4191-aa2e-0c5f24668c72" providerId="ADAL" clId="{F2B84187-37ED-4459-971D-E4FC052BE502}" dt="2021-03-28T20:36:51.325" v="2984" actId="20577"/>
+          <ac:spMkLst>
+            <pc:docMk/>
+            <pc:sldMk cId="651205157" sldId="262"/>
+            <ac:spMk id="2" creationId="{615B923B-CE6E-42FA-AF3A-862855EAD0CC}"/>
+          </ac:spMkLst>
+        </pc:spChg>
+        <pc:spChg chg="mod">
+          <ac:chgData name="Malcolm Hayward" userId="fd045f5c-b77a-4191-aa2e-0c5f24668c72" providerId="ADAL" clId="{F2B84187-37ED-4459-971D-E4FC052BE502}" dt="2021-03-29T03:25:38.286" v="5081" actId="20577"/>
+          <ac:spMkLst>
+            <pc:docMk/>
+            <pc:sldMk cId="651205157" sldId="262"/>
+            <ac:spMk id="3" creationId="{6E9D4976-9C25-41E0-9243-FA2033B1564E}"/>
+          </ac:spMkLst>
+        </pc:spChg>
+      </pc:sldChg>
+      <pc:sldChg chg="addSp modSp new mod">
+        <pc:chgData name="Malcolm Hayward" userId="fd045f5c-b77a-4191-aa2e-0c5f24668c72" providerId="ADAL" clId="{F2B84187-37ED-4459-971D-E4FC052BE502}" dt="2021-03-28T20:39:58.046" v="3100" actId="20577"/>
+        <pc:sldMkLst>
+          <pc:docMk/>
+          <pc:sldMk cId="1216375069" sldId="263"/>
+        </pc:sldMkLst>
+        <pc:spChg chg="mod">
+          <ac:chgData name="Malcolm Hayward" userId="fd045f5c-b77a-4191-aa2e-0c5f24668c72" providerId="ADAL" clId="{F2B84187-37ED-4459-971D-E4FC052BE502}" dt="2021-03-28T19:22:13.300" v="851" actId="20577"/>
+          <ac:spMkLst>
+            <pc:docMk/>
+            <pc:sldMk cId="1216375069" sldId="263"/>
+            <ac:spMk id="2" creationId="{66009DFB-F695-4564-8B48-EE605618ADD8}"/>
+          </ac:spMkLst>
+        </pc:spChg>
+        <pc:spChg chg="mod">
+          <ac:chgData name="Malcolm Hayward" userId="fd045f5c-b77a-4191-aa2e-0c5f24668c72" providerId="ADAL" clId="{F2B84187-37ED-4459-971D-E4FC052BE502}" dt="2021-03-28T20:39:58.046" v="3100" actId="20577"/>
+          <ac:spMkLst>
+            <pc:docMk/>
+            <pc:sldMk cId="1216375069" sldId="263"/>
+            <ac:spMk id="3" creationId="{A8EBA4CE-7450-4288-964B-FC3F84AD5BED}"/>
+          </ac:spMkLst>
+        </pc:spChg>
+        <pc:picChg chg="add mod">
+          <ac:chgData name="Malcolm Hayward" userId="fd045f5c-b77a-4191-aa2e-0c5f24668c72" providerId="ADAL" clId="{F2B84187-37ED-4459-971D-E4FC052BE502}" dt="2021-03-28T19:25:21.671" v="891" actId="1076"/>
+          <ac:picMkLst>
+            <pc:docMk/>
+            <pc:sldMk cId="1216375069" sldId="263"/>
+            <ac:picMk id="5" creationId="{2F40FAAB-7DB5-4C32-88C1-818797437AD8}"/>
+          </ac:picMkLst>
+        </pc:picChg>
+      </pc:sldChg>
+      <pc:sldChg chg="addSp delSp modSp add mod">
+        <pc:chgData name="Malcolm Hayward" userId="fd045f5c-b77a-4191-aa2e-0c5f24668c72" providerId="ADAL" clId="{F2B84187-37ED-4459-971D-E4FC052BE502}" dt="2021-04-16T06:13:28.877" v="9969"/>
+        <pc:sldMkLst>
+          <pc:docMk/>
+          <pc:sldMk cId="2609369189" sldId="264"/>
+        </pc:sldMkLst>
+        <pc:spChg chg="mod">
+          <ac:chgData name="Malcolm Hayward" userId="fd045f5c-b77a-4191-aa2e-0c5f24668c72" providerId="ADAL" clId="{F2B84187-37ED-4459-971D-E4FC052BE502}" dt="2021-03-28T20:40:04.739" v="3122" actId="20577"/>
+          <ac:spMkLst>
+            <pc:docMk/>
+            <pc:sldMk cId="2609369189" sldId="264"/>
+            <ac:spMk id="3" creationId="{A8EBA4CE-7450-4288-964B-FC3F84AD5BED}"/>
+          </ac:spMkLst>
+        </pc:spChg>
+        <pc:picChg chg="del">
+          <ac:chgData name="Malcolm Hayward" userId="fd045f5c-b77a-4191-aa2e-0c5f24668c72" providerId="ADAL" clId="{F2B84187-37ED-4459-971D-E4FC052BE502}" dt="2021-03-28T19:25:36.797" v="893" actId="478"/>
+          <ac:picMkLst>
+            <pc:docMk/>
+            <pc:sldMk cId="2609369189" sldId="264"/>
+            <ac:picMk id="5" creationId="{2F40FAAB-7DB5-4C32-88C1-818797437AD8}"/>
+          </ac:picMkLst>
+        </pc:picChg>
+        <pc:picChg chg="add mod">
+          <ac:chgData name="Malcolm Hayward" userId="fd045f5c-b77a-4191-aa2e-0c5f24668c72" providerId="ADAL" clId="{F2B84187-37ED-4459-971D-E4FC052BE502}" dt="2021-04-16T06:13:28.877" v="9969"/>
+          <ac:picMkLst>
+            <pc:docMk/>
+            <pc:sldMk cId="2609369189" sldId="264"/>
+            <ac:picMk id="6" creationId="{2A720751-D04A-4B6A-82F6-86BA1D3C0C5A}"/>
+          </ac:picMkLst>
+        </pc:picChg>
+      </pc:sldChg>
+      <pc:sldChg chg="modSp new mod">
+        <pc:chgData name="Malcolm Hayward" userId="fd045f5c-b77a-4191-aa2e-0c5f24668c72" providerId="ADAL" clId="{F2B84187-37ED-4459-971D-E4FC052BE502}" dt="2021-03-28T19:34:47.925" v="2018" actId="20577"/>
+        <pc:sldMkLst>
+          <pc:docMk/>
+          <pc:sldMk cId="742731802" sldId="265"/>
+        </pc:sldMkLst>
+        <pc:spChg chg="mod">
+          <ac:chgData name="Malcolm Hayward" userId="fd045f5c-b77a-4191-aa2e-0c5f24668c72" providerId="ADAL" clId="{F2B84187-37ED-4459-971D-E4FC052BE502}" dt="2021-03-28T19:28:33.253" v="932"/>
+          <ac:spMkLst>
+            <pc:docMk/>
+            <pc:sldMk cId="742731802" sldId="265"/>
+            <ac:spMk id="2" creationId="{024EFF52-7B0F-4D3E-A182-DD6131FC06BC}"/>
+          </ac:spMkLst>
+        </pc:spChg>
+        <pc:spChg chg="mod">
+          <ac:chgData name="Malcolm Hayward" userId="fd045f5c-b77a-4191-aa2e-0c5f24668c72" providerId="ADAL" clId="{F2B84187-37ED-4459-971D-E4FC052BE502}" dt="2021-03-28T19:34:47.925" v="2018" actId="20577"/>
+          <ac:spMkLst>
+            <pc:docMk/>
+            <pc:sldMk cId="742731802" sldId="265"/>
+            <ac:spMk id="3" creationId="{82E1FF18-D4BC-4AB6-9C6C-EB3D4E162AF1}"/>
+          </ac:spMkLst>
+        </pc:spChg>
+      </pc:sldChg>
+      <pc:sldChg chg="modSp new mod">
+        <pc:chgData name="Malcolm Hayward" userId="fd045f5c-b77a-4191-aa2e-0c5f24668c72" providerId="ADAL" clId="{F2B84187-37ED-4459-971D-E4FC052BE502}" dt="2021-04-16T06:02:11.995" v="9940" actId="20577"/>
+        <pc:sldMkLst>
+          <pc:docMk/>
+          <pc:sldMk cId="1331449212" sldId="266"/>
+        </pc:sldMkLst>
+        <pc:spChg chg="mod">
+          <ac:chgData name="Malcolm Hayward" userId="fd045f5c-b77a-4191-aa2e-0c5f24668c72" providerId="ADAL" clId="{F2B84187-37ED-4459-971D-E4FC052BE502}" dt="2021-03-28T19:34:06.598" v="1851" actId="20577"/>
+          <ac:spMkLst>
+            <pc:docMk/>
+            <pc:sldMk cId="1331449212" sldId="266"/>
+            <ac:spMk id="2" creationId="{0E0614CE-54DE-42EA-B367-76749BFE192B}"/>
+          </ac:spMkLst>
+        </pc:spChg>
+        <pc:spChg chg="mod">
+          <ac:chgData name="Malcolm Hayward" userId="fd045f5c-b77a-4191-aa2e-0c5f24668c72" providerId="ADAL" clId="{F2B84187-37ED-4459-971D-E4FC052BE502}" dt="2021-04-16T06:02:11.995" v="9940" actId="20577"/>
+          <ac:spMkLst>
+            <pc:docMk/>
+            <pc:sldMk cId="1331449212" sldId="266"/>
+            <ac:spMk id="3" creationId="{2F25E115-3ED5-47F4-81C9-E486E92CB310}"/>
+          </ac:spMkLst>
+        </pc:spChg>
+      </pc:sldChg>
+      <pc:sldChg chg="addSp modSp new mod">
+        <pc:chgData name="Malcolm Hayward" userId="fd045f5c-b77a-4191-aa2e-0c5f24668c72" providerId="ADAL" clId="{F2B84187-37ED-4459-971D-E4FC052BE502}" dt="2021-04-17T08:02:53.106" v="11387" actId="1076"/>
+        <pc:sldMkLst>
+          <pc:docMk/>
+          <pc:sldMk cId="4194598108" sldId="267"/>
+        </pc:sldMkLst>
+        <pc:spChg chg="mod">
+          <ac:chgData name="Malcolm Hayward" userId="fd045f5c-b77a-4191-aa2e-0c5f24668c72" providerId="ADAL" clId="{F2B84187-37ED-4459-971D-E4FC052BE502}" dt="2021-03-28T19:41:41.052" v="2557" actId="20577"/>
+          <ac:spMkLst>
+            <pc:docMk/>
+            <pc:sldMk cId="4194598108" sldId="267"/>
+            <ac:spMk id="2" creationId="{2856EC3D-AE07-443C-B0D6-7EE8A2F2267A}"/>
+          </ac:spMkLst>
+        </pc:spChg>
+        <pc:spChg chg="mod">
+          <ac:chgData name="Malcolm Hayward" userId="fd045f5c-b77a-4191-aa2e-0c5f24668c72" providerId="ADAL" clId="{F2B84187-37ED-4459-971D-E4FC052BE502}" dt="2021-03-28T19:42:03.294" v="2586" actId="20577"/>
+          <ac:spMkLst>
+            <pc:docMk/>
+            <pc:sldMk cId="4194598108" sldId="267"/>
+            <ac:spMk id="3" creationId="{9C3B2489-2303-4714-B415-91FFD34A87DA}"/>
+          </ac:spMkLst>
+        </pc:spChg>
+        <pc:picChg chg="add mod">
+          <ac:chgData name="Malcolm Hayward" userId="fd045f5c-b77a-4191-aa2e-0c5f24668c72" providerId="ADAL" clId="{F2B84187-37ED-4459-971D-E4FC052BE502}" dt="2021-04-17T08:02:53.106" v="11387" actId="1076"/>
+          <ac:picMkLst>
+            <pc:docMk/>
+            <pc:sldMk cId="4194598108" sldId="267"/>
+            <ac:picMk id="5" creationId="{5A8310E0-F709-4707-A0E5-EEE71BB5F3F2}"/>
+          </ac:picMkLst>
+        </pc:picChg>
+      </pc:sldChg>
+      <pc:sldChg chg="modSp new mod">
+        <pc:chgData name="Malcolm Hayward" userId="fd045f5c-b77a-4191-aa2e-0c5f24668c72" providerId="ADAL" clId="{F2B84187-37ED-4459-971D-E4FC052BE502}" dt="2021-03-28T20:40:57.609" v="3132" actId="20577"/>
+        <pc:sldMkLst>
+          <pc:docMk/>
+          <pc:sldMk cId="600868800" sldId="268"/>
+        </pc:sldMkLst>
+        <pc:spChg chg="mod">
+          <ac:chgData name="Malcolm Hayward" userId="fd045f5c-b77a-4191-aa2e-0c5f24668c72" providerId="ADAL" clId="{F2B84187-37ED-4459-971D-E4FC052BE502}" dt="2021-03-28T19:43:23.814" v="2610" actId="20577"/>
+          <ac:spMkLst>
+            <pc:docMk/>
+            <pc:sldMk cId="600868800" sldId="268"/>
+            <ac:spMk id="2" creationId="{C7DB756B-2FA9-4C52-9730-46BB8B0F0259}"/>
+          </ac:spMkLst>
+        </pc:spChg>
+        <pc:spChg chg="mod">
+          <ac:chgData name="Malcolm Hayward" userId="fd045f5c-b77a-4191-aa2e-0c5f24668c72" providerId="ADAL" clId="{F2B84187-37ED-4459-971D-E4FC052BE502}" dt="2021-03-28T20:40:57.609" v="3132" actId="20577"/>
+          <ac:spMkLst>
+            <pc:docMk/>
+            <pc:sldMk cId="600868800" sldId="268"/>
+            <ac:spMk id="3" creationId="{85620766-BC57-42B3-A70F-ACE9F3D3CDB6}"/>
+          </ac:spMkLst>
+        </pc:spChg>
+      </pc:sldChg>
+      <pc:sldChg chg="addSp delSp modSp new mod">
+        <pc:chgData name="Malcolm Hayward" userId="fd045f5c-b77a-4191-aa2e-0c5f24668c72" providerId="ADAL" clId="{F2B84187-37ED-4459-971D-E4FC052BE502}" dt="2021-04-16T04:39:11.518" v="8596" actId="14100"/>
+        <pc:sldMkLst>
+          <pc:docMk/>
+          <pc:sldMk cId="2644870450" sldId="269"/>
+        </pc:sldMkLst>
+        <pc:spChg chg="mod">
+          <ac:chgData name="Malcolm Hayward" userId="fd045f5c-b77a-4191-aa2e-0c5f24668c72" providerId="ADAL" clId="{F2B84187-37ED-4459-971D-E4FC052BE502}" dt="2021-03-28T20:14:28.802" v="2853" actId="20577"/>
+          <ac:spMkLst>
+            <pc:docMk/>
+            <pc:sldMk cId="2644870450" sldId="269"/>
+            <ac:spMk id="2" creationId="{F0D1CE63-1805-46EC-9A5B-1160C093EF5F}"/>
+          </ac:spMkLst>
+        </pc:spChg>
+        <pc:spChg chg="del mod">
+          <ac:chgData name="Malcolm Hayward" userId="fd045f5c-b77a-4191-aa2e-0c5f24668c72" providerId="ADAL" clId="{F2B84187-37ED-4459-971D-E4FC052BE502}" dt="2021-03-29T02:33:03.654" v="4347" actId="22"/>
+          <ac:spMkLst>
+            <pc:docMk/>
+            <pc:sldMk cId="2644870450" sldId="269"/>
+            <ac:spMk id="3" creationId="{6BED5169-161E-42EB-9A71-C54E18EC3DD6}"/>
+          </ac:spMkLst>
+        </pc:spChg>
+        <pc:picChg chg="add mod ord">
+          <ac:chgData name="Malcolm Hayward" userId="fd045f5c-b77a-4191-aa2e-0c5f24668c72" providerId="ADAL" clId="{F2B84187-37ED-4459-971D-E4FC052BE502}" dt="2021-04-16T04:39:11.518" v="8596" actId="14100"/>
+          <ac:picMkLst>
+            <pc:docMk/>
+            <pc:sldMk cId="2644870450" sldId="269"/>
+            <ac:picMk id="5" creationId="{4FAA9375-CCB5-4525-9D65-180456561FC9}"/>
+          </ac:picMkLst>
+        </pc:picChg>
+      </pc:sldChg>
+      <pc:sldChg chg="modSp new mod">
+        <pc:chgData name="Malcolm Hayward" userId="fd045f5c-b77a-4191-aa2e-0c5f24668c72" providerId="ADAL" clId="{F2B84187-37ED-4459-971D-E4FC052BE502}" dt="2021-03-29T03:13:18.787" v="4926" actId="20577"/>
+        <pc:sldMkLst>
+          <pc:docMk/>
+          <pc:sldMk cId="1440112597" sldId="270"/>
+        </pc:sldMkLst>
+        <pc:spChg chg="mod">
+          <ac:chgData name="Malcolm Hayward" userId="fd045f5c-b77a-4191-aa2e-0c5f24668c72" providerId="ADAL" clId="{F2B84187-37ED-4459-971D-E4FC052BE502}" dt="2021-03-28T21:55:20.762" v="3200" actId="20577"/>
+          <ac:spMkLst>
+            <pc:docMk/>
+            <pc:sldMk cId="1440112597" sldId="270"/>
+            <ac:spMk id="2" creationId="{263EF22C-9BE2-48C4-8373-F8ACE9802E06}"/>
+          </ac:spMkLst>
+        </pc:spChg>
+        <pc:spChg chg="mod">
+          <ac:chgData name="Malcolm Hayward" userId="fd045f5c-b77a-4191-aa2e-0c5f24668c72" providerId="ADAL" clId="{F2B84187-37ED-4459-971D-E4FC052BE502}" dt="2021-03-29T03:13:18.787" v="4926" actId="20577"/>
+          <ac:spMkLst>
+            <pc:docMk/>
+            <pc:sldMk cId="1440112597" sldId="270"/>
+            <ac:spMk id="3" creationId="{31D83BD4-F86A-4D77-A86B-192D5CB40359}"/>
+          </ac:spMkLst>
+        </pc:spChg>
+      </pc:sldChg>
+      <pc:sldChg chg="addSp delSp modSp new mod">
+        <pc:chgData name="Malcolm Hayward" userId="fd045f5c-b77a-4191-aa2e-0c5f24668c72" providerId="ADAL" clId="{F2B84187-37ED-4459-971D-E4FC052BE502}" dt="2021-04-16T04:55:25.721" v="9217" actId="1076"/>
+        <pc:sldMkLst>
+          <pc:docMk/>
+          <pc:sldMk cId="2919125898" sldId="271"/>
+        </pc:sldMkLst>
+        <pc:spChg chg="mod">
+          <ac:chgData name="Malcolm Hayward" userId="fd045f5c-b77a-4191-aa2e-0c5f24668c72" providerId="ADAL" clId="{F2B84187-37ED-4459-971D-E4FC052BE502}" dt="2021-03-28T22:07:43.450" v="4129" actId="20577"/>
+          <ac:spMkLst>
+            <pc:docMk/>
+            <pc:sldMk cId="2919125898" sldId="271"/>
+            <ac:spMk id="2" creationId="{08DCC45B-0180-4C71-A85C-BBEBDDA332A5}"/>
+          </ac:spMkLst>
+        </pc:spChg>
+        <pc:spChg chg="del">
+          <ac:chgData name="Malcolm Hayward" userId="fd045f5c-b77a-4191-aa2e-0c5f24668c72" providerId="ADAL" clId="{F2B84187-37ED-4459-971D-E4FC052BE502}" dt="2021-03-28T22:11:13.329" v="4130" actId="22"/>
+          <ac:spMkLst>
+            <pc:docMk/>
+            <pc:sldMk cId="2919125898" sldId="271"/>
+            <ac:spMk id="3" creationId="{5DE5C55E-CA41-486A-985D-6369BA0836EA}"/>
+          </ac:spMkLst>
+        </pc:spChg>
+        <pc:spChg chg="add del mod">
+          <ac:chgData name="Malcolm Hayward" userId="fd045f5c-b77a-4191-aa2e-0c5f24668c72" providerId="ADAL" clId="{F2B84187-37ED-4459-971D-E4FC052BE502}" dt="2021-04-16T04:41:16.692" v="8599" actId="22"/>
+          <ac:spMkLst>
+            <pc:docMk/>
+            <pc:sldMk cId="2919125898" sldId="271"/>
+            <ac:spMk id="4" creationId="{FC87D331-930C-472D-97C1-691FDC2CB4F1}"/>
+          </ac:spMkLst>
+        </pc:spChg>
+        <pc:spChg chg="add mod">
+          <ac:chgData name="Malcolm Hayward" userId="fd045f5c-b77a-4191-aa2e-0c5f24668c72" providerId="ADAL" clId="{F2B84187-37ED-4459-971D-E4FC052BE502}" dt="2021-04-16T04:55:25.721" v="9217" actId="1076"/>
+          <ac:spMkLst>
+            <pc:docMk/>
+            <pc:sldMk cId="2919125898" sldId="271"/>
+            <ac:spMk id="6" creationId="{B32C25EB-E174-4D23-9C68-4840FBD695AF}"/>
+          </ac:spMkLst>
+        </pc:spChg>
+        <pc:spChg chg="add del mod">
+          <ac:chgData name="Malcolm Hayward" userId="fd045f5c-b77a-4191-aa2e-0c5f24668c72" providerId="ADAL" clId="{F2B84187-37ED-4459-971D-E4FC052BE502}" dt="2021-04-16T04:33:14.942" v="8589" actId="478"/>
+          <ac:spMkLst>
+            <pc:docMk/>
+            <pc:sldMk cId="2919125898" sldId="271"/>
+            <ac:spMk id="7" creationId="{DBC54483-FE25-464B-A0F2-C4492E3B921D}"/>
+          </ac:spMkLst>
+        </pc:spChg>
+        <pc:picChg chg="add del mod ord">
+          <ac:chgData name="Malcolm Hayward" userId="fd045f5c-b77a-4191-aa2e-0c5f24668c72" providerId="ADAL" clId="{F2B84187-37ED-4459-971D-E4FC052BE502}" dt="2021-04-16T04:41:15.014" v="8598" actId="478"/>
+          <ac:picMkLst>
+            <pc:docMk/>
+            <pc:sldMk cId="2919125898" sldId="271"/>
+            <ac:picMk id="5" creationId="{C4F459E6-900B-435B-8DC0-F86AF747F5DA}"/>
+          </ac:picMkLst>
+        </pc:picChg>
+        <pc:picChg chg="add mod ord">
+          <ac:chgData name="Malcolm Hayward" userId="fd045f5c-b77a-4191-aa2e-0c5f24668c72" providerId="ADAL" clId="{F2B84187-37ED-4459-971D-E4FC052BE502}" dt="2021-04-16T04:55:23.040" v="9216" actId="14100"/>
+          <ac:picMkLst>
+            <pc:docMk/>
+            <pc:sldMk cId="2919125898" sldId="271"/>
+            <ac:picMk id="9" creationId="{7F3ACCC9-4B2D-4A35-86B2-E98C79A2A47C}"/>
+          </ac:picMkLst>
+        </pc:picChg>
+      </pc:sldChg>
+      <pc:sldChg chg="addSp delSp modSp new mod addCm delCm modCm">
+        <pc:chgData name="Malcolm Hayward" userId="fd045f5c-b77a-4191-aa2e-0c5f24668c72" providerId="ADAL" clId="{F2B84187-37ED-4459-971D-E4FC052BE502}" dt="2021-04-16T05:09:44.123" v="9833" actId="14100"/>
+        <pc:sldMkLst>
+          <pc:docMk/>
+          <pc:sldMk cId="3261498543" sldId="272"/>
+        </pc:sldMkLst>
+        <pc:spChg chg="mod">
+          <ac:chgData name="Malcolm Hayward" userId="fd045f5c-b77a-4191-aa2e-0c5f24668c72" providerId="ADAL" clId="{F2B84187-37ED-4459-971D-E4FC052BE502}" dt="2021-03-28T22:12:36.959" v="4208" actId="20577"/>
+          <ac:spMkLst>
+            <pc:docMk/>
+            <pc:sldMk cId="3261498543" sldId="272"/>
+            <ac:spMk id="2" creationId="{6902F2C7-7857-4CD1-9975-8E613578E07C}"/>
+          </ac:spMkLst>
+        </pc:spChg>
+        <pc:spChg chg="del">
+          <ac:chgData name="Malcolm Hayward" userId="fd045f5c-b77a-4191-aa2e-0c5f24668c72" providerId="ADAL" clId="{F2B84187-37ED-4459-971D-E4FC052BE502}" dt="2021-03-28T22:13:38.475" v="4209" actId="22"/>
+          <ac:spMkLst>
+            <pc:docMk/>
+            <pc:sldMk cId="3261498543" sldId="272"/>
+            <ac:spMk id="3" creationId="{565C1A6F-00DB-45B9-B686-F7FBC581C8C2}"/>
+          </ac:spMkLst>
+        </pc:spChg>
+        <pc:spChg chg="add del mod">
+          <ac:chgData name="Malcolm Hayward" userId="fd045f5c-b77a-4191-aa2e-0c5f24668c72" providerId="ADAL" clId="{F2B84187-37ED-4459-971D-E4FC052BE502}" dt="2021-03-29T02:54:36.281" v="4475" actId="22"/>
+          <ac:spMkLst>
+            <pc:docMk/>
+            <pc:sldMk cId="3261498543" sldId="272"/>
+            <ac:spMk id="9" creationId="{7477F9DA-6D54-4E30-87B0-CB63FD74291A}"/>
+          </ac:spMkLst>
+        </pc:spChg>
+        <pc:spChg chg="add mod">
+          <ac:chgData name="Malcolm Hayward" userId="fd045f5c-b77a-4191-aa2e-0c5f24668c72" providerId="ADAL" clId="{F2B84187-37ED-4459-971D-E4FC052BE502}" dt="2021-04-16T04:59:11.855" v="9775" actId="1076"/>
+          <ac:spMkLst>
+            <pc:docMk/>
+            <pc:sldMk cId="3261498543" sldId="272"/>
+            <ac:spMk id="14" creationId="{0A85B0EB-8A7D-4D0A-A03D-7CD06F72E85E}"/>
+          </ac:spMkLst>
+        </pc:spChg>
+        <pc:spChg chg="add mod">
+          <ac:chgData name="Malcolm Hayward" userId="fd045f5c-b77a-4191-aa2e-0c5f24668c72" providerId="ADAL" clId="{F2B84187-37ED-4459-971D-E4FC052BE502}" dt="2021-04-16T04:28:32.389" v="8236" actId="1076"/>
+          <ac:spMkLst>
+            <pc:docMk/>
+            <pc:sldMk cId="3261498543" sldId="272"/>
+            <ac:spMk id="15" creationId="{D7F63F0C-05C3-41CC-A2E5-6AC36E2C5D1C}"/>
+          </ac:spMkLst>
+        </pc:spChg>
+        <pc:spChg chg="add del mod">
+          <ac:chgData name="Malcolm Hayward" userId="fd045f5c-b77a-4191-aa2e-0c5f24668c72" providerId="ADAL" clId="{F2B84187-37ED-4459-971D-E4FC052BE502}" dt="2021-03-29T04:22:13.788" v="6234" actId="478"/>
+          <ac:spMkLst>
+            <pc:docMk/>
+            <pc:sldMk cId="3261498543" sldId="272"/>
+            <ac:spMk id="16" creationId="{F2D91ED8-11F4-4C27-87F6-3D71DAEC605A}"/>
+          </ac:spMkLst>
+        </pc:spChg>
+        <pc:picChg chg="add del mod ord">
+          <ac:chgData name="Malcolm Hayward" userId="fd045f5c-b77a-4191-aa2e-0c5f24668c72" providerId="ADAL" clId="{F2B84187-37ED-4459-971D-E4FC052BE502}" dt="2021-03-29T02:53:42.254" v="4474" actId="478"/>
+          <ac:picMkLst>
+            <pc:docMk/>
+            <pc:sldMk cId="3261498543" sldId="272"/>
+            <ac:picMk id="5" creationId="{1A8A7395-FAEF-49C2-A1CA-5D684700FD64}"/>
+          </ac:picMkLst>
+        </pc:picChg>
+        <pc:picChg chg="add del mod">
+          <ac:chgData name="Malcolm Hayward" userId="fd045f5c-b77a-4191-aa2e-0c5f24668c72" providerId="ADAL" clId="{F2B84187-37ED-4459-971D-E4FC052BE502}" dt="2021-03-28T22:16:04.844" v="4222" actId="478"/>
+          <ac:picMkLst>
+            <pc:docMk/>
+            <pc:sldMk cId="3261498543" sldId="272"/>
+            <ac:picMk id="7" creationId="{C0534F56-0D7A-4487-9581-9E6DCDC0E9E9}"/>
+          </ac:picMkLst>
+        </pc:picChg>
+        <pc:picChg chg="add mod ord">
+          <ac:chgData name="Malcolm Hayward" userId="fd045f5c-b77a-4191-aa2e-0c5f24668c72" providerId="ADAL" clId="{F2B84187-37ED-4459-971D-E4FC052BE502}" dt="2021-04-16T04:28:28.172" v="8235" actId="14100"/>
+          <ac:picMkLst>
+            <pc:docMk/>
+            <pc:sldMk cId="3261498543" sldId="272"/>
+            <ac:picMk id="11" creationId="{41C197CB-5F4C-4FC9-B86C-FAC24A718E36}"/>
+          </ac:picMkLst>
+        </pc:picChg>
+        <pc:picChg chg="add mod">
+          <ac:chgData name="Malcolm Hayward" userId="fd045f5c-b77a-4191-aa2e-0c5f24668c72" providerId="ADAL" clId="{F2B84187-37ED-4459-971D-E4FC052BE502}" dt="2021-04-16T05:09:44.123" v="9833" actId="14100"/>
+          <ac:picMkLst>
+            <pc:docMk/>
+            <pc:sldMk cId="3261498543" sldId="272"/>
+            <ac:picMk id="13" creationId="{100CC03C-7E3B-4A57-B7A4-FB942E14778A}"/>
+          </ac:picMkLst>
+        </pc:picChg>
+      </pc:sldChg>
+      <pc:sldChg chg="addSp delSp modSp new mod">
+        <pc:chgData name="Malcolm Hayward" userId="fd045f5c-b77a-4191-aa2e-0c5f24668c72" providerId="ADAL" clId="{F2B84187-37ED-4459-971D-E4FC052BE502}" dt="2021-04-17T08:31:25.519" v="11783" actId="20577"/>
+        <pc:sldMkLst>
+          <pc:docMk/>
+          <pc:sldMk cId="3257189420" sldId="273"/>
+        </pc:sldMkLst>
+        <pc:spChg chg="mod">
+          <ac:chgData name="Malcolm Hayward" userId="fd045f5c-b77a-4191-aa2e-0c5f24668c72" providerId="ADAL" clId="{F2B84187-37ED-4459-971D-E4FC052BE502}" dt="2021-03-28T22:17:10.302" v="4265" actId="313"/>
+          <ac:spMkLst>
+            <pc:docMk/>
+            <pc:sldMk cId="3257189420" sldId="273"/>
+            <ac:spMk id="2" creationId="{2FB4D46D-2B22-4B4D-804B-E8F7854B2E48}"/>
+          </ac:spMkLst>
+        </pc:spChg>
+        <pc:spChg chg="mod">
+          <ac:chgData name="Malcolm Hayward" userId="fd045f5c-b77a-4191-aa2e-0c5f24668c72" providerId="ADAL" clId="{F2B84187-37ED-4459-971D-E4FC052BE502}" dt="2021-04-17T08:31:25.519" v="11783" actId="20577"/>
+          <ac:spMkLst>
+            <pc:docMk/>
+            <pc:sldMk cId="3257189420" sldId="273"/>
+            <ac:spMk id="3" creationId="{7BBDBB4A-588A-4008-B72F-87A2EC36E6FA}"/>
+          </ac:spMkLst>
+        </pc:spChg>
+        <pc:picChg chg="add del">
+          <ac:chgData name="Malcolm Hayward" userId="fd045f5c-b77a-4191-aa2e-0c5f24668c72" providerId="ADAL" clId="{F2B84187-37ED-4459-971D-E4FC052BE502}" dt="2021-03-29T03:35:08.554" v="5396" actId="22"/>
+          <ac:picMkLst>
+            <pc:docMk/>
+            <pc:sldMk cId="3257189420" sldId="273"/>
+            <ac:picMk id="5" creationId="{E429B8E0-F289-4D79-8972-C8FE3F891941}"/>
+          </ac:picMkLst>
+        </pc:picChg>
+        <pc:picChg chg="add del mod">
+          <ac:chgData name="Malcolm Hayward" userId="fd045f5c-b77a-4191-aa2e-0c5f24668c72" providerId="ADAL" clId="{F2B84187-37ED-4459-971D-E4FC052BE502}" dt="2021-03-29T03:36:32.358" v="5445" actId="478"/>
+          <ac:picMkLst>
+            <pc:docMk/>
+            <pc:sldMk cId="3257189420" sldId="273"/>
+            <ac:picMk id="7" creationId="{00108ADF-952C-4F97-97C2-27A6E82C0B04}"/>
+          </ac:picMkLst>
+        </pc:picChg>
+      </pc:sldChg>
+      <pc:sldChg chg="addSp delSp modSp new mod">
+        <pc:chgData name="Malcolm Hayward" userId="fd045f5c-b77a-4191-aa2e-0c5f24668c72" providerId="ADAL" clId="{F2B84187-37ED-4459-971D-E4FC052BE502}" dt="2021-04-16T04:29:47.210" v="8292" actId="1076"/>
+        <pc:sldMkLst>
+          <pc:docMk/>
+          <pc:sldMk cId="2714755137" sldId="274"/>
+        </pc:sldMkLst>
+        <pc:spChg chg="mod">
+          <ac:chgData name="Malcolm Hayward" userId="fd045f5c-b77a-4191-aa2e-0c5f24668c72" providerId="ADAL" clId="{F2B84187-37ED-4459-971D-E4FC052BE502}" dt="2021-03-29T03:00:58.238" v="4512" actId="20577"/>
+          <ac:spMkLst>
+            <pc:docMk/>
+            <pc:sldMk cId="2714755137" sldId="274"/>
+            <ac:spMk id="2" creationId="{9EC0D9D7-89AE-45BB-9BAA-4E021141D7F8}"/>
+          </ac:spMkLst>
+        </pc:spChg>
+        <pc:spChg chg="del">
+          <ac:chgData name="Malcolm Hayward" userId="fd045f5c-b77a-4191-aa2e-0c5f24668c72" providerId="ADAL" clId="{F2B84187-37ED-4459-971D-E4FC052BE502}" dt="2021-03-29T03:00:50.607" v="4492" actId="22"/>
+          <ac:spMkLst>
+            <pc:docMk/>
+            <pc:sldMk cId="2714755137" sldId="274"/>
+            <ac:spMk id="3" creationId="{4E3B6F29-D82C-472F-99AC-DB5F1A648988}"/>
+          </ac:spMkLst>
+        </pc:spChg>
+        <pc:spChg chg="add mod">
+          <ac:chgData name="Malcolm Hayward" userId="fd045f5c-b77a-4191-aa2e-0c5f24668c72" providerId="ADAL" clId="{F2B84187-37ED-4459-971D-E4FC052BE502}" dt="2021-04-16T04:26:35.056" v="8202" actId="1076"/>
+          <ac:spMkLst>
+            <pc:docMk/>
+            <pc:sldMk cId="2714755137" sldId="274"/>
+            <ac:spMk id="8" creationId="{504FEAC0-5C5A-4996-AC9E-813751E42B47}"/>
+          </ac:spMkLst>
+        </pc:spChg>
+        <pc:spChg chg="add mod">
+          <ac:chgData name="Malcolm Hayward" userId="fd045f5c-b77a-4191-aa2e-0c5f24668c72" providerId="ADAL" clId="{F2B84187-37ED-4459-971D-E4FC052BE502}" dt="2021-04-16T04:29:38.094" v="8289" actId="1076"/>
+          <ac:spMkLst>
+            <pc:docMk/>
+            <pc:sldMk cId="2714755137" sldId="274"/>
+            <ac:spMk id="9" creationId="{0559EAF7-81F9-4EDC-A316-55907166BE04}"/>
+          </ac:spMkLst>
+        </pc:spChg>
+        <pc:picChg chg="add mod ord">
+          <ac:chgData name="Malcolm Hayward" userId="fd045f5c-b77a-4191-aa2e-0c5f24668c72" providerId="ADAL" clId="{F2B84187-37ED-4459-971D-E4FC052BE502}" dt="2021-04-16T04:26:17.111" v="8195" actId="14100"/>
+          <ac:picMkLst>
+            <pc:docMk/>
+            <pc:sldMk cId="2714755137" sldId="274"/>
+            <ac:picMk id="5" creationId="{A8B1809E-2D5A-48C4-BF07-BDF0FE73063C}"/>
+          </ac:picMkLst>
+        </pc:picChg>
+        <pc:picChg chg="add mod">
+          <ac:chgData name="Malcolm Hayward" userId="fd045f5c-b77a-4191-aa2e-0c5f24668c72" providerId="ADAL" clId="{F2B84187-37ED-4459-971D-E4FC052BE502}" dt="2021-04-16T04:29:47.210" v="8292" actId="1076"/>
+          <ac:picMkLst>
+            <pc:docMk/>
+            <pc:sldMk cId="2714755137" sldId="274"/>
+            <ac:picMk id="7" creationId="{9062CDAA-EF01-491A-9398-6FE6F987AD47}"/>
+          </ac:picMkLst>
+        </pc:picChg>
+      </pc:sldChg>
+      <pc:sldChg chg="modSp new del mod">
+        <pc:chgData name="Malcolm Hayward" userId="fd045f5c-b77a-4191-aa2e-0c5f24668c72" providerId="ADAL" clId="{F2B84187-37ED-4459-971D-E4FC052BE502}" dt="2021-03-29T04:00:57.769" v="5861" actId="2696"/>
+        <pc:sldMkLst>
+          <pc:docMk/>
+          <pc:sldMk cId="1135381488" sldId="275"/>
+        </pc:sldMkLst>
+        <pc:spChg chg="mod">
+          <ac:chgData name="Malcolm Hayward" userId="fd045f5c-b77a-4191-aa2e-0c5f24668c72" providerId="ADAL" clId="{F2B84187-37ED-4459-971D-E4FC052BE502}" dt="2021-03-28T22:18:15.173" v="4284" actId="20577"/>
+          <ac:spMkLst>
+            <pc:docMk/>
+            <pc:sldMk cId="1135381488" sldId="275"/>
+            <ac:spMk id="2" creationId="{B49094E7-7FB7-4576-BA2E-15EF03DA678B}"/>
+          </ac:spMkLst>
+        </pc:spChg>
+      </pc:sldChg>
+      <pc:sldChg chg="addSp delSp modSp new mod">
+        <pc:chgData name="Malcolm Hayward" userId="fd045f5c-b77a-4191-aa2e-0c5f24668c72" providerId="ADAL" clId="{F2B84187-37ED-4459-971D-E4FC052BE502}" dt="2021-04-16T04:39:01.494" v="8593" actId="14100"/>
+        <pc:sldMkLst>
+          <pc:docMk/>
+          <pc:sldMk cId="3191261408" sldId="276"/>
+        </pc:sldMkLst>
+        <pc:spChg chg="mod">
+          <ac:chgData name="Malcolm Hayward" userId="fd045f5c-b77a-4191-aa2e-0c5f24668c72" providerId="ADAL" clId="{F2B84187-37ED-4459-971D-E4FC052BE502}" dt="2021-03-29T02:33:57.802" v="4369" actId="20577"/>
+          <ac:spMkLst>
+            <pc:docMk/>
+            <pc:sldMk cId="3191261408" sldId="276"/>
+            <ac:spMk id="2" creationId="{3DE1CE75-6A4A-411A-9383-EA5DB3198624}"/>
+          </ac:spMkLst>
+        </pc:spChg>
+        <pc:spChg chg="del">
+          <ac:chgData name="Malcolm Hayward" userId="fd045f5c-b77a-4191-aa2e-0c5f24668c72" providerId="ADAL" clId="{F2B84187-37ED-4459-971D-E4FC052BE502}" dt="2021-03-29T02:33:52.884" v="4350" actId="22"/>
+          <ac:spMkLst>
+            <pc:docMk/>
+            <pc:sldMk cId="3191261408" sldId="276"/>
+            <ac:spMk id="3" creationId="{8F4F35B6-D914-462D-9436-B46ADB871642}"/>
+          </ac:spMkLst>
+        </pc:spChg>
+        <pc:picChg chg="add mod ord">
+          <ac:chgData name="Malcolm Hayward" userId="fd045f5c-b77a-4191-aa2e-0c5f24668c72" providerId="ADAL" clId="{F2B84187-37ED-4459-971D-E4FC052BE502}" dt="2021-03-29T02:46:15.105" v="4393" actId="14100"/>
+          <ac:picMkLst>
+            <pc:docMk/>
+            <pc:sldMk cId="3191261408" sldId="276"/>
+            <ac:picMk id="5" creationId="{25F4D553-6B98-444A-906C-0CAAAE5C7DBF}"/>
+          </ac:picMkLst>
+        </pc:picChg>
+        <pc:picChg chg="mod">
+          <ac:chgData name="Malcolm Hayward" userId="fd045f5c-b77a-4191-aa2e-0c5f24668c72" providerId="ADAL" clId="{F2B84187-37ED-4459-971D-E4FC052BE502}" dt="2021-04-16T04:39:01.494" v="8593" actId="14100"/>
+          <ac:picMkLst>
+            <pc:docMk/>
+            <pc:sldMk cId="3191261408" sldId="276"/>
+            <ac:picMk id="7" creationId="{E020F471-E56A-4C0E-B974-C2C8C4A836DC}"/>
+          </ac:picMkLst>
+        </pc:picChg>
+      </pc:sldChg>
+      <pc:sldChg chg="addSp modSp new mod">
+        <pc:chgData name="Malcolm Hayward" userId="fd045f5c-b77a-4191-aa2e-0c5f24668c72" providerId="ADAL" clId="{F2B84187-37ED-4459-971D-E4FC052BE502}" dt="2021-04-18T09:15:06.233" v="12192" actId="14100"/>
+        <pc:sldMkLst>
+          <pc:docMk/>
+          <pc:sldMk cId="1140682228" sldId="277"/>
+        </pc:sldMkLst>
+        <pc:spChg chg="mod">
+          <ac:chgData name="Malcolm Hayward" userId="fd045f5c-b77a-4191-aa2e-0c5f24668c72" providerId="ADAL" clId="{F2B84187-37ED-4459-971D-E4FC052BE502}" dt="2021-04-16T04:29:08.883" v="8286" actId="20577"/>
+          <ac:spMkLst>
+            <pc:docMk/>
+            <pc:sldMk cId="1140682228" sldId="277"/>
+            <ac:spMk id="2" creationId="{03E37E4E-87BE-4A78-B4CF-4917FBBF32A2}"/>
+          </ac:spMkLst>
+        </pc:spChg>
+        <pc:spChg chg="add mod">
+          <ac:chgData name="Malcolm Hayward" userId="fd045f5c-b77a-4191-aa2e-0c5f24668c72" providerId="ADAL" clId="{F2B84187-37ED-4459-971D-E4FC052BE502}" dt="2021-04-16T04:29:30.268" v="8288" actId="14100"/>
+          <ac:spMkLst>
+            <pc:docMk/>
+            <pc:sldMk cId="1140682228" sldId="277"/>
+            <ac:spMk id="3" creationId="{55D4CD6F-1ED4-47D5-9A83-06C197CD3E94}"/>
+          </ac:spMkLst>
+        </pc:spChg>
+        <pc:spChg chg="mod">
+          <ac:chgData name="Malcolm Hayward" userId="fd045f5c-b77a-4191-aa2e-0c5f24668c72" providerId="ADAL" clId="{F2B84187-37ED-4459-971D-E4FC052BE502}" dt="2021-03-29T03:06:45.629" v="4727" actId="20577"/>
+          <ac:spMkLst>
+            <pc:docMk/>
+            <pc:sldMk cId="1140682228" sldId="277"/>
+            <ac:spMk id="3" creationId="{ADD91F6A-CC28-440A-B5E8-DC933AEB421D}"/>
+          </ac:spMkLst>
+        </pc:spChg>
+        <pc:picChg chg="mod">
+          <ac:chgData name="Malcolm Hayward" userId="fd045f5c-b77a-4191-aa2e-0c5f24668c72" providerId="ADAL" clId="{F2B84187-37ED-4459-971D-E4FC052BE502}" dt="2021-04-18T09:15:06.233" v="12192" actId="14100"/>
+          <ac:picMkLst>
+            <pc:docMk/>
+            <pc:sldMk cId="1140682228" sldId="277"/>
+            <ac:picMk id="9" creationId="{4B3FEE71-0619-4549-8813-4DE2B8B9DFBE}"/>
+          </ac:picMkLst>
+        </pc:picChg>
+      </pc:sldChg>
+      <pc:sldChg chg="new del">
+        <pc:chgData name="Malcolm Hayward" userId="fd045f5c-b77a-4191-aa2e-0c5f24668c72" providerId="ADAL" clId="{F2B84187-37ED-4459-971D-E4FC052BE502}" dt="2021-03-29T03:28:29.868" v="5083" actId="680"/>
+        <pc:sldMkLst>
+          <pc:docMk/>
+          <pc:sldMk cId="2034423005" sldId="278"/>
+        </pc:sldMkLst>
+      </pc:sldChg>
+      <pc:sldChg chg="addSp delSp modSp new mod">
+        <pc:chgData name="Malcolm Hayward" userId="fd045f5c-b77a-4191-aa2e-0c5f24668c72" providerId="ADAL" clId="{F2B84187-37ED-4459-971D-E4FC052BE502}" dt="2021-04-17T08:32:03.182" v="11843" actId="1076"/>
+        <pc:sldMkLst>
+          <pc:docMk/>
+          <pc:sldMk cId="2238744396" sldId="278"/>
+        </pc:sldMkLst>
+        <pc:spChg chg="mod">
+          <ac:chgData name="Malcolm Hayward" userId="fd045f5c-b77a-4191-aa2e-0c5f24668c72" providerId="ADAL" clId="{F2B84187-37ED-4459-971D-E4FC052BE502}" dt="2021-04-17T08:31:44.321" v="11842" actId="20577"/>
+          <ac:spMkLst>
+            <pc:docMk/>
+            <pc:sldMk cId="2238744396" sldId="278"/>
+            <ac:spMk id="2" creationId="{A27652C0-7A7F-4776-B286-472A3C2F0871}"/>
+          </ac:spMkLst>
+        </pc:spChg>
+        <pc:spChg chg="del">
+          <ac:chgData name="Malcolm Hayward" userId="fd045f5c-b77a-4191-aa2e-0c5f24668c72" providerId="ADAL" clId="{F2B84187-37ED-4459-971D-E4FC052BE502}" dt="2021-03-29T03:36:35.585" v="5447" actId="22"/>
+          <ac:spMkLst>
+            <pc:docMk/>
+            <pc:sldMk cId="2238744396" sldId="278"/>
+            <ac:spMk id="3" creationId="{88BE9213-4BAA-4288-90BE-88718F69DC09}"/>
+          </ac:spMkLst>
+        </pc:spChg>
+        <pc:spChg chg="add del mod">
+          <ac:chgData name="Malcolm Hayward" userId="fd045f5c-b77a-4191-aa2e-0c5f24668c72" providerId="ADAL" clId="{F2B84187-37ED-4459-971D-E4FC052BE502}" dt="2021-03-29T03:39:59.698" v="5500" actId="22"/>
+          <ac:spMkLst>
+            <pc:docMk/>
+            <pc:sldMk cId="2238744396" sldId="278"/>
+            <ac:spMk id="7" creationId="{520402CA-7584-461B-A7E6-1AFF82BE8B56}"/>
+          </ac:spMkLst>
+        </pc:spChg>
+        <pc:picChg chg="add del mod ord">
+          <ac:chgData name="Malcolm Hayward" userId="fd045f5c-b77a-4191-aa2e-0c5f24668c72" providerId="ADAL" clId="{F2B84187-37ED-4459-971D-E4FC052BE502}" dt="2021-03-29T03:39:57.853" v="5499" actId="478"/>
+          <ac:picMkLst>
+            <pc:docMk/>
+            <pc:sldMk cId="2238744396" sldId="278"/>
+            <ac:picMk id="5" creationId="{0133DEE5-60BC-4BDD-8434-E4C559BEF7FF}"/>
+          </ac:picMkLst>
+        </pc:picChg>
+        <pc:picChg chg="add mod ord">
+          <ac:chgData name="Malcolm Hayward" userId="fd045f5c-b77a-4191-aa2e-0c5f24668c72" providerId="ADAL" clId="{F2B84187-37ED-4459-971D-E4FC052BE502}" dt="2021-04-17T08:32:03.182" v="11843" actId="1076"/>
+          <ac:picMkLst>
+            <pc:docMk/>
+            <pc:sldMk cId="2238744396" sldId="278"/>
+            <ac:picMk id="9" creationId="{20FB56B1-400F-4945-9985-FD934DD65ED1}"/>
+          </ac:picMkLst>
+        </pc:picChg>
+      </pc:sldChg>
+      <pc:sldChg chg="addSp delSp modSp new mod">
+        <pc:chgData name="Malcolm Hayward" userId="fd045f5c-b77a-4191-aa2e-0c5f24668c72" providerId="ADAL" clId="{F2B84187-37ED-4459-971D-E4FC052BE502}" dt="2021-04-17T08:32:25.222" v="11875" actId="1076"/>
+        <pc:sldMkLst>
+          <pc:docMk/>
+          <pc:sldMk cId="334425312" sldId="279"/>
+        </pc:sldMkLst>
+        <pc:spChg chg="mod">
+          <ac:chgData name="Malcolm Hayward" userId="fd045f5c-b77a-4191-aa2e-0c5f24668c72" providerId="ADAL" clId="{F2B84187-37ED-4459-971D-E4FC052BE502}" dt="2021-04-17T08:32:18.376" v="11874" actId="20577"/>
+          <ac:spMkLst>
+            <pc:docMk/>
+            <pc:sldMk cId="334425312" sldId="279"/>
+            <ac:spMk id="2" creationId="{B60B3F95-6244-43F7-B16C-198F20FD2102}"/>
+          </ac:spMkLst>
+        </pc:spChg>
+        <pc:spChg chg="del">
+          <ac:chgData name="Malcolm Hayward" userId="fd045f5c-b77a-4191-aa2e-0c5f24668c72" providerId="ADAL" clId="{F2B84187-37ED-4459-971D-E4FC052BE502}" dt="2021-03-29T03:42:56.077" v="5504" actId="22"/>
+          <ac:spMkLst>
+            <pc:docMk/>
+            <pc:sldMk cId="334425312" sldId="279"/>
+            <ac:spMk id="3" creationId="{189F6B65-E542-45FE-A205-3282FD9760ED}"/>
+          </ac:spMkLst>
+        </pc:spChg>
+        <pc:picChg chg="add mod ord">
+          <ac:chgData name="Malcolm Hayward" userId="fd045f5c-b77a-4191-aa2e-0c5f24668c72" providerId="ADAL" clId="{F2B84187-37ED-4459-971D-E4FC052BE502}" dt="2021-04-17T08:32:25.222" v="11875" actId="1076"/>
+          <ac:picMkLst>
+            <pc:docMk/>
+            <pc:sldMk cId="334425312" sldId="279"/>
+            <ac:picMk id="5" creationId="{C7D96507-FC5E-4741-ADD4-D447329D3933}"/>
+          </ac:picMkLst>
+        </pc:picChg>
+      </pc:sldChg>
+      <pc:sldChg chg="addSp delSp modSp new mod ord">
+        <pc:chgData name="Malcolm Hayward" userId="fd045f5c-b77a-4191-aa2e-0c5f24668c72" providerId="ADAL" clId="{F2B84187-37ED-4459-971D-E4FC052BE502}" dt="2021-04-17T08:27:54.261" v="11711" actId="1076"/>
+        <pc:sldMkLst>
+          <pc:docMk/>
+          <pc:sldMk cId="2855457371" sldId="280"/>
+        </pc:sldMkLst>
+        <pc:spChg chg="mod">
+          <ac:chgData name="Malcolm Hayward" userId="fd045f5c-b77a-4191-aa2e-0c5f24668c72" providerId="ADAL" clId="{F2B84187-37ED-4459-971D-E4FC052BE502}" dt="2021-03-29T03:45:55.335" v="5574" actId="20577"/>
+          <ac:spMkLst>
+            <pc:docMk/>
+            <pc:sldMk cId="2855457371" sldId="280"/>
+            <ac:spMk id="2" creationId="{29C07C8B-D26D-4536-9BBB-DE5DF8596AED}"/>
+          </ac:spMkLst>
+        </pc:spChg>
+        <pc:spChg chg="del">
+          <ac:chgData name="Malcolm Hayward" userId="fd045f5c-b77a-4191-aa2e-0c5f24668c72" providerId="ADAL" clId="{F2B84187-37ED-4459-971D-E4FC052BE502}" dt="2021-03-29T03:45:46.813" v="5539" actId="22"/>
+          <ac:spMkLst>
+            <pc:docMk/>
+            <pc:sldMk cId="2855457371" sldId="280"/>
+            <ac:spMk id="3" creationId="{7B38F789-044A-4187-B069-C4477766AF0B}"/>
+          </ac:spMkLst>
+        </pc:spChg>
+        <pc:spChg chg="add del mod">
+          <ac:chgData name="Malcolm Hayward" userId="fd045f5c-b77a-4191-aa2e-0c5f24668c72" providerId="ADAL" clId="{F2B84187-37ED-4459-971D-E4FC052BE502}" dt="2021-04-16T04:00:56.357" v="7925" actId="478"/>
+          <ac:spMkLst>
+            <pc:docMk/>
+            <pc:sldMk cId="2855457371" sldId="280"/>
+            <ac:spMk id="3" creationId="{E379FDDD-FF22-41CE-8D2E-0E96CC99FA43}"/>
+          </ac:spMkLst>
+        </pc:spChg>
+        <pc:spChg chg="add mod">
+          <ac:chgData name="Malcolm Hayward" userId="fd045f5c-b77a-4191-aa2e-0c5f24668c72" providerId="ADAL" clId="{F2B84187-37ED-4459-971D-E4FC052BE502}" dt="2021-04-17T08:27:54.261" v="11711" actId="1076"/>
+          <ac:spMkLst>
+            <pc:docMk/>
+            <pc:sldMk cId="2855457371" sldId="280"/>
+            <ac:spMk id="4" creationId="{242010A5-2A6D-4901-B056-3883936A3FD8}"/>
+          </ac:spMkLst>
+        </pc:spChg>
+        <pc:spChg chg="add del mod">
+          <ac:chgData name="Malcolm Hayward" userId="fd045f5c-b77a-4191-aa2e-0c5f24668c72" providerId="ADAL" clId="{F2B84187-37ED-4459-971D-E4FC052BE502}" dt="2021-04-16T04:01:19.203" v="7931" actId="478"/>
+          <ac:spMkLst>
+            <pc:docMk/>
+            <pc:sldMk cId="2855457371" sldId="280"/>
+            <ac:spMk id="6" creationId="{861B5EF8-E207-4B34-8B90-36E3E4780661}"/>
+          </ac:spMkLst>
+        </pc:spChg>
+        <pc:picChg chg="add mod ord">
+          <ac:chgData name="Malcolm Hayward" userId="fd045f5c-b77a-4191-aa2e-0c5f24668c72" providerId="ADAL" clId="{F2B84187-37ED-4459-971D-E4FC052BE502}" dt="2021-04-17T08:27:50.501" v="11710" actId="1076"/>
+          <ac:picMkLst>
+            <pc:docMk/>
+            <pc:sldMk cId="2855457371" sldId="280"/>
+            <ac:picMk id="5" creationId="{9B348F33-D554-47FF-BE6E-10FDB2B0E6E6}"/>
+          </ac:picMkLst>
+        </pc:picChg>
+      </pc:sldChg>
+      <pc:sldChg chg="addSp delSp modSp new mod">
+        <pc:chgData name="Malcolm Hayward" userId="fd045f5c-b77a-4191-aa2e-0c5f24668c72" providerId="ADAL" clId="{F2B84187-37ED-4459-971D-E4FC052BE502}" dt="2021-04-16T03:54:52.897" v="7679" actId="1076"/>
+        <pc:sldMkLst>
+          <pc:docMk/>
+          <pc:sldMk cId="312878233" sldId="281"/>
+        </pc:sldMkLst>
+        <pc:spChg chg="mod">
+          <ac:chgData name="Malcolm Hayward" userId="fd045f5c-b77a-4191-aa2e-0c5f24668c72" providerId="ADAL" clId="{F2B84187-37ED-4459-971D-E4FC052BE502}" dt="2021-03-29T04:27:53.084" v="6565" actId="120"/>
+          <ac:spMkLst>
+            <pc:docMk/>
+            <pc:sldMk cId="312878233" sldId="281"/>
+            <ac:spMk id="2" creationId="{936869A1-4263-48A9-8324-B372B976B56A}"/>
+          </ac:spMkLst>
+        </pc:spChg>
+        <pc:spChg chg="del">
+          <ac:chgData name="Malcolm Hayward" userId="fd045f5c-b77a-4191-aa2e-0c5f24668c72" providerId="ADAL" clId="{F2B84187-37ED-4459-971D-E4FC052BE502}" dt="2021-03-29T03:51:57.173" v="5593" actId="22"/>
+          <ac:spMkLst>
+            <pc:docMk/>
+            <pc:sldMk cId="312878233" sldId="281"/>
+            <ac:spMk id="3" creationId="{41CBB064-4BAC-42DE-932B-066491822591}"/>
+          </ac:spMkLst>
+        </pc:spChg>
+        <pc:spChg chg="add del mod">
+          <ac:chgData name="Malcolm Hayward" userId="fd045f5c-b77a-4191-aa2e-0c5f24668c72" providerId="ADAL" clId="{F2B84187-37ED-4459-971D-E4FC052BE502}" dt="2021-04-16T03:52:25.747" v="7642" actId="478"/>
+          <ac:spMkLst>
+            <pc:docMk/>
+            <pc:sldMk cId="312878233" sldId="281"/>
+            <ac:spMk id="4" creationId="{295DF3B3-240E-42E4-8E20-0648EB4C864C}"/>
+          </ac:spMkLst>
+        </pc:spChg>
+        <pc:spChg chg="add mod">
+          <ac:chgData name="Malcolm Hayward" userId="fd045f5c-b77a-4191-aa2e-0c5f24668c72" providerId="ADAL" clId="{F2B84187-37ED-4459-971D-E4FC052BE502}" dt="2021-04-16T03:54:51.745" v="7678" actId="1076"/>
+          <ac:spMkLst>
+            <pc:docMk/>
+            <pc:sldMk cId="312878233" sldId="281"/>
+            <ac:spMk id="8" creationId="{4A04850C-75F4-4C87-A217-AF238CFAC90B}"/>
+          </ac:spMkLst>
+        </pc:spChg>
+        <pc:spChg chg="add del mod">
+          <ac:chgData name="Malcolm Hayward" userId="fd045f5c-b77a-4191-aa2e-0c5f24668c72" providerId="ADAL" clId="{F2B84187-37ED-4459-971D-E4FC052BE502}" dt="2021-04-16T03:52:27.586" v="7643" actId="478"/>
+          <ac:spMkLst>
+            <pc:docMk/>
+            <pc:sldMk cId="312878233" sldId="281"/>
+            <ac:spMk id="9" creationId="{0BE7E352-EDFF-4BFE-B47D-8E6CD282B955}"/>
+          </ac:spMkLst>
+        </pc:spChg>
+        <pc:picChg chg="add del mod ord">
+          <ac:chgData name="Malcolm Hayward" userId="fd045f5c-b77a-4191-aa2e-0c5f24668c72" providerId="ADAL" clId="{F2B84187-37ED-4459-971D-E4FC052BE502}" dt="2021-04-16T03:52:21.091" v="7641" actId="478"/>
+          <ac:picMkLst>
+            <pc:docMk/>
+            <pc:sldMk cId="312878233" sldId="281"/>
+            <ac:picMk id="5" creationId="{4CD61613-8C65-473E-B257-2307673C3C60}"/>
+          </ac:picMkLst>
+        </pc:picChg>
+        <pc:picChg chg="add mod">
+          <ac:chgData name="Malcolm Hayward" userId="fd045f5c-b77a-4191-aa2e-0c5f24668c72" providerId="ADAL" clId="{F2B84187-37ED-4459-971D-E4FC052BE502}" dt="2021-04-16T03:54:52.897" v="7679" actId="1076"/>
+          <ac:picMkLst>
+            <pc:docMk/>
+            <pc:sldMk cId="312878233" sldId="281"/>
+            <ac:picMk id="7" creationId="{EEF6522E-BBC0-461E-BAF5-8B047F4F2184}"/>
+          </ac:picMkLst>
+        </pc:picChg>
+      </pc:sldChg>
+      <pc:sldChg chg="addSp delSp modSp new mod">
+        <pc:chgData name="Malcolm Hayward" userId="fd045f5c-b77a-4191-aa2e-0c5f24668c72" providerId="ADAL" clId="{F2B84187-37ED-4459-971D-E4FC052BE502}" dt="2021-04-17T08:35:14.028" v="12132" actId="14100"/>
+        <pc:sldMkLst>
+          <pc:docMk/>
+          <pc:sldMk cId="3626365319" sldId="282"/>
+        </pc:sldMkLst>
+        <pc:spChg chg="mod">
+          <ac:chgData name="Malcolm Hayward" userId="fd045f5c-b77a-4191-aa2e-0c5f24668c72" providerId="ADAL" clId="{F2B84187-37ED-4459-971D-E4FC052BE502}" dt="2021-03-29T03:53:40.183" v="5650" actId="20577"/>
+          <ac:spMkLst>
+            <pc:docMk/>
+            <pc:sldMk cId="3626365319" sldId="282"/>
+            <ac:spMk id="2" creationId="{74E2A155-C11A-41DB-B80D-5633F14051EC}"/>
+          </ac:spMkLst>
+        </pc:spChg>
+        <pc:spChg chg="del">
+          <ac:chgData name="Malcolm Hayward" userId="fd045f5c-b77a-4191-aa2e-0c5f24668c72" providerId="ADAL" clId="{F2B84187-37ED-4459-971D-E4FC052BE502}" dt="2021-03-29T03:54:34.404" v="5651" actId="22"/>
+          <ac:spMkLst>
+            <pc:docMk/>
+            <pc:sldMk cId="3626365319" sldId="282"/>
+            <ac:spMk id="3" creationId="{3FE4F222-E677-4A0D-8A1D-76A526E4380F}"/>
+          </ac:spMkLst>
+        </pc:spChg>
+        <pc:spChg chg="add mod">
+          <ac:chgData name="Malcolm Hayward" userId="fd045f5c-b77a-4191-aa2e-0c5f24668c72" providerId="ADAL" clId="{F2B84187-37ED-4459-971D-E4FC052BE502}" dt="2021-04-17T08:35:06.561" v="12130" actId="1076"/>
+          <ac:spMkLst>
+            <pc:docMk/>
+            <pc:sldMk cId="3626365319" sldId="282"/>
+            <ac:spMk id="3" creationId="{41DBD695-2A86-4ADF-A197-2BAD045E2782}"/>
+          </ac:spMkLst>
+        </pc:spChg>
+        <pc:picChg chg="add mod ord">
+          <ac:chgData name="Malcolm Hayward" userId="fd045f5c-b77a-4191-aa2e-0c5f24668c72" providerId="ADAL" clId="{F2B84187-37ED-4459-971D-E4FC052BE502}" dt="2021-04-17T08:35:14.028" v="12132" actId="14100"/>
+          <ac:picMkLst>
+            <pc:docMk/>
+            <pc:sldMk cId="3626365319" sldId="282"/>
+            <ac:picMk id="5" creationId="{33048E9C-E1E5-4400-939F-B1A3CD704484}"/>
+          </ac:picMkLst>
+        </pc:picChg>
+      </pc:sldChg>
+      <pc:sldChg chg="addSp delSp modSp new mod ord">
+        <pc:chgData name="Malcolm Hayward" userId="fd045f5c-b77a-4191-aa2e-0c5f24668c72" providerId="ADAL" clId="{F2B84187-37ED-4459-971D-E4FC052BE502}" dt="2021-04-17T08:18:05.620" v="11388" actId="14100"/>
+        <pc:sldMkLst>
+          <pc:docMk/>
+          <pc:sldMk cId="4007241215" sldId="283"/>
+        </pc:sldMkLst>
+        <pc:spChg chg="mod">
+          <ac:chgData name="Malcolm Hayward" userId="fd045f5c-b77a-4191-aa2e-0c5f24668c72" providerId="ADAL" clId="{F2B84187-37ED-4459-971D-E4FC052BE502}" dt="2021-03-29T03:57:36.478" v="5726" actId="20577"/>
+          <ac:spMkLst>
+            <pc:docMk/>
+            <pc:sldMk cId="4007241215" sldId="283"/>
+            <ac:spMk id="2" creationId="{02574D71-F0B2-4270-AA58-D42F39D7BC63}"/>
+          </ac:spMkLst>
+        </pc:spChg>
+        <pc:spChg chg="del mod">
+          <ac:chgData name="Malcolm Hayward" userId="fd045f5c-b77a-4191-aa2e-0c5f24668c72" providerId="ADAL" clId="{F2B84187-37ED-4459-971D-E4FC052BE502}" dt="2021-03-29T13:53:44.978" v="6988" actId="22"/>
+          <ac:spMkLst>
+            <pc:docMk/>
+            <pc:sldMk cId="4007241215" sldId="283"/>
+            <ac:spMk id="3" creationId="{9EF77FD0-93B8-4186-B68E-1F6310B3428C}"/>
+          </ac:spMkLst>
+        </pc:spChg>
+        <pc:picChg chg="add mod ord">
+          <ac:chgData name="Malcolm Hayward" userId="fd045f5c-b77a-4191-aa2e-0c5f24668c72" providerId="ADAL" clId="{F2B84187-37ED-4459-971D-E4FC052BE502}" dt="2021-04-17T08:18:05.620" v="11388" actId="14100"/>
+          <ac:picMkLst>
+            <pc:docMk/>
+            <pc:sldMk cId="4007241215" sldId="283"/>
+            <ac:picMk id="5" creationId="{642CC9D8-4285-4B46-9F62-EC6DBC4A32CF}"/>
+          </ac:picMkLst>
+        </pc:picChg>
+      </pc:sldChg>
+      <pc:sldChg chg="addSp delSp modSp new mod ord">
+        <pc:chgData name="Malcolm Hayward" userId="fd045f5c-b77a-4191-aa2e-0c5f24668c72" providerId="ADAL" clId="{F2B84187-37ED-4459-971D-E4FC052BE502}" dt="2021-04-17T08:24:30.341" v="11559" actId="1076"/>
+        <pc:sldMkLst>
+          <pc:docMk/>
+          <pc:sldMk cId="3159775641" sldId="284"/>
+        </pc:sldMkLst>
+        <pc:spChg chg="mod">
+          <ac:chgData name="Malcolm Hayward" userId="fd045f5c-b77a-4191-aa2e-0c5f24668c72" providerId="ADAL" clId="{F2B84187-37ED-4459-971D-E4FC052BE502}" dt="2021-03-29T04:30:28.560" v="6602" actId="20577"/>
+          <ac:spMkLst>
+            <pc:docMk/>
+            <pc:sldMk cId="3159775641" sldId="284"/>
+            <ac:spMk id="2" creationId="{1BD8FAD5-D659-4DF1-A682-29D8619E2BED}"/>
+          </ac:spMkLst>
+        </pc:spChg>
+        <pc:spChg chg="add mod">
+          <ac:chgData name="Malcolm Hayward" userId="fd045f5c-b77a-4191-aa2e-0c5f24668c72" providerId="ADAL" clId="{F2B84187-37ED-4459-971D-E4FC052BE502}" dt="2021-04-17T08:23:33.429" v="11457" actId="20577"/>
+          <ac:spMkLst>
+            <pc:docMk/>
+            <pc:sldMk cId="3159775641" sldId="284"/>
+            <ac:spMk id="3" creationId="{892BD556-80CC-45AA-AD59-41E155BB8CAB}"/>
+          </ac:spMkLst>
+        </pc:spChg>
+        <pc:spChg chg="del">
+          <ac:chgData name="Malcolm Hayward" userId="fd045f5c-b77a-4191-aa2e-0c5f24668c72" providerId="ADAL" clId="{F2B84187-37ED-4459-971D-E4FC052BE502}" dt="2021-03-30T20:18:47.944" v="7035" actId="22"/>
+          <ac:spMkLst>
+            <pc:docMk/>
+            <pc:sldMk cId="3159775641" sldId="284"/>
+            <ac:spMk id="3" creationId="{D43C9CC2-2FB9-4A6B-BF3C-FFD68358A30E}"/>
+          </ac:spMkLst>
+        </pc:spChg>
+        <pc:spChg chg="add mod">
+          <ac:chgData name="Malcolm Hayward" userId="fd045f5c-b77a-4191-aa2e-0c5f24668c72" providerId="ADAL" clId="{F2B84187-37ED-4459-971D-E4FC052BE502}" dt="2021-04-17T08:24:30.341" v="11559" actId="1076"/>
+          <ac:spMkLst>
+            <pc:docMk/>
+            <pc:sldMk cId="3159775641" sldId="284"/>
+            <ac:spMk id="4" creationId="{4A4BD6FE-0D87-41F1-823E-F8688BAFDEC5}"/>
+          </ac:spMkLst>
+        </pc:spChg>
+        <pc:spChg chg="add del mod">
+          <ac:chgData name="Malcolm Hayward" userId="fd045f5c-b77a-4191-aa2e-0c5f24668c72" providerId="ADAL" clId="{F2B84187-37ED-4459-971D-E4FC052BE502}" dt="2021-03-30T20:51:19.326" v="7286" actId="22"/>
+          <ac:spMkLst>
+            <pc:docMk/>
+            <pc:sldMk cId="3159775641" sldId="284"/>
+            <ac:spMk id="4" creationId="{AC43D15D-148B-4EE1-8958-9DA2CF3A928D}"/>
+          </ac:spMkLst>
+        </pc:spChg>
+        <pc:picChg chg="add del mod ord">
+          <ac:chgData name="Malcolm Hayward" userId="fd045f5c-b77a-4191-aa2e-0c5f24668c72" providerId="ADAL" clId="{F2B84187-37ED-4459-971D-E4FC052BE502}" dt="2021-03-30T20:50:41.760" v="7285" actId="478"/>
+          <ac:picMkLst>
+            <pc:docMk/>
+            <pc:sldMk cId="3159775641" sldId="284"/>
+            <ac:picMk id="5" creationId="{14E64031-7814-442F-A0AC-521B667BF4E8}"/>
+          </ac:picMkLst>
+        </pc:picChg>
+        <pc:picChg chg="add mod ord">
+          <ac:chgData name="Malcolm Hayward" userId="fd045f5c-b77a-4191-aa2e-0c5f24668c72" providerId="ADAL" clId="{F2B84187-37ED-4459-971D-E4FC052BE502}" dt="2021-04-17T08:24:27.520" v="11558" actId="1076"/>
+          <ac:picMkLst>
+            <pc:docMk/>
+            <pc:sldMk cId="3159775641" sldId="284"/>
+            <ac:picMk id="7" creationId="{7DB1626A-A340-48AD-B01A-F4165DC223FA}"/>
+          </ac:picMkLst>
+        </pc:picChg>
+      </pc:sldChg>
+      <pc:sldChg chg="del">
+        <pc:chgData name="Malcolm Hayward" userId="fd045f5c-b77a-4191-aa2e-0c5f24668c72" providerId="ADAL" clId="{F2B84187-37ED-4459-971D-E4FC052BE502}" dt="2021-03-30T20:42:49.483" v="7172" actId="2696"/>
+        <pc:sldMkLst>
+          <pc:docMk/>
+          <pc:sldMk cId="3033189543" sldId="285"/>
+        </pc:sldMkLst>
+      </pc:sldChg>
+      <pc:sldChg chg="modSp mod">
+        <pc:chgData name="Malcolm Hayward" userId="fd045f5c-b77a-4191-aa2e-0c5f24668c72" providerId="ADAL" clId="{F2B84187-37ED-4459-971D-E4FC052BE502}" dt="2021-04-17T08:18:27.636" v="11389" actId="14100"/>
+        <pc:sldMkLst>
+          <pc:docMk/>
+          <pc:sldMk cId="1300467158" sldId="286"/>
+        </pc:sldMkLst>
+        <pc:picChg chg="mod">
+          <ac:chgData name="Malcolm Hayward" userId="fd045f5c-b77a-4191-aa2e-0c5f24668c72" providerId="ADAL" clId="{F2B84187-37ED-4459-971D-E4FC052BE502}" dt="2021-04-17T08:18:27.636" v="11389" actId="14100"/>
+          <ac:picMkLst>
+            <pc:docMk/>
+            <pc:sldMk cId="1300467158" sldId="286"/>
+            <ac:picMk id="5" creationId="{4638485C-F2C5-4C31-A95B-28FBBDA2BD20}"/>
+          </ac:picMkLst>
+        </pc:picChg>
+      </pc:sldChg>
+      <pc:sldChg chg="modSp mod">
+        <pc:chgData name="Malcolm Hayward" userId="fd045f5c-b77a-4191-aa2e-0c5f24668c72" providerId="ADAL" clId="{F2B84187-37ED-4459-971D-E4FC052BE502}" dt="2021-04-16T06:11:53.691" v="9964" actId="14100"/>
+        <pc:sldMkLst>
+          <pc:docMk/>
+          <pc:sldMk cId="1827431044" sldId="287"/>
+        </pc:sldMkLst>
+        <pc:spChg chg="mod">
+          <ac:chgData name="Malcolm Hayward" userId="fd045f5c-b77a-4191-aa2e-0c5f24668c72" providerId="ADAL" clId="{F2B84187-37ED-4459-971D-E4FC052BE502}" dt="2021-04-12T14:52:36.435" v="7627" actId="20577"/>
+          <ac:spMkLst>
+            <pc:docMk/>
+            <pc:sldMk cId="1827431044" sldId="287"/>
+            <ac:spMk id="2" creationId="{03E818AA-76A1-4237-8749-6DAC56FD30E3}"/>
+          </ac:spMkLst>
+        </pc:spChg>
+        <pc:picChg chg="mod">
+          <ac:chgData name="Malcolm Hayward" userId="fd045f5c-b77a-4191-aa2e-0c5f24668c72" providerId="ADAL" clId="{F2B84187-37ED-4459-971D-E4FC052BE502}" dt="2021-04-16T06:11:53.691" v="9964" actId="14100"/>
+          <ac:picMkLst>
+            <pc:docMk/>
+            <pc:sldMk cId="1827431044" sldId="287"/>
+            <ac:picMk id="5" creationId="{A3FE2B94-FEFF-4641-ADC0-028062380727}"/>
+          </ac:picMkLst>
+        </pc:picChg>
+      </pc:sldChg>
+      <pc:sldChg chg="addSp delSp modSp new mod">
+        <pc:chgData name="Malcolm Hayward" userId="fd045f5c-b77a-4191-aa2e-0c5f24668c72" providerId="ADAL" clId="{F2B84187-37ED-4459-971D-E4FC052BE502}" dt="2021-04-17T08:24:56.478" v="11607" actId="1076"/>
+        <pc:sldMkLst>
+          <pc:docMk/>
+          <pc:sldMk cId="1943220090" sldId="288"/>
+        </pc:sldMkLst>
+        <pc:spChg chg="mod">
+          <ac:chgData name="Malcolm Hayward" userId="fd045f5c-b77a-4191-aa2e-0c5f24668c72" providerId="ADAL" clId="{F2B84187-37ED-4459-971D-E4FC052BE502}" dt="2021-04-17T08:24:49.920" v="11606" actId="20577"/>
+          <ac:spMkLst>
+            <pc:docMk/>
+            <pc:sldMk cId="1943220090" sldId="288"/>
+            <ac:spMk id="2" creationId="{2B32DB9A-A8F7-403D-AC75-3E7187DEF4C8}"/>
+          </ac:spMkLst>
+        </pc:spChg>
+        <pc:spChg chg="del">
+          <ac:chgData name="Malcolm Hayward" userId="fd045f5c-b77a-4191-aa2e-0c5f24668c72" providerId="ADAL" clId="{F2B84187-37ED-4459-971D-E4FC052BE502}" dt="2021-03-30T20:38:25.225" v="7075" actId="22"/>
+          <ac:spMkLst>
+            <pc:docMk/>
+            <pc:sldMk cId="1943220090" sldId="288"/>
+            <ac:spMk id="3" creationId="{F9EF2CFA-A0E7-4E0C-9132-104AA5CA798F}"/>
+          </ac:spMkLst>
+        </pc:spChg>
+        <pc:picChg chg="add mod ord">
+          <ac:chgData name="Malcolm Hayward" userId="fd045f5c-b77a-4191-aa2e-0c5f24668c72" providerId="ADAL" clId="{F2B84187-37ED-4459-971D-E4FC052BE502}" dt="2021-04-17T08:24:56.478" v="11607" actId="1076"/>
+          <ac:picMkLst>
+            <pc:docMk/>
+            <pc:sldMk cId="1943220090" sldId="288"/>
+            <ac:picMk id="5" creationId="{4B30F89A-9F93-43D6-B426-E7C95664376A}"/>
+          </ac:picMkLst>
+        </pc:picChg>
+      </pc:sldChg>
+      <pc:sldChg chg="modSp mod">
+        <pc:chgData name="Malcolm Hayward" userId="fd045f5c-b77a-4191-aa2e-0c5f24668c72" providerId="ADAL" clId="{F2B84187-37ED-4459-971D-E4FC052BE502}" dt="2021-04-17T07:36:06.144" v="11025" actId="20577"/>
+        <pc:sldMkLst>
+          <pc:docMk/>
+          <pc:sldMk cId="3329615997" sldId="289"/>
+        </pc:sldMkLst>
+        <pc:spChg chg="mod">
+          <ac:chgData name="Malcolm Hayward" userId="fd045f5c-b77a-4191-aa2e-0c5f24668c72" providerId="ADAL" clId="{F2B84187-37ED-4459-971D-E4FC052BE502}" dt="2021-04-17T07:36:06.144" v="11025" actId="20577"/>
+          <ac:spMkLst>
+            <pc:docMk/>
+            <pc:sldMk cId="3329615997" sldId="289"/>
+            <ac:spMk id="2" creationId="{C549C308-6FBC-42AB-ADEA-73F8A238A190}"/>
+          </ac:spMkLst>
+        </pc:spChg>
+        <pc:spChg chg="mod">
+          <ac:chgData name="Malcolm Hayward" userId="fd045f5c-b77a-4191-aa2e-0c5f24668c72" providerId="ADAL" clId="{F2B84187-37ED-4459-971D-E4FC052BE502}" dt="2021-04-17T05:43:33.337" v="10164" actId="20577"/>
+          <ac:spMkLst>
+            <pc:docMk/>
+            <pc:sldMk cId="3329615997" sldId="289"/>
+            <ac:spMk id="3" creationId="{FBACFB0F-0E9A-48D4-97A7-27723CDED9AC}"/>
+          </ac:spMkLst>
+        </pc:spChg>
+      </pc:sldChg>
+      <pc:sldChg chg="addSp delSp modSp new mod">
+        <pc:chgData name="Malcolm Hayward" userId="fd045f5c-b77a-4191-aa2e-0c5f24668c72" providerId="ADAL" clId="{F2B84187-37ED-4459-971D-E4FC052BE502}" dt="2021-04-16T03:55:02.307" v="7681" actId="14100"/>
+        <pc:sldMkLst>
+          <pc:docMk/>
+          <pc:sldMk cId="3818593411" sldId="290"/>
+        </pc:sldMkLst>
+        <pc:spChg chg="mod">
+          <ac:chgData name="Malcolm Hayward" userId="fd045f5c-b77a-4191-aa2e-0c5f24668c72" providerId="ADAL" clId="{F2B84187-37ED-4459-971D-E4FC052BE502}" dt="2021-04-16T03:52:54.909" v="7650"/>
+          <ac:spMkLst>
+            <pc:docMk/>
+            <pc:sldMk cId="3818593411" sldId="290"/>
+            <ac:spMk id="2" creationId="{1881E8A8-25A2-45AF-8239-21A81C633A08}"/>
+          </ac:spMkLst>
+        </pc:spChg>
+        <pc:spChg chg="del">
+          <ac:chgData name="Malcolm Hayward" userId="fd045f5c-b77a-4191-aa2e-0c5f24668c72" providerId="ADAL" clId="{F2B84187-37ED-4459-971D-E4FC052BE502}" dt="2021-04-16T03:52:05.893" v="7635"/>
+          <ac:spMkLst>
+            <pc:docMk/>
+            <pc:sldMk cId="3818593411" sldId="290"/>
+            <ac:spMk id="3" creationId="{43B78EFC-D879-42B4-A821-85D0D3BE718D}"/>
+          </ac:spMkLst>
+        </pc:spChg>
+        <pc:spChg chg="add mod">
+          <ac:chgData name="Malcolm Hayward" userId="fd045f5c-b77a-4191-aa2e-0c5f24668c72" providerId="ADAL" clId="{F2B84187-37ED-4459-971D-E4FC052BE502}" dt="2021-04-16T03:55:00.488" v="7680" actId="1076"/>
+          <ac:spMkLst>
+            <pc:docMk/>
+            <pc:sldMk cId="3818593411" sldId="290"/>
+            <ac:spMk id="5" creationId="{418DAA15-6F0C-4684-8345-34967CD6EA50}"/>
+          </ac:spMkLst>
+        </pc:spChg>
+        <pc:picChg chg="add mod">
+          <ac:chgData name="Malcolm Hayward" userId="fd045f5c-b77a-4191-aa2e-0c5f24668c72" providerId="ADAL" clId="{F2B84187-37ED-4459-971D-E4FC052BE502}" dt="2021-04-16T03:55:02.307" v="7681" actId="14100"/>
+          <ac:picMkLst>
+            <pc:docMk/>
+            <pc:sldMk cId="3818593411" sldId="290"/>
+            <ac:picMk id="4" creationId="{FD3413AE-BC36-47EF-B157-8D4DBFFE9058}"/>
+          </ac:picMkLst>
+        </pc:picChg>
+      </pc:sldChg>
+      <pc:sldChg chg="modSp new mod">
+        <pc:chgData name="Malcolm Hayward" userId="fd045f5c-b77a-4191-aa2e-0c5f24668c72" providerId="ADAL" clId="{F2B84187-37ED-4459-971D-E4FC052BE502}" dt="2021-04-16T04:39:54.126" v="8597" actId="20577"/>
+        <pc:sldMkLst>
+          <pc:docMk/>
+          <pc:sldMk cId="4225937240" sldId="291"/>
+        </pc:sldMkLst>
+        <pc:spChg chg="mod">
+          <ac:chgData name="Malcolm Hayward" userId="fd045f5c-b77a-4191-aa2e-0c5f24668c72" providerId="ADAL" clId="{F2B84187-37ED-4459-971D-E4FC052BE502}" dt="2021-04-16T04:30:57.730" v="8344" actId="20577"/>
+          <ac:spMkLst>
+            <pc:docMk/>
+            <pc:sldMk cId="4225937240" sldId="291"/>
+            <ac:spMk id="2" creationId="{4EF2DC42-2162-4C4C-B946-7CA5791A0E11}"/>
+          </ac:spMkLst>
+        </pc:spChg>
+        <pc:spChg chg="mod">
+          <ac:chgData name="Malcolm Hayward" userId="fd045f5c-b77a-4191-aa2e-0c5f24668c72" providerId="ADAL" clId="{F2B84187-37ED-4459-971D-E4FC052BE502}" dt="2021-04-16T04:39:54.126" v="8597" actId="20577"/>
+          <ac:spMkLst>
+            <pc:docMk/>
+            <pc:sldMk cId="4225937240" sldId="291"/>
+            <ac:spMk id="3" creationId="{10CA2D5F-B982-474D-9CEC-641A3EA41B7A}"/>
+          </ac:spMkLst>
+        </pc:spChg>
+      </pc:sldChg>
+      <pc:sldChg chg="modSp new mod">
+        <pc:chgData name="Malcolm Hayward" userId="fd045f5c-b77a-4191-aa2e-0c5f24668c72" providerId="ADAL" clId="{F2B84187-37ED-4459-971D-E4FC052BE502}" dt="2021-04-16T05:01:40.385" v="9831" actId="5793"/>
+        <pc:sldMkLst>
+          <pc:docMk/>
+          <pc:sldMk cId="3162552374" sldId="292"/>
+        </pc:sldMkLst>
+        <pc:spChg chg="mod">
+          <ac:chgData name="Malcolm Hayward" userId="fd045f5c-b77a-4191-aa2e-0c5f24668c72" providerId="ADAL" clId="{F2B84187-37ED-4459-971D-E4FC052BE502}" dt="2021-04-16T04:44:32.509" v="8641" actId="20577"/>
+          <ac:spMkLst>
+            <pc:docMk/>
+            <pc:sldMk cId="3162552374" sldId="292"/>
+            <ac:spMk id="2" creationId="{45E0CBCD-C010-4DF3-937C-02B8731F050F}"/>
+          </ac:spMkLst>
+        </pc:spChg>
+        <pc:spChg chg="mod">
+          <ac:chgData name="Malcolm Hayward" userId="fd045f5c-b77a-4191-aa2e-0c5f24668c72" providerId="ADAL" clId="{F2B84187-37ED-4459-971D-E4FC052BE502}" dt="2021-04-16T05:01:40.385" v="9831" actId="5793"/>
+          <ac:spMkLst>
+            <pc:docMk/>
+            <pc:sldMk cId="3162552374" sldId="292"/>
+            <ac:spMk id="3" creationId="{7EE42915-297B-4033-B516-4B845B3BAAA3}"/>
+          </ac:spMkLst>
+        </pc:spChg>
+      </pc:sldChg>
+      <pc:sldChg chg="addSp delSp modSp new mod">
+        <pc:chgData name="Malcolm Hayward" userId="fd045f5c-b77a-4191-aa2e-0c5f24668c72" providerId="ADAL" clId="{F2B84187-37ED-4459-971D-E4FC052BE502}" dt="2021-04-16T04:53:45.648" v="9067" actId="20577"/>
+        <pc:sldMkLst>
+          <pc:docMk/>
+          <pc:sldMk cId="1627882353" sldId="293"/>
+        </pc:sldMkLst>
+        <pc:spChg chg="mod">
+          <ac:chgData name="Malcolm Hayward" userId="fd045f5c-b77a-4191-aa2e-0c5f24668c72" providerId="ADAL" clId="{F2B84187-37ED-4459-971D-E4FC052BE502}" dt="2021-04-16T04:53:45.648" v="9067" actId="20577"/>
+          <ac:spMkLst>
+            <pc:docMk/>
+            <pc:sldMk cId="1627882353" sldId="293"/>
+            <ac:spMk id="2" creationId="{34FC2CF9-9DBF-4289-95B4-D724F130E63F}"/>
+          </ac:spMkLst>
+        </pc:spChg>
+        <pc:spChg chg="del">
+          <ac:chgData name="Malcolm Hayward" userId="fd045f5c-b77a-4191-aa2e-0c5f24668c72" providerId="ADAL" clId="{F2B84187-37ED-4459-971D-E4FC052BE502}" dt="2021-04-16T04:53:09.440" v="8989" actId="22"/>
+          <ac:spMkLst>
+            <pc:docMk/>
+            <pc:sldMk cId="1627882353" sldId="293"/>
+            <ac:spMk id="3" creationId="{F32D27E9-878F-42D2-8E88-0A9FC6A7FCCB}"/>
+          </ac:spMkLst>
+        </pc:spChg>
+        <pc:picChg chg="add mod ord">
+          <ac:chgData name="Malcolm Hayward" userId="fd045f5c-b77a-4191-aa2e-0c5f24668c72" providerId="ADAL" clId="{F2B84187-37ED-4459-971D-E4FC052BE502}" dt="2021-04-16T04:53:30.877" v="9000" actId="14100"/>
+          <ac:picMkLst>
+            <pc:docMk/>
+            <pc:sldMk cId="1627882353" sldId="293"/>
+            <ac:picMk id="5" creationId="{3EFD3DFB-E647-4E4A-AEFE-39FD2CF323E5}"/>
+          </ac:picMkLst>
+        </pc:picChg>
+      </pc:sldChg>
+      <pc:sldChg chg="modSp new mod addCm modCm">
+        <pc:chgData name="Malcolm Hayward" userId="fd045f5c-b77a-4191-aa2e-0c5f24668c72" providerId="ADAL" clId="{F2B84187-37ED-4459-971D-E4FC052BE502}" dt="2021-04-23T23:42:48.079" v="12531" actId="20577"/>
+        <pc:sldMkLst>
+          <pc:docMk/>
+          <pc:sldMk cId="379489396" sldId="294"/>
+        </pc:sldMkLst>
+        <pc:spChg chg="mod">
+          <ac:chgData name="Malcolm Hayward" userId="fd045f5c-b77a-4191-aa2e-0c5f24668c72" providerId="ADAL" clId="{F2B84187-37ED-4459-971D-E4FC052BE502}" dt="2021-04-17T08:39:41.396" v="12140" actId="20577"/>
+          <ac:spMkLst>
+            <pc:docMk/>
+            <pc:sldMk cId="379489396" sldId="294"/>
+            <ac:spMk id="2" creationId="{76611BE4-E132-440C-B0E7-390037577EC0}"/>
+          </ac:spMkLst>
+        </pc:spChg>
+        <pc:spChg chg="mod">
+          <ac:chgData name="Malcolm Hayward" userId="fd045f5c-b77a-4191-aa2e-0c5f24668c72" providerId="ADAL" clId="{F2B84187-37ED-4459-971D-E4FC052BE502}" dt="2021-04-23T23:42:48.079" v="12531" actId="20577"/>
+          <ac:spMkLst>
+            <pc:docMk/>
+            <pc:sldMk cId="379489396" sldId="294"/>
+            <ac:spMk id="3" creationId="{92BC5D98-647B-42E8-8F8C-27308D61790E}"/>
+          </ac:spMkLst>
+        </pc:spChg>
+      </pc:sldChg>
+      <pc:sldChg chg="modSp new mod">
+        <pc:chgData name="Malcolm Hayward" userId="fd045f5c-b77a-4191-aa2e-0c5f24668c72" providerId="ADAL" clId="{F2B84187-37ED-4459-971D-E4FC052BE502}" dt="2021-04-19T13:15:34.603" v="12202" actId="20577"/>
+        <pc:sldMkLst>
+          <pc:docMk/>
+          <pc:sldMk cId="4210512842" sldId="295"/>
+        </pc:sldMkLst>
+        <pc:spChg chg="mod">
+          <ac:chgData name="Malcolm Hayward" userId="fd045f5c-b77a-4191-aa2e-0c5f24668c72" providerId="ADAL" clId="{F2B84187-37ED-4459-971D-E4FC052BE502}" dt="2021-04-17T07:38:18.468" v="11265" actId="20577"/>
+          <ac:spMkLst>
+            <pc:docMk/>
+            <pc:sldMk cId="4210512842" sldId="295"/>
+            <ac:spMk id="2" creationId="{CE1305A4-E685-4446-93A4-C74617E621BE}"/>
+          </ac:spMkLst>
+        </pc:spChg>
+        <pc:spChg chg="mod">
+          <ac:chgData name="Malcolm Hayward" userId="fd045f5c-b77a-4191-aa2e-0c5f24668c72" providerId="ADAL" clId="{F2B84187-37ED-4459-971D-E4FC052BE502}" dt="2021-04-19T13:15:34.603" v="12202" actId="20577"/>
+          <ac:spMkLst>
+            <pc:docMk/>
+            <pc:sldMk cId="4210512842" sldId="295"/>
+            <ac:spMk id="3" creationId="{D217E6F4-051D-40AC-89C8-1EB66596D46B}"/>
+          </ac:spMkLst>
+        </pc:spChg>
+      </pc:sldChg>
+    </pc:docChg>
+  </pc:docChgLst>
+  <pc:docChgLst>
+    <pc:chgData name="Weifeng Xu" userId="e7aed605-a3dd-4d5a-a692-a87037af107b" providerId="ADAL" clId="{1F4F5B84-491D-43A0-805D-265CDB221584}"/>
+    <pc:docChg chg="undo custSel addSld modSld">
+      <pc:chgData name="Weifeng Xu" userId="e7aed605-a3dd-4d5a-a692-a87037af107b" providerId="ADAL" clId="{1F4F5B84-491D-43A0-805D-265CDB221584}" dt="2021-06-25T18:57:40.790" v="1203" actId="20577"/>
+      <pc:docMkLst>
+        <pc:docMk/>
+      </pc:docMkLst>
+      <pc:sldChg chg="modSp mod">
+        <pc:chgData name="Weifeng Xu" userId="e7aed605-a3dd-4d5a-a692-a87037af107b" providerId="ADAL" clId="{1F4F5B84-491D-43A0-805D-265CDB221584}" dt="2021-06-23T12:29:00.335" v="351" actId="20577"/>
+        <pc:sldMkLst>
+          <pc:docMk/>
+          <pc:sldMk cId="3994808847" sldId="256"/>
+        </pc:sldMkLst>
+        <pc:spChg chg="mod">
+          <ac:chgData name="Weifeng Xu" userId="e7aed605-a3dd-4d5a-a692-a87037af107b" providerId="ADAL" clId="{1F4F5B84-491D-43A0-805D-265CDB221584}" dt="2021-06-23T12:29:00.335" v="351" actId="20577"/>
+          <ac:spMkLst>
+            <pc:docMk/>
+            <pc:sldMk cId="3994808847" sldId="256"/>
+            <ac:spMk id="2" creationId="{70237326-DEB0-48BC-A677-FA9640B9C967}"/>
+          </ac:spMkLst>
+        </pc:spChg>
+      </pc:sldChg>
+      <pc:sldChg chg="addSp modSp mod">
+        <pc:chgData name="Weifeng Xu" userId="e7aed605-a3dd-4d5a-a692-a87037af107b" providerId="ADAL" clId="{1F4F5B84-491D-43A0-805D-265CDB221584}" dt="2021-06-22T14:30:40.798" v="184" actId="1076"/>
+        <pc:sldMkLst>
+          <pc:docMk/>
+          <pc:sldMk cId="330888168" sldId="258"/>
+        </pc:sldMkLst>
+        <pc:spChg chg="mod">
+          <ac:chgData name="Weifeng Xu" userId="e7aed605-a3dd-4d5a-a692-a87037af107b" providerId="ADAL" clId="{1F4F5B84-491D-43A0-805D-265CDB221584}" dt="2021-06-22T14:15:26.098" v="146" actId="6549"/>
+          <ac:spMkLst>
+            <pc:docMk/>
+            <pc:sldMk cId="330888168" sldId="258"/>
+            <ac:spMk id="2" creationId="{1D3B01B3-DBAD-4764-BF44-57D5C2C3E788}"/>
+          </ac:spMkLst>
+        </pc:spChg>
+        <pc:spChg chg="add mod">
+          <ac:chgData name="Weifeng Xu" userId="e7aed605-a3dd-4d5a-a692-a87037af107b" providerId="ADAL" clId="{1F4F5B84-491D-43A0-805D-265CDB221584}" dt="2021-06-22T14:30:40.798" v="184" actId="1076"/>
+          <ac:spMkLst>
+            <pc:docMk/>
+            <pc:sldMk cId="330888168" sldId="258"/>
+            <ac:spMk id="3" creationId="{069C2D5A-DC52-4846-84FA-BA354714EACC}"/>
+          </ac:spMkLst>
+        </pc:spChg>
+        <pc:picChg chg="mod">
+          <ac:chgData name="Weifeng Xu" userId="e7aed605-a3dd-4d5a-a692-a87037af107b" providerId="ADAL" clId="{1F4F5B84-491D-43A0-805D-265CDB221584}" dt="2021-06-22T14:30:38.848" v="183" actId="1076"/>
+          <ac:picMkLst>
+            <pc:docMk/>
+            <pc:sldMk cId="330888168" sldId="258"/>
+            <ac:picMk id="6" creationId="{B9289351-22B6-4B47-9EAA-52F38ADFF92F}"/>
+          </ac:picMkLst>
+        </pc:picChg>
+      </pc:sldChg>
+      <pc:sldChg chg="modSp mod">
+        <pc:chgData name="Weifeng Xu" userId="e7aed605-a3dd-4d5a-a692-a87037af107b" providerId="ADAL" clId="{1F4F5B84-491D-43A0-805D-265CDB221584}" dt="2021-06-22T15:51:56.161" v="323" actId="207"/>
+        <pc:sldMkLst>
+          <pc:docMk/>
+          <pc:sldMk cId="2554469295" sldId="260"/>
+        </pc:sldMkLst>
+        <pc:spChg chg="mod">
+          <ac:chgData name="Weifeng Xu" userId="e7aed605-a3dd-4d5a-a692-a87037af107b" providerId="ADAL" clId="{1F4F5B84-491D-43A0-805D-265CDB221584}" dt="2021-06-22T15:51:56.161" v="323" actId="207"/>
+          <ac:spMkLst>
+            <pc:docMk/>
+            <pc:sldMk cId="2554469295" sldId="260"/>
+            <ac:spMk id="3" creationId="{3BA30A2E-1BF0-49E4-80D5-BB47E80CBD3E}"/>
+          </ac:spMkLst>
+        </pc:spChg>
+      </pc:sldChg>
+      <pc:sldChg chg="modSp mod">
+        <pc:chgData name="Weifeng Xu" userId="e7aed605-a3dd-4d5a-a692-a87037af107b" providerId="ADAL" clId="{1F4F5B84-491D-43A0-805D-265CDB221584}" dt="2021-06-25T18:57:40.790" v="1203" actId="20577"/>
+        <pc:sldMkLst>
+          <pc:docMk/>
+          <pc:sldMk cId="1758211574" sldId="261"/>
+        </pc:sldMkLst>
+        <pc:spChg chg="mod">
+          <ac:chgData name="Weifeng Xu" userId="e7aed605-a3dd-4d5a-a692-a87037af107b" providerId="ADAL" clId="{1F4F5B84-491D-43A0-805D-265CDB221584}" dt="2021-06-25T18:57:40.790" v="1203" actId="20577"/>
+          <ac:spMkLst>
+            <pc:docMk/>
+            <pc:sldMk cId="1758211574" sldId="261"/>
+            <ac:spMk id="3" creationId="{689D8F08-8365-4E2C-BFB6-D1790294648E}"/>
+          </ac:spMkLst>
+        </pc:spChg>
+      </pc:sldChg>
+      <pc:sldChg chg="modSp mod">
+        <pc:chgData name="Weifeng Xu" userId="e7aed605-a3dd-4d5a-a692-a87037af107b" providerId="ADAL" clId="{1F4F5B84-491D-43A0-805D-265CDB221584}" dt="2021-06-22T15:24:55.645" v="233" actId="114"/>
+        <pc:sldMkLst>
+          <pc:docMk/>
+          <pc:sldMk cId="3257189420" sldId="273"/>
+        </pc:sldMkLst>
+        <pc:spChg chg="mod">
+          <ac:chgData name="Weifeng Xu" userId="e7aed605-a3dd-4d5a-a692-a87037af107b" providerId="ADAL" clId="{1F4F5B84-491D-43A0-805D-265CDB221584}" dt="2021-06-22T15:24:55.645" v="233" actId="114"/>
+          <ac:spMkLst>
+            <pc:docMk/>
+            <pc:sldMk cId="3257189420" sldId="273"/>
+            <ac:spMk id="2" creationId="{2FB4D46D-2B22-4B4D-804B-E8F7854B2E48}"/>
+          </ac:spMkLst>
+        </pc:spChg>
+        <pc:spChg chg="mod">
+          <ac:chgData name="Weifeng Xu" userId="e7aed605-a3dd-4d5a-a692-a87037af107b" providerId="ADAL" clId="{1F4F5B84-491D-43A0-805D-265CDB221584}" dt="2021-06-22T15:24:52.008" v="232" actId="114"/>
+          <ac:spMkLst>
+            <pc:docMk/>
+            <pc:sldMk cId="3257189420" sldId="273"/>
+            <ac:spMk id="3" creationId="{7BBDBB4A-588A-4008-B72F-87A2EC36E6FA}"/>
+          </ac:spMkLst>
+        </pc:spChg>
+      </pc:sldChg>
+      <pc:sldChg chg="modSp mod">
+        <pc:chgData name="Weifeng Xu" userId="e7aed605-a3dd-4d5a-a692-a87037af107b" providerId="ADAL" clId="{1F4F5B84-491D-43A0-805D-265CDB221584}" dt="2021-06-22T15:17:35.757" v="215" actId="114"/>
+        <pc:sldMkLst>
+          <pc:docMk/>
+          <pc:sldMk cId="2714755137" sldId="274"/>
+        </pc:sldMkLst>
+        <pc:spChg chg="mod">
+          <ac:chgData name="Weifeng Xu" userId="e7aed605-a3dd-4d5a-a692-a87037af107b" providerId="ADAL" clId="{1F4F5B84-491D-43A0-805D-265CDB221584}" dt="2021-06-22T15:17:35.757" v="215" actId="114"/>
+          <ac:spMkLst>
+            <pc:docMk/>
+            <pc:sldMk cId="2714755137" sldId="274"/>
+            <ac:spMk id="8" creationId="{504FEAC0-5C5A-4996-AC9E-813751E42B47}"/>
+          </ac:spMkLst>
+        </pc:spChg>
+      </pc:sldChg>
+      <pc:sldChg chg="modSp mod">
+        <pc:chgData name="Weifeng Xu" userId="e7aed605-a3dd-4d5a-a692-a87037af107b" providerId="ADAL" clId="{1F4F5B84-491D-43A0-805D-265CDB221584}" dt="2021-06-22T15:19:12.898" v="217" actId="114"/>
+        <pc:sldMkLst>
+          <pc:docMk/>
+          <pc:sldMk cId="1140682228" sldId="277"/>
+        </pc:sldMkLst>
+        <pc:spChg chg="mod">
+          <ac:chgData name="Weifeng Xu" userId="e7aed605-a3dd-4d5a-a692-a87037af107b" providerId="ADAL" clId="{1F4F5B84-491D-43A0-805D-265CDB221584}" dt="2021-06-22T15:19:12.898" v="217" actId="114"/>
+          <ac:spMkLst>
+            <pc:docMk/>
+            <pc:sldMk cId="1140682228" sldId="277"/>
+            <ac:spMk id="2" creationId="{03E37E4E-87BE-4A78-B4CF-4917FBBF32A2}"/>
+          </ac:spMkLst>
+        </pc:spChg>
+      </pc:sldChg>
+      <pc:sldChg chg="modSp mod">
+        <pc:chgData name="Weifeng Xu" userId="e7aed605-a3dd-4d5a-a692-a87037af107b" providerId="ADAL" clId="{1F4F5B84-491D-43A0-805D-265CDB221584}" dt="2021-06-22T15:41:23.425" v="256" actId="114"/>
+        <pc:sldMkLst>
+          <pc:docMk/>
+          <pc:sldMk cId="2238744396" sldId="278"/>
+        </pc:sldMkLst>
+        <pc:spChg chg="mod">
+          <ac:chgData name="Weifeng Xu" userId="e7aed605-a3dd-4d5a-a692-a87037af107b" providerId="ADAL" clId="{1F4F5B84-491D-43A0-805D-265CDB221584}" dt="2021-06-22T15:41:23.425" v="256" actId="114"/>
+          <ac:spMkLst>
+            <pc:docMk/>
+            <pc:sldMk cId="2238744396" sldId="278"/>
+            <ac:spMk id="2" creationId="{A27652C0-7A7F-4776-B286-472A3C2F0871}"/>
+          </ac:spMkLst>
+        </pc:spChg>
+      </pc:sldChg>
+      <pc:sldChg chg="modSp mod">
+        <pc:chgData name="Weifeng Xu" userId="e7aed605-a3dd-4d5a-a692-a87037af107b" providerId="ADAL" clId="{1F4F5B84-491D-43A0-805D-265CDB221584}" dt="2021-06-22T15:41:55.968" v="260" actId="114"/>
+        <pc:sldMkLst>
+          <pc:docMk/>
+          <pc:sldMk cId="334425312" sldId="279"/>
+        </pc:sldMkLst>
+        <pc:spChg chg="mod">
+          <ac:chgData name="Weifeng Xu" userId="e7aed605-a3dd-4d5a-a692-a87037af107b" providerId="ADAL" clId="{1F4F5B84-491D-43A0-805D-265CDB221584}" dt="2021-06-22T15:41:55.968" v="260" actId="114"/>
+          <ac:spMkLst>
+            <pc:docMk/>
+            <pc:sldMk cId="334425312" sldId="279"/>
+            <ac:spMk id="2" creationId="{B60B3F95-6244-43F7-B16C-198F20FD2102}"/>
+          </ac:spMkLst>
+        </pc:spChg>
+      </pc:sldChg>
+      <pc:sldChg chg="modSp mod">
+        <pc:chgData name="Weifeng Xu" userId="e7aed605-a3dd-4d5a-a692-a87037af107b" providerId="ADAL" clId="{1F4F5B84-491D-43A0-805D-265CDB221584}" dt="2021-06-22T15:40:01.900" v="252" actId="20577"/>
+        <pc:sldMkLst>
+          <pc:docMk/>
+          <pc:sldMk cId="2855457371" sldId="280"/>
+        </pc:sldMkLst>
+        <pc:spChg chg="mod">
+          <ac:chgData name="Weifeng Xu" userId="e7aed605-a3dd-4d5a-a692-a87037af107b" providerId="ADAL" clId="{1F4F5B84-491D-43A0-805D-265CDB221584}" dt="2021-06-22T15:40:01.900" v="252" actId="20577"/>
+          <ac:spMkLst>
+            <pc:docMk/>
+            <pc:sldMk cId="2855457371" sldId="280"/>
+            <ac:spMk id="4" creationId="{242010A5-2A6D-4901-B056-3883936A3FD8}"/>
+          </ac:spMkLst>
+        </pc:spChg>
+        <pc:picChg chg="mod modCrop">
+          <ac:chgData name="Weifeng Xu" userId="e7aed605-a3dd-4d5a-a692-a87037af107b" providerId="ADAL" clId="{1F4F5B84-491D-43A0-805D-265CDB221584}" dt="2021-06-22T15:38:04.164" v="234" actId="732"/>
+          <ac:picMkLst>
+            <pc:docMk/>
+            <pc:sldMk cId="2855457371" sldId="280"/>
+            <ac:picMk id="8" creationId="{BB1D64D1-035F-4688-9BBE-B70E84A25A72}"/>
+          </ac:picMkLst>
+        </pc:picChg>
+      </pc:sldChg>
+      <pc:sldChg chg="modSp mod">
+        <pc:chgData name="Weifeng Xu" userId="e7aed605-a3dd-4d5a-a692-a87037af107b" providerId="ADAL" clId="{1F4F5B84-491D-43A0-805D-265CDB221584}" dt="2021-06-22T15:46:06.518" v="268" actId="114"/>
+        <pc:sldMkLst>
+          <pc:docMk/>
+          <pc:sldMk cId="3626365319" sldId="282"/>
+        </pc:sldMkLst>
+        <pc:spChg chg="mod">
+          <ac:chgData name="Weifeng Xu" userId="e7aed605-a3dd-4d5a-a692-a87037af107b" providerId="ADAL" clId="{1F4F5B84-491D-43A0-805D-265CDB221584}" dt="2021-06-22T15:45:49.054" v="264" actId="114"/>
+          <ac:spMkLst>
+            <pc:docMk/>
+            <pc:sldMk cId="3626365319" sldId="282"/>
+            <ac:spMk id="2" creationId="{74E2A155-C11A-41DB-B80D-5633F14051EC}"/>
+          </ac:spMkLst>
+        </pc:spChg>
+        <pc:spChg chg="mod">
+          <ac:chgData name="Weifeng Xu" userId="e7aed605-a3dd-4d5a-a692-a87037af107b" providerId="ADAL" clId="{1F4F5B84-491D-43A0-805D-265CDB221584}" dt="2021-06-22T15:46:06.518" v="268" actId="114"/>
+          <ac:spMkLst>
+            <pc:docMk/>
+            <pc:sldMk cId="3626365319" sldId="282"/>
+            <ac:spMk id="3" creationId="{41DBD695-2A86-4ADF-A197-2BAD045E2782}"/>
+          </ac:spMkLst>
+        </pc:spChg>
+      </pc:sldChg>
+      <pc:sldChg chg="modSp mod">
+        <pc:chgData name="Weifeng Xu" userId="e7aed605-a3dd-4d5a-a692-a87037af107b" providerId="ADAL" clId="{1F4F5B84-491D-43A0-805D-265CDB221584}" dt="2021-06-22T13:22:33.103" v="113" actId="207"/>
+        <pc:sldMkLst>
+          <pc:docMk/>
+          <pc:sldMk cId="1827431044" sldId="287"/>
+        </pc:sldMkLst>
+        <pc:spChg chg="mod">
+          <ac:chgData name="Weifeng Xu" userId="e7aed605-a3dd-4d5a-a692-a87037af107b" providerId="ADAL" clId="{1F4F5B84-491D-43A0-805D-265CDB221584}" dt="2021-06-22T13:22:33.103" v="113" actId="207"/>
+          <ac:spMkLst>
+            <pc:docMk/>
+            <pc:sldMk cId="1827431044" sldId="287"/>
+            <ac:spMk id="2" creationId="{03E818AA-76A1-4237-8749-6DAC56FD30E3}"/>
+          </ac:spMkLst>
+        </pc:spChg>
+      </pc:sldChg>
+      <pc:sldChg chg="modNotesTx">
+        <pc:chgData name="Weifeng Xu" userId="e7aed605-a3dd-4d5a-a692-a87037af107b" providerId="ADAL" clId="{1F4F5B84-491D-43A0-805D-265CDB221584}" dt="2021-06-23T13:05:52.756" v="409"/>
+        <pc:sldMkLst>
+          <pc:docMk/>
+          <pc:sldMk cId="1943220090" sldId="288"/>
+        </pc:sldMkLst>
+      </pc:sldChg>
+      <pc:sldChg chg="modSp mod modNotesTx">
+        <pc:chgData name="Weifeng Xu" userId="e7aed605-a3dd-4d5a-a692-a87037af107b" providerId="ADAL" clId="{1F4F5B84-491D-43A0-805D-265CDB221584}" dt="2021-06-22T14:55:03.727" v="211" actId="114"/>
+        <pc:sldMkLst>
+          <pc:docMk/>
+          <pc:sldMk cId="3162552374" sldId="292"/>
+        </pc:sldMkLst>
+        <pc:spChg chg="mod">
+          <ac:chgData name="Weifeng Xu" userId="e7aed605-a3dd-4d5a-a692-a87037af107b" providerId="ADAL" clId="{1F4F5B84-491D-43A0-805D-265CDB221584}" dt="2021-06-22T13:21:59.791" v="111" actId="6549"/>
+          <ac:spMkLst>
+            <pc:docMk/>
+            <pc:sldMk cId="3162552374" sldId="292"/>
+            <ac:spMk id="2" creationId="{45E0CBCD-C010-4DF3-937C-02B8731F050F}"/>
+          </ac:spMkLst>
+        </pc:spChg>
+        <pc:spChg chg="mod">
+          <ac:chgData name="Weifeng Xu" userId="e7aed605-a3dd-4d5a-a692-a87037af107b" providerId="ADAL" clId="{1F4F5B84-491D-43A0-805D-265CDB221584}" dt="2021-06-22T14:55:03.727" v="211" actId="114"/>
+          <ac:spMkLst>
+            <pc:docMk/>
+            <pc:sldMk cId="3162552374" sldId="292"/>
+            <ac:spMk id="3" creationId="{7EE42915-297B-4033-B516-4B845B3BAAA3}"/>
+          </ac:spMkLst>
+        </pc:spChg>
+      </pc:sldChg>
+      <pc:sldChg chg="addSp modSp">
+        <pc:chgData name="Weifeng Xu" userId="e7aed605-a3dd-4d5a-a692-a87037af107b" providerId="ADAL" clId="{1F4F5B84-491D-43A0-805D-265CDB221584}" dt="2021-06-22T13:29:30.499" v="126" actId="1076"/>
+        <pc:sldMkLst>
+          <pc:docMk/>
+          <pc:sldMk cId="379489396" sldId="294"/>
+        </pc:sldMkLst>
+        <pc:picChg chg="add mod">
+          <ac:chgData name="Weifeng Xu" userId="e7aed605-a3dd-4d5a-a692-a87037af107b" providerId="ADAL" clId="{1F4F5B84-491D-43A0-805D-265CDB221584}" dt="2021-06-22T13:25:51.054" v="116" actId="1076"/>
+          <ac:picMkLst>
+            <pc:docMk/>
+            <pc:sldMk cId="379489396" sldId="294"/>
+            <ac:picMk id="1026" creationId="{6B2A3740-B731-4C7C-9164-6EFC58F43D8E}"/>
+          </ac:picMkLst>
+        </pc:picChg>
+        <pc:picChg chg="add mod">
+          <ac:chgData name="Weifeng Xu" userId="e7aed605-a3dd-4d5a-a692-a87037af107b" providerId="ADAL" clId="{1F4F5B84-491D-43A0-805D-265CDB221584}" dt="2021-06-22T13:26:15.291" v="122" actId="1076"/>
+          <ac:picMkLst>
+            <pc:docMk/>
+            <pc:sldMk cId="379489396" sldId="294"/>
+            <ac:picMk id="1028" creationId="{F3D6E8EE-1F95-40C8-A79F-703922B526ED}"/>
+          </ac:picMkLst>
+        </pc:picChg>
+        <pc:picChg chg="add mod">
+          <ac:chgData name="Weifeng Xu" userId="e7aed605-a3dd-4d5a-a692-a87037af107b" providerId="ADAL" clId="{1F4F5B84-491D-43A0-805D-265CDB221584}" dt="2021-06-22T13:29:30.499" v="126" actId="1076"/>
+          <ac:picMkLst>
+            <pc:docMk/>
+            <pc:sldMk cId="379489396" sldId="294"/>
+            <ac:picMk id="1030" creationId="{6DB7CDE2-F3FE-4A54-9FFD-1D57173DF431}"/>
+          </ac:picMkLst>
+        </pc:picChg>
+      </pc:sldChg>
+      <pc:sldChg chg="modSp mod">
+        <pc:chgData name="Weifeng Xu" userId="e7aed605-a3dd-4d5a-a692-a87037af107b" providerId="ADAL" clId="{1F4F5B84-491D-43A0-805D-265CDB221584}" dt="2021-06-22T13:53:14.272" v="133" actId="207"/>
+        <pc:sldMkLst>
+          <pc:docMk/>
+          <pc:sldMk cId="2866903223" sldId="296"/>
+        </pc:sldMkLst>
+        <pc:spChg chg="mod">
+          <ac:chgData name="Weifeng Xu" userId="e7aed605-a3dd-4d5a-a692-a87037af107b" providerId="ADAL" clId="{1F4F5B84-491D-43A0-805D-265CDB221584}" dt="2021-06-22T13:53:14.272" v="133" actId="207"/>
+          <ac:spMkLst>
+            <pc:docMk/>
+            <pc:sldMk cId="2866903223" sldId="296"/>
+            <ac:spMk id="3" creationId="{12EECF59-D087-4334-A3AD-C30FC1FC5222}"/>
+          </ac:spMkLst>
+        </pc:spChg>
+      </pc:sldChg>
+      <pc:sldChg chg="modSp mod">
+        <pc:chgData name="Weifeng Xu" userId="e7aed605-a3dd-4d5a-a692-a87037af107b" providerId="ADAL" clId="{1F4F5B84-491D-43A0-805D-265CDB221584}" dt="2021-06-24T21:48:05.784" v="1096" actId="20577"/>
+        <pc:sldMkLst>
+          <pc:docMk/>
+          <pc:sldMk cId="2598178450" sldId="298"/>
+        </pc:sldMkLst>
+        <pc:spChg chg="mod">
+          <ac:chgData name="Weifeng Xu" userId="e7aed605-a3dd-4d5a-a692-a87037af107b" providerId="ADAL" clId="{1F4F5B84-491D-43A0-805D-265CDB221584}" dt="2021-06-24T21:48:05.784" v="1096" actId="20577"/>
+          <ac:spMkLst>
+            <pc:docMk/>
+            <pc:sldMk cId="2598178450" sldId="298"/>
+            <ac:spMk id="3" creationId="{6E8C0C4A-EE9E-4BE5-BE22-D346A92B4B65}"/>
+          </ac:spMkLst>
+        </pc:spChg>
+      </pc:sldChg>
+      <pc:sldChg chg="modSp mod">
+        <pc:chgData name="Weifeng Xu" userId="e7aed605-a3dd-4d5a-a692-a87037af107b" providerId="ADAL" clId="{1F4F5B84-491D-43A0-805D-265CDB221584}" dt="2021-06-25T11:48:33.320" v="1137" actId="27636"/>
+        <pc:sldMkLst>
+          <pc:docMk/>
+          <pc:sldMk cId="4108355451" sldId="299"/>
+        </pc:sldMkLst>
+        <pc:spChg chg="mod">
+          <ac:chgData name="Weifeng Xu" userId="e7aed605-a3dd-4d5a-a692-a87037af107b" providerId="ADAL" clId="{1F4F5B84-491D-43A0-805D-265CDB221584}" dt="2021-06-25T11:48:33.320" v="1137" actId="27636"/>
+          <ac:spMkLst>
+            <pc:docMk/>
+            <pc:sldMk cId="4108355451" sldId="299"/>
+            <ac:spMk id="3" creationId="{1A5AF07E-27F2-437F-AE26-3E0C4A83F6DF}"/>
+          </ac:spMkLst>
+        </pc:spChg>
+      </pc:sldChg>
+      <pc:sldChg chg="modSp mod">
+        <pc:chgData name="Weifeng Xu" userId="e7aed605-a3dd-4d5a-a692-a87037af107b" providerId="ADAL" clId="{1F4F5B84-491D-43A0-805D-265CDB221584}" dt="2021-06-22T14:38:29.606" v="186" actId="207"/>
+        <pc:sldMkLst>
+          <pc:docMk/>
+          <pc:sldMk cId="1660567586" sldId="300"/>
+        </pc:sldMkLst>
+        <pc:spChg chg="mod">
+          <ac:chgData name="Weifeng Xu" userId="e7aed605-a3dd-4d5a-a692-a87037af107b" providerId="ADAL" clId="{1F4F5B84-491D-43A0-805D-265CDB221584}" dt="2021-06-22T14:38:29.606" v="186" actId="207"/>
+          <ac:spMkLst>
+            <pc:docMk/>
+            <pc:sldMk cId="1660567586" sldId="300"/>
+            <ac:spMk id="2" creationId="{5A428FDF-B1C8-4F01-BD77-C6B0B4564695}"/>
+          </ac:spMkLst>
+        </pc:spChg>
+      </pc:sldChg>
+      <pc:sldChg chg="modSp mod">
+        <pc:chgData name="Weifeng Xu" userId="e7aed605-a3dd-4d5a-a692-a87037af107b" providerId="ADAL" clId="{1F4F5B84-491D-43A0-805D-265CDB221584}" dt="2021-06-22T14:44:59.326" v="188" actId="114"/>
+        <pc:sldMkLst>
+          <pc:docMk/>
+          <pc:sldMk cId="4031451362" sldId="301"/>
+        </pc:sldMkLst>
+        <pc:spChg chg="mod">
+          <ac:chgData name="Weifeng Xu" userId="e7aed605-a3dd-4d5a-a692-a87037af107b" providerId="ADAL" clId="{1F4F5B84-491D-43A0-805D-265CDB221584}" dt="2021-06-22T14:44:59.326" v="188" actId="114"/>
+          <ac:spMkLst>
+            <pc:docMk/>
+            <pc:sldMk cId="4031451362" sldId="301"/>
+            <ac:spMk id="2" creationId="{9427C24E-AADE-40F8-B0FF-8A108A6D7289}"/>
+          </ac:spMkLst>
+        </pc:spChg>
+      </pc:sldChg>
+      <pc:sldChg chg="modSp mod">
+        <pc:chgData name="Weifeng Xu" userId="e7aed605-a3dd-4d5a-a692-a87037af107b" providerId="ADAL" clId="{1F4F5B84-491D-43A0-805D-265CDB221584}" dt="2021-06-22T14:51:51.418" v="199" actId="114"/>
+        <pc:sldMkLst>
+          <pc:docMk/>
+          <pc:sldMk cId="2386719427" sldId="304"/>
+        </pc:sldMkLst>
+        <pc:spChg chg="mod">
+          <ac:chgData name="Weifeng Xu" userId="e7aed605-a3dd-4d5a-a692-a87037af107b" providerId="ADAL" clId="{1F4F5B84-491D-43A0-805D-265CDB221584}" dt="2021-06-22T14:51:51.418" v="199" actId="114"/>
+          <ac:spMkLst>
+            <pc:docMk/>
+            <pc:sldMk cId="2386719427" sldId="304"/>
+            <ac:spMk id="2" creationId="{89C9E81F-0386-4493-8A46-A2E56985CF8F}"/>
+          </ac:spMkLst>
+        </pc:spChg>
+        <pc:spChg chg="mod">
+          <ac:chgData name="Weifeng Xu" userId="e7aed605-a3dd-4d5a-a692-a87037af107b" providerId="ADAL" clId="{1F4F5B84-491D-43A0-805D-265CDB221584}" dt="2021-06-22T14:51:48.635" v="197" actId="114"/>
+          <ac:spMkLst>
+            <pc:docMk/>
+            <pc:sldMk cId="2386719427" sldId="304"/>
+            <ac:spMk id="3" creationId="{AE804E77-71DD-452B-9B99-E681DBE2714E}"/>
+          </ac:spMkLst>
+        </pc:spChg>
+      </pc:sldChg>
+      <pc:sldChg chg="modSp mod">
+        <pc:chgData name="Weifeng Xu" userId="e7aed605-a3dd-4d5a-a692-a87037af107b" providerId="ADAL" clId="{1F4F5B84-491D-43A0-805D-265CDB221584}" dt="2021-06-22T15:49:18.778" v="317" actId="114"/>
+        <pc:sldMkLst>
+          <pc:docMk/>
+          <pc:sldMk cId="1657819105" sldId="305"/>
+        </pc:sldMkLst>
+        <pc:spChg chg="mod">
+          <ac:chgData name="Weifeng Xu" userId="e7aed605-a3dd-4d5a-a692-a87037af107b" providerId="ADAL" clId="{1F4F5B84-491D-43A0-805D-265CDB221584}" dt="2021-06-22T15:48:23.684" v="309" actId="114"/>
+          <ac:spMkLst>
+            <pc:docMk/>
+            <pc:sldMk cId="1657819105" sldId="305"/>
+            <ac:spMk id="2" creationId="{81B2B962-623B-47A5-AF65-DAA8AC4CB808}"/>
+          </ac:spMkLst>
+        </pc:spChg>
+        <pc:spChg chg="mod">
+          <ac:chgData name="Weifeng Xu" userId="e7aed605-a3dd-4d5a-a692-a87037af107b" providerId="ADAL" clId="{1F4F5B84-491D-43A0-805D-265CDB221584}" dt="2021-06-22T15:49:18.778" v="317" actId="114"/>
+          <ac:spMkLst>
+            <pc:docMk/>
+            <pc:sldMk cId="1657819105" sldId="305"/>
+            <ac:spMk id="3" creationId="{1574B035-BAAD-4460-B1C6-DD9CD59F73C1}"/>
+          </ac:spMkLst>
+        </pc:spChg>
+      </pc:sldChg>
+      <pc:sldChg chg="modSp new mod">
+        <pc:chgData name="Weifeng Xu" userId="e7aed605-a3dd-4d5a-a692-a87037af107b" providerId="ADAL" clId="{1F4F5B84-491D-43A0-805D-265CDB221584}" dt="2021-06-23T18:59:13.957" v="848" actId="20577"/>
+        <pc:sldMkLst>
+          <pc:docMk/>
+          <pc:sldMk cId="4198338688" sldId="307"/>
+        </pc:sldMkLst>
+        <pc:spChg chg="mod">
+          <ac:chgData name="Weifeng Xu" userId="e7aed605-a3dd-4d5a-a692-a87037af107b" providerId="ADAL" clId="{1F4F5B84-491D-43A0-805D-265CDB221584}" dt="2021-06-23T18:57:36.461" v="728"/>
+          <ac:spMkLst>
+            <pc:docMk/>
+            <pc:sldMk cId="4198338688" sldId="307"/>
+            <ac:spMk id="2" creationId="{EF5ADFAF-0651-459A-802B-8BB0CBC5A4A3}"/>
+          </ac:spMkLst>
+        </pc:spChg>
+        <pc:spChg chg="mod">
+          <ac:chgData name="Weifeng Xu" userId="e7aed605-a3dd-4d5a-a692-a87037af107b" providerId="ADAL" clId="{1F4F5B84-491D-43A0-805D-265CDB221584}" dt="2021-06-23T18:59:13.957" v="848" actId="20577"/>
+          <ac:spMkLst>
+            <pc:docMk/>
+            <pc:sldMk cId="4198338688" sldId="307"/>
+            <ac:spMk id="3" creationId="{22CDBE13-DF05-44D1-9DDC-860C8F19E8B2}"/>
+          </ac:spMkLst>
+        </pc:spChg>
+      </pc:sldChg>
+    </pc:docChg>
+  </pc:docChgLst>
+  <pc:docChgLst>
     <pc:chgData name="Malcolm Hayward" userId="fd045f5c-b77a-4191-aa2e-0c5f24668c72" providerId="ADAL" clId="{2841AAE6-08DC-4C4B-87B4-43E9ADD47CE7}"/>
     <pc:docChg chg="undo custSel addSld delSld modSld sldOrd">
       <pc:chgData name="Malcolm Hayward" userId="fd045f5c-b77a-4191-aa2e-0c5f24668c72" providerId="ADAL" clId="{2841AAE6-08DC-4C4B-87B4-43E9ADD47CE7}" dt="2021-05-14T10:48:42.795" v="7246" actId="1076"/>
@@ -1042,1761 +2797,6 @@
             <ac:picMk id="5" creationId="{01020365-F956-40AF-9368-B89F1B8F97FB}"/>
           </ac:picMkLst>
         </pc:picChg>
-      </pc:sldChg>
-    </pc:docChg>
-  </pc:docChgLst>
-  <pc:docChgLst>
-    <pc:chgData name="Malcolm Hayward" userId="fd045f5c-b77a-4191-aa2e-0c5f24668c72" providerId="ADAL" clId="{F2B84187-37ED-4459-971D-E4FC052BE502}"/>
-    <pc:docChg chg="undo custSel addSld delSld modSld sldOrd">
-      <pc:chgData name="Malcolm Hayward" userId="fd045f5c-b77a-4191-aa2e-0c5f24668c72" providerId="ADAL" clId="{F2B84187-37ED-4459-971D-E4FC052BE502}" dt="2021-04-23T23:44:22.687" v="12551" actId="20577"/>
-      <pc:docMkLst>
-        <pc:docMk/>
-      </pc:docMkLst>
-      <pc:sldChg chg="modSp mod addCm modCm">
-        <pc:chgData name="Malcolm Hayward" userId="fd045f5c-b77a-4191-aa2e-0c5f24668c72" providerId="ADAL" clId="{F2B84187-37ED-4459-971D-E4FC052BE502}" dt="2021-04-23T23:43:38.083" v="12533"/>
-        <pc:sldMkLst>
-          <pc:docMk/>
-          <pc:sldMk cId="1173531828" sldId="257"/>
-        </pc:sldMkLst>
-        <pc:spChg chg="mod">
-          <ac:chgData name="Malcolm Hayward" userId="fd045f5c-b77a-4191-aa2e-0c5f24668c72" providerId="ADAL" clId="{F2B84187-37ED-4459-971D-E4FC052BE502}" dt="2021-04-17T05:43:01.890" v="10107" actId="20577"/>
-          <ac:spMkLst>
-            <pc:docMk/>
-            <pc:sldMk cId="1173531828" sldId="257"/>
-            <ac:spMk id="3" creationId="{FBACFB0F-0E9A-48D4-97A7-27723CDED9AC}"/>
-          </ac:spMkLst>
-        </pc:spChg>
-      </pc:sldChg>
-      <pc:sldChg chg="modSp mod">
-        <pc:chgData name="Malcolm Hayward" userId="fd045f5c-b77a-4191-aa2e-0c5f24668c72" providerId="ADAL" clId="{F2B84187-37ED-4459-971D-E4FC052BE502}" dt="2021-04-16T06:09:01.570" v="9961" actId="1076"/>
-        <pc:sldMkLst>
-          <pc:docMk/>
-          <pc:sldMk cId="330888168" sldId="258"/>
-        </pc:sldMkLst>
-        <pc:spChg chg="mod">
-          <ac:chgData name="Malcolm Hayward" userId="fd045f5c-b77a-4191-aa2e-0c5f24668c72" providerId="ADAL" clId="{F2B84187-37ED-4459-971D-E4FC052BE502}" dt="2021-04-12T14:52:27.289" v="7584" actId="20577"/>
-          <ac:spMkLst>
-            <pc:docMk/>
-            <pc:sldMk cId="330888168" sldId="258"/>
-            <ac:spMk id="2" creationId="{1D3B01B3-DBAD-4764-BF44-57D5C2C3E788}"/>
-          </ac:spMkLst>
-        </pc:spChg>
-        <pc:spChg chg="mod">
-          <ac:chgData name="Malcolm Hayward" userId="fd045f5c-b77a-4191-aa2e-0c5f24668c72" providerId="ADAL" clId="{F2B84187-37ED-4459-971D-E4FC052BE502}" dt="2021-03-28T19:06:33.581" v="315" actId="20577"/>
-          <ac:spMkLst>
-            <pc:docMk/>
-            <pc:sldMk cId="330888168" sldId="258"/>
-            <ac:spMk id="3" creationId="{B536B83B-5F93-42E4-BC74-98042FCC0898}"/>
-          </ac:spMkLst>
-        </pc:spChg>
-        <pc:picChg chg="mod">
-          <ac:chgData name="Malcolm Hayward" userId="fd045f5c-b77a-4191-aa2e-0c5f24668c72" providerId="ADAL" clId="{F2B84187-37ED-4459-971D-E4FC052BE502}" dt="2021-04-16T06:09:01.570" v="9961" actId="1076"/>
-          <ac:picMkLst>
-            <pc:docMk/>
-            <pc:sldMk cId="330888168" sldId="258"/>
-            <ac:picMk id="9" creationId="{9C85B62B-EF63-40F6-8E48-8BA60687C8F6}"/>
-          </ac:picMkLst>
-        </pc:picChg>
-      </pc:sldChg>
-      <pc:sldChg chg="addSp delSp modSp new mod addCm delCm">
-        <pc:chgData name="Malcolm Hayward" userId="fd045f5c-b77a-4191-aa2e-0c5f24668c72" providerId="ADAL" clId="{F2B84187-37ED-4459-971D-E4FC052BE502}" dt="2021-04-23T23:44:22.687" v="12551" actId="20577"/>
-        <pc:sldMkLst>
-          <pc:docMk/>
-          <pc:sldMk cId="2696214102" sldId="259"/>
-        </pc:sldMkLst>
-        <pc:spChg chg="mod">
-          <ac:chgData name="Malcolm Hayward" userId="fd045f5c-b77a-4191-aa2e-0c5f24668c72" providerId="ADAL" clId="{F2B84187-37ED-4459-971D-E4FC052BE502}" dt="2021-03-28T18:58:55.438" v="72" actId="20577"/>
-          <ac:spMkLst>
-            <pc:docMk/>
-            <pc:sldMk cId="2696214102" sldId="259"/>
-            <ac:spMk id="2" creationId="{72EA782D-BD19-48DD-8DE9-C41B8EA69D07}"/>
-          </ac:spMkLst>
-        </pc:spChg>
-        <pc:spChg chg="mod">
-          <ac:chgData name="Malcolm Hayward" userId="fd045f5c-b77a-4191-aa2e-0c5f24668c72" providerId="ADAL" clId="{F2B84187-37ED-4459-971D-E4FC052BE502}" dt="2021-04-23T23:44:22.687" v="12551" actId="20577"/>
-          <ac:spMkLst>
-            <pc:docMk/>
-            <pc:sldMk cId="2696214102" sldId="259"/>
-            <ac:spMk id="3" creationId="{3862E7A1-A22F-4D0F-A7E9-51C8CDDA6527}"/>
-          </ac:spMkLst>
-        </pc:spChg>
-        <pc:spChg chg="add del mod">
-          <ac:chgData name="Malcolm Hayward" userId="fd045f5c-b77a-4191-aa2e-0c5f24668c72" providerId="ADAL" clId="{F2B84187-37ED-4459-971D-E4FC052BE502}" dt="2021-03-29T13:30:07.929" v="6987" actId="478"/>
-          <ac:spMkLst>
-            <pc:docMk/>
-            <pc:sldMk cId="2696214102" sldId="259"/>
-            <ac:spMk id="4" creationId="{57F1D51E-EC35-418C-9E0B-7889F5251006}"/>
-          </ac:spMkLst>
-        </pc:spChg>
-        <pc:spChg chg="add mod">
-          <ac:chgData name="Malcolm Hayward" userId="fd045f5c-b77a-4191-aa2e-0c5f24668c72" providerId="ADAL" clId="{F2B84187-37ED-4459-971D-E4FC052BE502}" dt="2021-03-30T21:13:47.313" v="7448" actId="12"/>
-          <ac:spMkLst>
-            <pc:docMk/>
-            <pc:sldMk cId="2696214102" sldId="259"/>
-            <ac:spMk id="4" creationId="{D87AE1B0-F910-4DE1-93EC-F2E8AF23907D}"/>
-          </ac:spMkLst>
-        </pc:spChg>
-        <pc:spChg chg="add mod">
-          <ac:chgData name="Malcolm Hayward" userId="fd045f5c-b77a-4191-aa2e-0c5f24668c72" providerId="ADAL" clId="{F2B84187-37ED-4459-971D-E4FC052BE502}" dt="2021-03-30T21:13:23.078" v="7446" actId="12"/>
-          <ac:spMkLst>
-            <pc:docMk/>
-            <pc:sldMk cId="2696214102" sldId="259"/>
-            <ac:spMk id="5" creationId="{2D8008C4-E3C9-4206-BEA1-84962D1EECEC}"/>
-          </ac:spMkLst>
-        </pc:spChg>
-      </pc:sldChg>
-      <pc:sldChg chg="modSp new mod">
-        <pc:chgData name="Malcolm Hayward" userId="fd045f5c-b77a-4191-aa2e-0c5f24668c72" providerId="ADAL" clId="{F2B84187-37ED-4459-971D-E4FC052BE502}" dt="2021-03-29T04:01:22.450" v="5881" actId="20577"/>
-        <pc:sldMkLst>
-          <pc:docMk/>
-          <pc:sldMk cId="2554469295" sldId="260"/>
-        </pc:sldMkLst>
-        <pc:spChg chg="mod">
-          <ac:chgData name="Malcolm Hayward" userId="fd045f5c-b77a-4191-aa2e-0c5f24668c72" providerId="ADAL" clId="{F2B84187-37ED-4459-971D-E4FC052BE502}" dt="2021-03-28T18:59:07.559" v="127" actId="20577"/>
-          <ac:spMkLst>
-            <pc:docMk/>
-            <pc:sldMk cId="2554469295" sldId="260"/>
-            <ac:spMk id="2" creationId="{1A3FC82E-5227-4B5D-B08D-ED3E9E524F6D}"/>
-          </ac:spMkLst>
-        </pc:spChg>
-        <pc:spChg chg="mod">
-          <ac:chgData name="Malcolm Hayward" userId="fd045f5c-b77a-4191-aa2e-0c5f24668c72" providerId="ADAL" clId="{F2B84187-37ED-4459-971D-E4FC052BE502}" dt="2021-03-29T04:01:22.450" v="5881" actId="20577"/>
-          <ac:spMkLst>
-            <pc:docMk/>
-            <pc:sldMk cId="2554469295" sldId="260"/>
-            <ac:spMk id="3" creationId="{3BA30A2E-1BF0-49E4-80D5-BB47E80CBD3E}"/>
-          </ac:spMkLst>
-        </pc:spChg>
-      </pc:sldChg>
-      <pc:sldChg chg="modSp new mod">
-        <pc:chgData name="Malcolm Hayward" userId="fd045f5c-b77a-4191-aa2e-0c5f24668c72" providerId="ADAL" clId="{F2B84187-37ED-4459-971D-E4FC052BE502}" dt="2021-04-17T08:26:22.732" v="11650" actId="20577"/>
-        <pc:sldMkLst>
-          <pc:docMk/>
-          <pc:sldMk cId="1758211574" sldId="261"/>
-        </pc:sldMkLst>
-        <pc:spChg chg="mod">
-          <ac:chgData name="Malcolm Hayward" userId="fd045f5c-b77a-4191-aa2e-0c5f24668c72" providerId="ADAL" clId="{F2B84187-37ED-4459-971D-E4FC052BE502}" dt="2021-03-28T19:17:06.620" v="540" actId="20577"/>
-          <ac:spMkLst>
-            <pc:docMk/>
-            <pc:sldMk cId="1758211574" sldId="261"/>
-            <ac:spMk id="2" creationId="{817FAD62-355E-43DE-95BD-6915F7867A48}"/>
-          </ac:spMkLst>
-        </pc:spChg>
-        <pc:spChg chg="mod">
-          <ac:chgData name="Malcolm Hayward" userId="fd045f5c-b77a-4191-aa2e-0c5f24668c72" providerId="ADAL" clId="{F2B84187-37ED-4459-971D-E4FC052BE502}" dt="2021-04-17T08:26:22.732" v="11650" actId="20577"/>
-          <ac:spMkLst>
-            <pc:docMk/>
-            <pc:sldMk cId="1758211574" sldId="261"/>
-            <ac:spMk id="3" creationId="{689D8F08-8365-4E2C-BFB6-D1790294648E}"/>
-          </ac:spMkLst>
-        </pc:spChg>
-      </pc:sldChg>
-      <pc:sldChg chg="modSp new mod">
-        <pc:chgData name="Malcolm Hayward" userId="fd045f5c-b77a-4191-aa2e-0c5f24668c72" providerId="ADAL" clId="{F2B84187-37ED-4459-971D-E4FC052BE502}" dt="2021-03-29T03:25:38.286" v="5081" actId="20577"/>
-        <pc:sldMkLst>
-          <pc:docMk/>
-          <pc:sldMk cId="651205157" sldId="262"/>
-        </pc:sldMkLst>
-        <pc:spChg chg="mod">
-          <ac:chgData name="Malcolm Hayward" userId="fd045f5c-b77a-4191-aa2e-0c5f24668c72" providerId="ADAL" clId="{F2B84187-37ED-4459-971D-E4FC052BE502}" dt="2021-03-28T20:36:51.325" v="2984" actId="20577"/>
-          <ac:spMkLst>
-            <pc:docMk/>
-            <pc:sldMk cId="651205157" sldId="262"/>
-            <ac:spMk id="2" creationId="{615B923B-CE6E-42FA-AF3A-862855EAD0CC}"/>
-          </ac:spMkLst>
-        </pc:spChg>
-        <pc:spChg chg="mod">
-          <ac:chgData name="Malcolm Hayward" userId="fd045f5c-b77a-4191-aa2e-0c5f24668c72" providerId="ADAL" clId="{F2B84187-37ED-4459-971D-E4FC052BE502}" dt="2021-03-29T03:25:38.286" v="5081" actId="20577"/>
-          <ac:spMkLst>
-            <pc:docMk/>
-            <pc:sldMk cId="651205157" sldId="262"/>
-            <ac:spMk id="3" creationId="{6E9D4976-9C25-41E0-9243-FA2033B1564E}"/>
-          </ac:spMkLst>
-        </pc:spChg>
-      </pc:sldChg>
-      <pc:sldChg chg="addSp modSp new mod">
-        <pc:chgData name="Malcolm Hayward" userId="fd045f5c-b77a-4191-aa2e-0c5f24668c72" providerId="ADAL" clId="{F2B84187-37ED-4459-971D-E4FC052BE502}" dt="2021-03-28T20:39:58.046" v="3100" actId="20577"/>
-        <pc:sldMkLst>
-          <pc:docMk/>
-          <pc:sldMk cId="1216375069" sldId="263"/>
-        </pc:sldMkLst>
-        <pc:spChg chg="mod">
-          <ac:chgData name="Malcolm Hayward" userId="fd045f5c-b77a-4191-aa2e-0c5f24668c72" providerId="ADAL" clId="{F2B84187-37ED-4459-971D-E4FC052BE502}" dt="2021-03-28T19:22:13.300" v="851" actId="20577"/>
-          <ac:spMkLst>
-            <pc:docMk/>
-            <pc:sldMk cId="1216375069" sldId="263"/>
-            <ac:spMk id="2" creationId="{66009DFB-F695-4564-8B48-EE605618ADD8}"/>
-          </ac:spMkLst>
-        </pc:spChg>
-        <pc:spChg chg="mod">
-          <ac:chgData name="Malcolm Hayward" userId="fd045f5c-b77a-4191-aa2e-0c5f24668c72" providerId="ADAL" clId="{F2B84187-37ED-4459-971D-E4FC052BE502}" dt="2021-03-28T20:39:58.046" v="3100" actId="20577"/>
-          <ac:spMkLst>
-            <pc:docMk/>
-            <pc:sldMk cId="1216375069" sldId="263"/>
-            <ac:spMk id="3" creationId="{A8EBA4CE-7450-4288-964B-FC3F84AD5BED}"/>
-          </ac:spMkLst>
-        </pc:spChg>
-        <pc:picChg chg="add mod">
-          <ac:chgData name="Malcolm Hayward" userId="fd045f5c-b77a-4191-aa2e-0c5f24668c72" providerId="ADAL" clId="{F2B84187-37ED-4459-971D-E4FC052BE502}" dt="2021-03-28T19:25:21.671" v="891" actId="1076"/>
-          <ac:picMkLst>
-            <pc:docMk/>
-            <pc:sldMk cId="1216375069" sldId="263"/>
-            <ac:picMk id="5" creationId="{2F40FAAB-7DB5-4C32-88C1-818797437AD8}"/>
-          </ac:picMkLst>
-        </pc:picChg>
-      </pc:sldChg>
-      <pc:sldChg chg="addSp delSp modSp add mod">
-        <pc:chgData name="Malcolm Hayward" userId="fd045f5c-b77a-4191-aa2e-0c5f24668c72" providerId="ADAL" clId="{F2B84187-37ED-4459-971D-E4FC052BE502}" dt="2021-04-16T06:13:28.877" v="9969"/>
-        <pc:sldMkLst>
-          <pc:docMk/>
-          <pc:sldMk cId="2609369189" sldId="264"/>
-        </pc:sldMkLst>
-        <pc:spChg chg="mod">
-          <ac:chgData name="Malcolm Hayward" userId="fd045f5c-b77a-4191-aa2e-0c5f24668c72" providerId="ADAL" clId="{F2B84187-37ED-4459-971D-E4FC052BE502}" dt="2021-03-28T20:40:04.739" v="3122" actId="20577"/>
-          <ac:spMkLst>
-            <pc:docMk/>
-            <pc:sldMk cId="2609369189" sldId="264"/>
-            <ac:spMk id="3" creationId="{A8EBA4CE-7450-4288-964B-FC3F84AD5BED}"/>
-          </ac:spMkLst>
-        </pc:spChg>
-        <pc:picChg chg="del">
-          <ac:chgData name="Malcolm Hayward" userId="fd045f5c-b77a-4191-aa2e-0c5f24668c72" providerId="ADAL" clId="{F2B84187-37ED-4459-971D-E4FC052BE502}" dt="2021-03-28T19:25:36.797" v="893" actId="478"/>
-          <ac:picMkLst>
-            <pc:docMk/>
-            <pc:sldMk cId="2609369189" sldId="264"/>
-            <ac:picMk id="5" creationId="{2F40FAAB-7DB5-4C32-88C1-818797437AD8}"/>
-          </ac:picMkLst>
-        </pc:picChg>
-        <pc:picChg chg="add mod">
-          <ac:chgData name="Malcolm Hayward" userId="fd045f5c-b77a-4191-aa2e-0c5f24668c72" providerId="ADAL" clId="{F2B84187-37ED-4459-971D-E4FC052BE502}" dt="2021-04-16T06:13:28.877" v="9969"/>
-          <ac:picMkLst>
-            <pc:docMk/>
-            <pc:sldMk cId="2609369189" sldId="264"/>
-            <ac:picMk id="6" creationId="{2A720751-D04A-4B6A-82F6-86BA1D3C0C5A}"/>
-          </ac:picMkLst>
-        </pc:picChg>
-      </pc:sldChg>
-      <pc:sldChg chg="modSp new mod">
-        <pc:chgData name="Malcolm Hayward" userId="fd045f5c-b77a-4191-aa2e-0c5f24668c72" providerId="ADAL" clId="{F2B84187-37ED-4459-971D-E4FC052BE502}" dt="2021-03-28T19:34:47.925" v="2018" actId="20577"/>
-        <pc:sldMkLst>
-          <pc:docMk/>
-          <pc:sldMk cId="742731802" sldId="265"/>
-        </pc:sldMkLst>
-        <pc:spChg chg="mod">
-          <ac:chgData name="Malcolm Hayward" userId="fd045f5c-b77a-4191-aa2e-0c5f24668c72" providerId="ADAL" clId="{F2B84187-37ED-4459-971D-E4FC052BE502}" dt="2021-03-28T19:28:33.253" v="932"/>
-          <ac:spMkLst>
-            <pc:docMk/>
-            <pc:sldMk cId="742731802" sldId="265"/>
-            <ac:spMk id="2" creationId="{024EFF52-7B0F-4D3E-A182-DD6131FC06BC}"/>
-          </ac:spMkLst>
-        </pc:spChg>
-        <pc:spChg chg="mod">
-          <ac:chgData name="Malcolm Hayward" userId="fd045f5c-b77a-4191-aa2e-0c5f24668c72" providerId="ADAL" clId="{F2B84187-37ED-4459-971D-E4FC052BE502}" dt="2021-03-28T19:34:47.925" v="2018" actId="20577"/>
-          <ac:spMkLst>
-            <pc:docMk/>
-            <pc:sldMk cId="742731802" sldId="265"/>
-            <ac:spMk id="3" creationId="{82E1FF18-D4BC-4AB6-9C6C-EB3D4E162AF1}"/>
-          </ac:spMkLst>
-        </pc:spChg>
-      </pc:sldChg>
-      <pc:sldChg chg="modSp new mod">
-        <pc:chgData name="Malcolm Hayward" userId="fd045f5c-b77a-4191-aa2e-0c5f24668c72" providerId="ADAL" clId="{F2B84187-37ED-4459-971D-E4FC052BE502}" dt="2021-04-16T06:02:11.995" v="9940" actId="20577"/>
-        <pc:sldMkLst>
-          <pc:docMk/>
-          <pc:sldMk cId="1331449212" sldId="266"/>
-        </pc:sldMkLst>
-        <pc:spChg chg="mod">
-          <ac:chgData name="Malcolm Hayward" userId="fd045f5c-b77a-4191-aa2e-0c5f24668c72" providerId="ADAL" clId="{F2B84187-37ED-4459-971D-E4FC052BE502}" dt="2021-03-28T19:34:06.598" v="1851" actId="20577"/>
-          <ac:spMkLst>
-            <pc:docMk/>
-            <pc:sldMk cId="1331449212" sldId="266"/>
-            <ac:spMk id="2" creationId="{0E0614CE-54DE-42EA-B367-76749BFE192B}"/>
-          </ac:spMkLst>
-        </pc:spChg>
-        <pc:spChg chg="mod">
-          <ac:chgData name="Malcolm Hayward" userId="fd045f5c-b77a-4191-aa2e-0c5f24668c72" providerId="ADAL" clId="{F2B84187-37ED-4459-971D-E4FC052BE502}" dt="2021-04-16T06:02:11.995" v="9940" actId="20577"/>
-          <ac:spMkLst>
-            <pc:docMk/>
-            <pc:sldMk cId="1331449212" sldId="266"/>
-            <ac:spMk id="3" creationId="{2F25E115-3ED5-47F4-81C9-E486E92CB310}"/>
-          </ac:spMkLst>
-        </pc:spChg>
-      </pc:sldChg>
-      <pc:sldChg chg="addSp modSp new mod">
-        <pc:chgData name="Malcolm Hayward" userId="fd045f5c-b77a-4191-aa2e-0c5f24668c72" providerId="ADAL" clId="{F2B84187-37ED-4459-971D-E4FC052BE502}" dt="2021-04-17T08:02:53.106" v="11387" actId="1076"/>
-        <pc:sldMkLst>
-          <pc:docMk/>
-          <pc:sldMk cId="4194598108" sldId="267"/>
-        </pc:sldMkLst>
-        <pc:spChg chg="mod">
-          <ac:chgData name="Malcolm Hayward" userId="fd045f5c-b77a-4191-aa2e-0c5f24668c72" providerId="ADAL" clId="{F2B84187-37ED-4459-971D-E4FC052BE502}" dt="2021-03-28T19:41:41.052" v="2557" actId="20577"/>
-          <ac:spMkLst>
-            <pc:docMk/>
-            <pc:sldMk cId="4194598108" sldId="267"/>
-            <ac:spMk id="2" creationId="{2856EC3D-AE07-443C-B0D6-7EE8A2F2267A}"/>
-          </ac:spMkLst>
-        </pc:spChg>
-        <pc:spChg chg="mod">
-          <ac:chgData name="Malcolm Hayward" userId="fd045f5c-b77a-4191-aa2e-0c5f24668c72" providerId="ADAL" clId="{F2B84187-37ED-4459-971D-E4FC052BE502}" dt="2021-03-28T19:42:03.294" v="2586" actId="20577"/>
-          <ac:spMkLst>
-            <pc:docMk/>
-            <pc:sldMk cId="4194598108" sldId="267"/>
-            <ac:spMk id="3" creationId="{9C3B2489-2303-4714-B415-91FFD34A87DA}"/>
-          </ac:spMkLst>
-        </pc:spChg>
-        <pc:picChg chg="add mod">
-          <ac:chgData name="Malcolm Hayward" userId="fd045f5c-b77a-4191-aa2e-0c5f24668c72" providerId="ADAL" clId="{F2B84187-37ED-4459-971D-E4FC052BE502}" dt="2021-04-17T08:02:53.106" v="11387" actId="1076"/>
-          <ac:picMkLst>
-            <pc:docMk/>
-            <pc:sldMk cId="4194598108" sldId="267"/>
-            <ac:picMk id="5" creationId="{5A8310E0-F709-4707-A0E5-EEE71BB5F3F2}"/>
-          </ac:picMkLst>
-        </pc:picChg>
-      </pc:sldChg>
-      <pc:sldChg chg="modSp new mod">
-        <pc:chgData name="Malcolm Hayward" userId="fd045f5c-b77a-4191-aa2e-0c5f24668c72" providerId="ADAL" clId="{F2B84187-37ED-4459-971D-E4FC052BE502}" dt="2021-03-28T20:40:57.609" v="3132" actId="20577"/>
-        <pc:sldMkLst>
-          <pc:docMk/>
-          <pc:sldMk cId="600868800" sldId="268"/>
-        </pc:sldMkLst>
-        <pc:spChg chg="mod">
-          <ac:chgData name="Malcolm Hayward" userId="fd045f5c-b77a-4191-aa2e-0c5f24668c72" providerId="ADAL" clId="{F2B84187-37ED-4459-971D-E4FC052BE502}" dt="2021-03-28T19:43:23.814" v="2610" actId="20577"/>
-          <ac:spMkLst>
-            <pc:docMk/>
-            <pc:sldMk cId="600868800" sldId="268"/>
-            <ac:spMk id="2" creationId="{C7DB756B-2FA9-4C52-9730-46BB8B0F0259}"/>
-          </ac:spMkLst>
-        </pc:spChg>
-        <pc:spChg chg="mod">
-          <ac:chgData name="Malcolm Hayward" userId="fd045f5c-b77a-4191-aa2e-0c5f24668c72" providerId="ADAL" clId="{F2B84187-37ED-4459-971D-E4FC052BE502}" dt="2021-03-28T20:40:57.609" v="3132" actId="20577"/>
-          <ac:spMkLst>
-            <pc:docMk/>
-            <pc:sldMk cId="600868800" sldId="268"/>
-            <ac:spMk id="3" creationId="{85620766-BC57-42B3-A70F-ACE9F3D3CDB6}"/>
-          </ac:spMkLst>
-        </pc:spChg>
-      </pc:sldChg>
-      <pc:sldChg chg="addSp delSp modSp new mod">
-        <pc:chgData name="Malcolm Hayward" userId="fd045f5c-b77a-4191-aa2e-0c5f24668c72" providerId="ADAL" clId="{F2B84187-37ED-4459-971D-E4FC052BE502}" dt="2021-04-16T04:39:11.518" v="8596" actId="14100"/>
-        <pc:sldMkLst>
-          <pc:docMk/>
-          <pc:sldMk cId="2644870450" sldId="269"/>
-        </pc:sldMkLst>
-        <pc:spChg chg="mod">
-          <ac:chgData name="Malcolm Hayward" userId="fd045f5c-b77a-4191-aa2e-0c5f24668c72" providerId="ADAL" clId="{F2B84187-37ED-4459-971D-E4FC052BE502}" dt="2021-03-28T20:14:28.802" v="2853" actId="20577"/>
-          <ac:spMkLst>
-            <pc:docMk/>
-            <pc:sldMk cId="2644870450" sldId="269"/>
-            <ac:spMk id="2" creationId="{F0D1CE63-1805-46EC-9A5B-1160C093EF5F}"/>
-          </ac:spMkLst>
-        </pc:spChg>
-        <pc:spChg chg="del mod">
-          <ac:chgData name="Malcolm Hayward" userId="fd045f5c-b77a-4191-aa2e-0c5f24668c72" providerId="ADAL" clId="{F2B84187-37ED-4459-971D-E4FC052BE502}" dt="2021-03-29T02:33:03.654" v="4347" actId="22"/>
-          <ac:spMkLst>
-            <pc:docMk/>
-            <pc:sldMk cId="2644870450" sldId="269"/>
-            <ac:spMk id="3" creationId="{6BED5169-161E-42EB-9A71-C54E18EC3DD6}"/>
-          </ac:spMkLst>
-        </pc:spChg>
-        <pc:picChg chg="add mod ord">
-          <ac:chgData name="Malcolm Hayward" userId="fd045f5c-b77a-4191-aa2e-0c5f24668c72" providerId="ADAL" clId="{F2B84187-37ED-4459-971D-E4FC052BE502}" dt="2021-04-16T04:39:11.518" v="8596" actId="14100"/>
-          <ac:picMkLst>
-            <pc:docMk/>
-            <pc:sldMk cId="2644870450" sldId="269"/>
-            <ac:picMk id="5" creationId="{4FAA9375-CCB5-4525-9D65-180456561FC9}"/>
-          </ac:picMkLst>
-        </pc:picChg>
-      </pc:sldChg>
-      <pc:sldChg chg="modSp new mod">
-        <pc:chgData name="Malcolm Hayward" userId="fd045f5c-b77a-4191-aa2e-0c5f24668c72" providerId="ADAL" clId="{F2B84187-37ED-4459-971D-E4FC052BE502}" dt="2021-03-29T03:13:18.787" v="4926" actId="20577"/>
-        <pc:sldMkLst>
-          <pc:docMk/>
-          <pc:sldMk cId="1440112597" sldId="270"/>
-        </pc:sldMkLst>
-        <pc:spChg chg="mod">
-          <ac:chgData name="Malcolm Hayward" userId="fd045f5c-b77a-4191-aa2e-0c5f24668c72" providerId="ADAL" clId="{F2B84187-37ED-4459-971D-E4FC052BE502}" dt="2021-03-28T21:55:20.762" v="3200" actId="20577"/>
-          <ac:spMkLst>
-            <pc:docMk/>
-            <pc:sldMk cId="1440112597" sldId="270"/>
-            <ac:spMk id="2" creationId="{263EF22C-9BE2-48C4-8373-F8ACE9802E06}"/>
-          </ac:spMkLst>
-        </pc:spChg>
-        <pc:spChg chg="mod">
-          <ac:chgData name="Malcolm Hayward" userId="fd045f5c-b77a-4191-aa2e-0c5f24668c72" providerId="ADAL" clId="{F2B84187-37ED-4459-971D-E4FC052BE502}" dt="2021-03-29T03:13:18.787" v="4926" actId="20577"/>
-          <ac:spMkLst>
-            <pc:docMk/>
-            <pc:sldMk cId="1440112597" sldId="270"/>
-            <ac:spMk id="3" creationId="{31D83BD4-F86A-4D77-A86B-192D5CB40359}"/>
-          </ac:spMkLst>
-        </pc:spChg>
-      </pc:sldChg>
-      <pc:sldChg chg="addSp delSp modSp new mod">
-        <pc:chgData name="Malcolm Hayward" userId="fd045f5c-b77a-4191-aa2e-0c5f24668c72" providerId="ADAL" clId="{F2B84187-37ED-4459-971D-E4FC052BE502}" dt="2021-04-16T04:55:25.721" v="9217" actId="1076"/>
-        <pc:sldMkLst>
-          <pc:docMk/>
-          <pc:sldMk cId="2919125898" sldId="271"/>
-        </pc:sldMkLst>
-        <pc:spChg chg="mod">
-          <ac:chgData name="Malcolm Hayward" userId="fd045f5c-b77a-4191-aa2e-0c5f24668c72" providerId="ADAL" clId="{F2B84187-37ED-4459-971D-E4FC052BE502}" dt="2021-03-28T22:07:43.450" v="4129" actId="20577"/>
-          <ac:spMkLst>
-            <pc:docMk/>
-            <pc:sldMk cId="2919125898" sldId="271"/>
-            <ac:spMk id="2" creationId="{08DCC45B-0180-4C71-A85C-BBEBDDA332A5}"/>
-          </ac:spMkLst>
-        </pc:spChg>
-        <pc:spChg chg="del">
-          <ac:chgData name="Malcolm Hayward" userId="fd045f5c-b77a-4191-aa2e-0c5f24668c72" providerId="ADAL" clId="{F2B84187-37ED-4459-971D-E4FC052BE502}" dt="2021-03-28T22:11:13.329" v="4130" actId="22"/>
-          <ac:spMkLst>
-            <pc:docMk/>
-            <pc:sldMk cId="2919125898" sldId="271"/>
-            <ac:spMk id="3" creationId="{5DE5C55E-CA41-486A-985D-6369BA0836EA}"/>
-          </ac:spMkLst>
-        </pc:spChg>
-        <pc:spChg chg="add del mod">
-          <ac:chgData name="Malcolm Hayward" userId="fd045f5c-b77a-4191-aa2e-0c5f24668c72" providerId="ADAL" clId="{F2B84187-37ED-4459-971D-E4FC052BE502}" dt="2021-04-16T04:41:16.692" v="8599" actId="22"/>
-          <ac:spMkLst>
-            <pc:docMk/>
-            <pc:sldMk cId="2919125898" sldId="271"/>
-            <ac:spMk id="4" creationId="{FC87D331-930C-472D-97C1-691FDC2CB4F1}"/>
-          </ac:spMkLst>
-        </pc:spChg>
-        <pc:spChg chg="add mod">
-          <ac:chgData name="Malcolm Hayward" userId="fd045f5c-b77a-4191-aa2e-0c5f24668c72" providerId="ADAL" clId="{F2B84187-37ED-4459-971D-E4FC052BE502}" dt="2021-04-16T04:55:25.721" v="9217" actId="1076"/>
-          <ac:spMkLst>
-            <pc:docMk/>
-            <pc:sldMk cId="2919125898" sldId="271"/>
-            <ac:spMk id="6" creationId="{B32C25EB-E174-4D23-9C68-4840FBD695AF}"/>
-          </ac:spMkLst>
-        </pc:spChg>
-        <pc:spChg chg="add del mod">
-          <ac:chgData name="Malcolm Hayward" userId="fd045f5c-b77a-4191-aa2e-0c5f24668c72" providerId="ADAL" clId="{F2B84187-37ED-4459-971D-E4FC052BE502}" dt="2021-04-16T04:33:14.942" v="8589" actId="478"/>
-          <ac:spMkLst>
-            <pc:docMk/>
-            <pc:sldMk cId="2919125898" sldId="271"/>
-            <ac:spMk id="7" creationId="{DBC54483-FE25-464B-A0F2-C4492E3B921D}"/>
-          </ac:spMkLst>
-        </pc:spChg>
-        <pc:picChg chg="add del mod ord">
-          <ac:chgData name="Malcolm Hayward" userId="fd045f5c-b77a-4191-aa2e-0c5f24668c72" providerId="ADAL" clId="{F2B84187-37ED-4459-971D-E4FC052BE502}" dt="2021-04-16T04:41:15.014" v="8598" actId="478"/>
-          <ac:picMkLst>
-            <pc:docMk/>
-            <pc:sldMk cId="2919125898" sldId="271"/>
-            <ac:picMk id="5" creationId="{C4F459E6-900B-435B-8DC0-F86AF747F5DA}"/>
-          </ac:picMkLst>
-        </pc:picChg>
-        <pc:picChg chg="add mod ord">
-          <ac:chgData name="Malcolm Hayward" userId="fd045f5c-b77a-4191-aa2e-0c5f24668c72" providerId="ADAL" clId="{F2B84187-37ED-4459-971D-E4FC052BE502}" dt="2021-04-16T04:55:23.040" v="9216" actId="14100"/>
-          <ac:picMkLst>
-            <pc:docMk/>
-            <pc:sldMk cId="2919125898" sldId="271"/>
-            <ac:picMk id="9" creationId="{7F3ACCC9-4B2D-4A35-86B2-E98C79A2A47C}"/>
-          </ac:picMkLst>
-        </pc:picChg>
-      </pc:sldChg>
-      <pc:sldChg chg="addSp delSp modSp new mod addCm delCm modCm">
-        <pc:chgData name="Malcolm Hayward" userId="fd045f5c-b77a-4191-aa2e-0c5f24668c72" providerId="ADAL" clId="{F2B84187-37ED-4459-971D-E4FC052BE502}" dt="2021-04-16T05:09:44.123" v="9833" actId="14100"/>
-        <pc:sldMkLst>
-          <pc:docMk/>
-          <pc:sldMk cId="3261498543" sldId="272"/>
-        </pc:sldMkLst>
-        <pc:spChg chg="mod">
-          <ac:chgData name="Malcolm Hayward" userId="fd045f5c-b77a-4191-aa2e-0c5f24668c72" providerId="ADAL" clId="{F2B84187-37ED-4459-971D-E4FC052BE502}" dt="2021-03-28T22:12:36.959" v="4208" actId="20577"/>
-          <ac:spMkLst>
-            <pc:docMk/>
-            <pc:sldMk cId="3261498543" sldId="272"/>
-            <ac:spMk id="2" creationId="{6902F2C7-7857-4CD1-9975-8E613578E07C}"/>
-          </ac:spMkLst>
-        </pc:spChg>
-        <pc:spChg chg="del">
-          <ac:chgData name="Malcolm Hayward" userId="fd045f5c-b77a-4191-aa2e-0c5f24668c72" providerId="ADAL" clId="{F2B84187-37ED-4459-971D-E4FC052BE502}" dt="2021-03-28T22:13:38.475" v="4209" actId="22"/>
-          <ac:spMkLst>
-            <pc:docMk/>
-            <pc:sldMk cId="3261498543" sldId="272"/>
-            <ac:spMk id="3" creationId="{565C1A6F-00DB-45B9-B686-F7FBC581C8C2}"/>
-          </ac:spMkLst>
-        </pc:spChg>
-        <pc:spChg chg="add del mod">
-          <ac:chgData name="Malcolm Hayward" userId="fd045f5c-b77a-4191-aa2e-0c5f24668c72" providerId="ADAL" clId="{F2B84187-37ED-4459-971D-E4FC052BE502}" dt="2021-03-29T02:54:36.281" v="4475" actId="22"/>
-          <ac:spMkLst>
-            <pc:docMk/>
-            <pc:sldMk cId="3261498543" sldId="272"/>
-            <ac:spMk id="9" creationId="{7477F9DA-6D54-4E30-87B0-CB63FD74291A}"/>
-          </ac:spMkLst>
-        </pc:spChg>
-        <pc:spChg chg="add mod">
-          <ac:chgData name="Malcolm Hayward" userId="fd045f5c-b77a-4191-aa2e-0c5f24668c72" providerId="ADAL" clId="{F2B84187-37ED-4459-971D-E4FC052BE502}" dt="2021-04-16T04:59:11.855" v="9775" actId="1076"/>
-          <ac:spMkLst>
-            <pc:docMk/>
-            <pc:sldMk cId="3261498543" sldId="272"/>
-            <ac:spMk id="14" creationId="{0A85B0EB-8A7D-4D0A-A03D-7CD06F72E85E}"/>
-          </ac:spMkLst>
-        </pc:spChg>
-        <pc:spChg chg="add mod">
-          <ac:chgData name="Malcolm Hayward" userId="fd045f5c-b77a-4191-aa2e-0c5f24668c72" providerId="ADAL" clId="{F2B84187-37ED-4459-971D-E4FC052BE502}" dt="2021-04-16T04:28:32.389" v="8236" actId="1076"/>
-          <ac:spMkLst>
-            <pc:docMk/>
-            <pc:sldMk cId="3261498543" sldId="272"/>
-            <ac:spMk id="15" creationId="{D7F63F0C-05C3-41CC-A2E5-6AC36E2C5D1C}"/>
-          </ac:spMkLst>
-        </pc:spChg>
-        <pc:spChg chg="add del mod">
-          <ac:chgData name="Malcolm Hayward" userId="fd045f5c-b77a-4191-aa2e-0c5f24668c72" providerId="ADAL" clId="{F2B84187-37ED-4459-971D-E4FC052BE502}" dt="2021-03-29T04:22:13.788" v="6234" actId="478"/>
-          <ac:spMkLst>
-            <pc:docMk/>
-            <pc:sldMk cId="3261498543" sldId="272"/>
-            <ac:spMk id="16" creationId="{F2D91ED8-11F4-4C27-87F6-3D71DAEC605A}"/>
-          </ac:spMkLst>
-        </pc:spChg>
-        <pc:picChg chg="add del mod ord">
-          <ac:chgData name="Malcolm Hayward" userId="fd045f5c-b77a-4191-aa2e-0c5f24668c72" providerId="ADAL" clId="{F2B84187-37ED-4459-971D-E4FC052BE502}" dt="2021-03-29T02:53:42.254" v="4474" actId="478"/>
-          <ac:picMkLst>
-            <pc:docMk/>
-            <pc:sldMk cId="3261498543" sldId="272"/>
-            <ac:picMk id="5" creationId="{1A8A7395-FAEF-49C2-A1CA-5D684700FD64}"/>
-          </ac:picMkLst>
-        </pc:picChg>
-        <pc:picChg chg="add del mod">
-          <ac:chgData name="Malcolm Hayward" userId="fd045f5c-b77a-4191-aa2e-0c5f24668c72" providerId="ADAL" clId="{F2B84187-37ED-4459-971D-E4FC052BE502}" dt="2021-03-28T22:16:04.844" v="4222" actId="478"/>
-          <ac:picMkLst>
-            <pc:docMk/>
-            <pc:sldMk cId="3261498543" sldId="272"/>
-            <ac:picMk id="7" creationId="{C0534F56-0D7A-4487-9581-9E6DCDC0E9E9}"/>
-          </ac:picMkLst>
-        </pc:picChg>
-        <pc:picChg chg="add mod ord">
-          <ac:chgData name="Malcolm Hayward" userId="fd045f5c-b77a-4191-aa2e-0c5f24668c72" providerId="ADAL" clId="{F2B84187-37ED-4459-971D-E4FC052BE502}" dt="2021-04-16T04:28:28.172" v="8235" actId="14100"/>
-          <ac:picMkLst>
-            <pc:docMk/>
-            <pc:sldMk cId="3261498543" sldId="272"/>
-            <ac:picMk id="11" creationId="{41C197CB-5F4C-4FC9-B86C-FAC24A718E36}"/>
-          </ac:picMkLst>
-        </pc:picChg>
-        <pc:picChg chg="add mod">
-          <ac:chgData name="Malcolm Hayward" userId="fd045f5c-b77a-4191-aa2e-0c5f24668c72" providerId="ADAL" clId="{F2B84187-37ED-4459-971D-E4FC052BE502}" dt="2021-04-16T05:09:44.123" v="9833" actId="14100"/>
-          <ac:picMkLst>
-            <pc:docMk/>
-            <pc:sldMk cId="3261498543" sldId="272"/>
-            <ac:picMk id="13" creationId="{100CC03C-7E3B-4A57-B7A4-FB942E14778A}"/>
-          </ac:picMkLst>
-        </pc:picChg>
-      </pc:sldChg>
-      <pc:sldChg chg="addSp delSp modSp new mod">
-        <pc:chgData name="Malcolm Hayward" userId="fd045f5c-b77a-4191-aa2e-0c5f24668c72" providerId="ADAL" clId="{F2B84187-37ED-4459-971D-E4FC052BE502}" dt="2021-04-17T08:31:25.519" v="11783" actId="20577"/>
-        <pc:sldMkLst>
-          <pc:docMk/>
-          <pc:sldMk cId="3257189420" sldId="273"/>
-        </pc:sldMkLst>
-        <pc:spChg chg="mod">
-          <ac:chgData name="Malcolm Hayward" userId="fd045f5c-b77a-4191-aa2e-0c5f24668c72" providerId="ADAL" clId="{F2B84187-37ED-4459-971D-E4FC052BE502}" dt="2021-03-28T22:17:10.302" v="4265" actId="313"/>
-          <ac:spMkLst>
-            <pc:docMk/>
-            <pc:sldMk cId="3257189420" sldId="273"/>
-            <ac:spMk id="2" creationId="{2FB4D46D-2B22-4B4D-804B-E8F7854B2E48}"/>
-          </ac:spMkLst>
-        </pc:spChg>
-        <pc:spChg chg="mod">
-          <ac:chgData name="Malcolm Hayward" userId="fd045f5c-b77a-4191-aa2e-0c5f24668c72" providerId="ADAL" clId="{F2B84187-37ED-4459-971D-E4FC052BE502}" dt="2021-04-17T08:31:25.519" v="11783" actId="20577"/>
-          <ac:spMkLst>
-            <pc:docMk/>
-            <pc:sldMk cId="3257189420" sldId="273"/>
-            <ac:spMk id="3" creationId="{7BBDBB4A-588A-4008-B72F-87A2EC36E6FA}"/>
-          </ac:spMkLst>
-        </pc:spChg>
-        <pc:picChg chg="add del">
-          <ac:chgData name="Malcolm Hayward" userId="fd045f5c-b77a-4191-aa2e-0c5f24668c72" providerId="ADAL" clId="{F2B84187-37ED-4459-971D-E4FC052BE502}" dt="2021-03-29T03:35:08.554" v="5396" actId="22"/>
-          <ac:picMkLst>
-            <pc:docMk/>
-            <pc:sldMk cId="3257189420" sldId="273"/>
-            <ac:picMk id="5" creationId="{E429B8E0-F289-4D79-8972-C8FE3F891941}"/>
-          </ac:picMkLst>
-        </pc:picChg>
-        <pc:picChg chg="add del mod">
-          <ac:chgData name="Malcolm Hayward" userId="fd045f5c-b77a-4191-aa2e-0c5f24668c72" providerId="ADAL" clId="{F2B84187-37ED-4459-971D-E4FC052BE502}" dt="2021-03-29T03:36:32.358" v="5445" actId="478"/>
-          <ac:picMkLst>
-            <pc:docMk/>
-            <pc:sldMk cId="3257189420" sldId="273"/>
-            <ac:picMk id="7" creationId="{00108ADF-952C-4F97-97C2-27A6E82C0B04}"/>
-          </ac:picMkLst>
-        </pc:picChg>
-      </pc:sldChg>
-      <pc:sldChg chg="addSp delSp modSp new mod">
-        <pc:chgData name="Malcolm Hayward" userId="fd045f5c-b77a-4191-aa2e-0c5f24668c72" providerId="ADAL" clId="{F2B84187-37ED-4459-971D-E4FC052BE502}" dt="2021-04-16T04:29:47.210" v="8292" actId="1076"/>
-        <pc:sldMkLst>
-          <pc:docMk/>
-          <pc:sldMk cId="2714755137" sldId="274"/>
-        </pc:sldMkLst>
-        <pc:spChg chg="mod">
-          <ac:chgData name="Malcolm Hayward" userId="fd045f5c-b77a-4191-aa2e-0c5f24668c72" providerId="ADAL" clId="{F2B84187-37ED-4459-971D-E4FC052BE502}" dt="2021-03-29T03:00:58.238" v="4512" actId="20577"/>
-          <ac:spMkLst>
-            <pc:docMk/>
-            <pc:sldMk cId="2714755137" sldId="274"/>
-            <ac:spMk id="2" creationId="{9EC0D9D7-89AE-45BB-9BAA-4E021141D7F8}"/>
-          </ac:spMkLst>
-        </pc:spChg>
-        <pc:spChg chg="del">
-          <ac:chgData name="Malcolm Hayward" userId="fd045f5c-b77a-4191-aa2e-0c5f24668c72" providerId="ADAL" clId="{F2B84187-37ED-4459-971D-E4FC052BE502}" dt="2021-03-29T03:00:50.607" v="4492" actId="22"/>
-          <ac:spMkLst>
-            <pc:docMk/>
-            <pc:sldMk cId="2714755137" sldId="274"/>
-            <ac:spMk id="3" creationId="{4E3B6F29-D82C-472F-99AC-DB5F1A648988}"/>
-          </ac:spMkLst>
-        </pc:spChg>
-        <pc:spChg chg="add mod">
-          <ac:chgData name="Malcolm Hayward" userId="fd045f5c-b77a-4191-aa2e-0c5f24668c72" providerId="ADAL" clId="{F2B84187-37ED-4459-971D-E4FC052BE502}" dt="2021-04-16T04:26:35.056" v="8202" actId="1076"/>
-          <ac:spMkLst>
-            <pc:docMk/>
-            <pc:sldMk cId="2714755137" sldId="274"/>
-            <ac:spMk id="8" creationId="{504FEAC0-5C5A-4996-AC9E-813751E42B47}"/>
-          </ac:spMkLst>
-        </pc:spChg>
-        <pc:spChg chg="add mod">
-          <ac:chgData name="Malcolm Hayward" userId="fd045f5c-b77a-4191-aa2e-0c5f24668c72" providerId="ADAL" clId="{F2B84187-37ED-4459-971D-E4FC052BE502}" dt="2021-04-16T04:29:38.094" v="8289" actId="1076"/>
-          <ac:spMkLst>
-            <pc:docMk/>
-            <pc:sldMk cId="2714755137" sldId="274"/>
-            <ac:spMk id="9" creationId="{0559EAF7-81F9-4EDC-A316-55907166BE04}"/>
-          </ac:spMkLst>
-        </pc:spChg>
-        <pc:picChg chg="add mod ord">
-          <ac:chgData name="Malcolm Hayward" userId="fd045f5c-b77a-4191-aa2e-0c5f24668c72" providerId="ADAL" clId="{F2B84187-37ED-4459-971D-E4FC052BE502}" dt="2021-04-16T04:26:17.111" v="8195" actId="14100"/>
-          <ac:picMkLst>
-            <pc:docMk/>
-            <pc:sldMk cId="2714755137" sldId="274"/>
-            <ac:picMk id="5" creationId="{A8B1809E-2D5A-48C4-BF07-BDF0FE73063C}"/>
-          </ac:picMkLst>
-        </pc:picChg>
-        <pc:picChg chg="add mod">
-          <ac:chgData name="Malcolm Hayward" userId="fd045f5c-b77a-4191-aa2e-0c5f24668c72" providerId="ADAL" clId="{F2B84187-37ED-4459-971D-E4FC052BE502}" dt="2021-04-16T04:29:47.210" v="8292" actId="1076"/>
-          <ac:picMkLst>
-            <pc:docMk/>
-            <pc:sldMk cId="2714755137" sldId="274"/>
-            <ac:picMk id="7" creationId="{9062CDAA-EF01-491A-9398-6FE6F987AD47}"/>
-          </ac:picMkLst>
-        </pc:picChg>
-      </pc:sldChg>
-      <pc:sldChg chg="modSp new del mod">
-        <pc:chgData name="Malcolm Hayward" userId="fd045f5c-b77a-4191-aa2e-0c5f24668c72" providerId="ADAL" clId="{F2B84187-37ED-4459-971D-E4FC052BE502}" dt="2021-03-29T04:00:57.769" v="5861" actId="2696"/>
-        <pc:sldMkLst>
-          <pc:docMk/>
-          <pc:sldMk cId="1135381488" sldId="275"/>
-        </pc:sldMkLst>
-        <pc:spChg chg="mod">
-          <ac:chgData name="Malcolm Hayward" userId="fd045f5c-b77a-4191-aa2e-0c5f24668c72" providerId="ADAL" clId="{F2B84187-37ED-4459-971D-E4FC052BE502}" dt="2021-03-28T22:18:15.173" v="4284" actId="20577"/>
-          <ac:spMkLst>
-            <pc:docMk/>
-            <pc:sldMk cId="1135381488" sldId="275"/>
-            <ac:spMk id="2" creationId="{B49094E7-7FB7-4576-BA2E-15EF03DA678B}"/>
-          </ac:spMkLst>
-        </pc:spChg>
-      </pc:sldChg>
-      <pc:sldChg chg="addSp delSp modSp new mod">
-        <pc:chgData name="Malcolm Hayward" userId="fd045f5c-b77a-4191-aa2e-0c5f24668c72" providerId="ADAL" clId="{F2B84187-37ED-4459-971D-E4FC052BE502}" dt="2021-04-16T04:39:01.494" v="8593" actId="14100"/>
-        <pc:sldMkLst>
-          <pc:docMk/>
-          <pc:sldMk cId="3191261408" sldId="276"/>
-        </pc:sldMkLst>
-        <pc:spChg chg="mod">
-          <ac:chgData name="Malcolm Hayward" userId="fd045f5c-b77a-4191-aa2e-0c5f24668c72" providerId="ADAL" clId="{F2B84187-37ED-4459-971D-E4FC052BE502}" dt="2021-03-29T02:33:57.802" v="4369" actId="20577"/>
-          <ac:spMkLst>
-            <pc:docMk/>
-            <pc:sldMk cId="3191261408" sldId="276"/>
-            <ac:spMk id="2" creationId="{3DE1CE75-6A4A-411A-9383-EA5DB3198624}"/>
-          </ac:spMkLst>
-        </pc:spChg>
-        <pc:spChg chg="del">
-          <ac:chgData name="Malcolm Hayward" userId="fd045f5c-b77a-4191-aa2e-0c5f24668c72" providerId="ADAL" clId="{F2B84187-37ED-4459-971D-E4FC052BE502}" dt="2021-03-29T02:33:52.884" v="4350" actId="22"/>
-          <ac:spMkLst>
-            <pc:docMk/>
-            <pc:sldMk cId="3191261408" sldId="276"/>
-            <ac:spMk id="3" creationId="{8F4F35B6-D914-462D-9436-B46ADB871642}"/>
-          </ac:spMkLst>
-        </pc:spChg>
-        <pc:picChg chg="add mod ord">
-          <ac:chgData name="Malcolm Hayward" userId="fd045f5c-b77a-4191-aa2e-0c5f24668c72" providerId="ADAL" clId="{F2B84187-37ED-4459-971D-E4FC052BE502}" dt="2021-03-29T02:46:15.105" v="4393" actId="14100"/>
-          <ac:picMkLst>
-            <pc:docMk/>
-            <pc:sldMk cId="3191261408" sldId="276"/>
-            <ac:picMk id="5" creationId="{25F4D553-6B98-444A-906C-0CAAAE5C7DBF}"/>
-          </ac:picMkLst>
-        </pc:picChg>
-        <pc:picChg chg="mod">
-          <ac:chgData name="Malcolm Hayward" userId="fd045f5c-b77a-4191-aa2e-0c5f24668c72" providerId="ADAL" clId="{F2B84187-37ED-4459-971D-E4FC052BE502}" dt="2021-04-16T04:39:01.494" v="8593" actId="14100"/>
-          <ac:picMkLst>
-            <pc:docMk/>
-            <pc:sldMk cId="3191261408" sldId="276"/>
-            <ac:picMk id="7" creationId="{E020F471-E56A-4C0E-B974-C2C8C4A836DC}"/>
-          </ac:picMkLst>
-        </pc:picChg>
-      </pc:sldChg>
-      <pc:sldChg chg="addSp modSp new mod">
-        <pc:chgData name="Malcolm Hayward" userId="fd045f5c-b77a-4191-aa2e-0c5f24668c72" providerId="ADAL" clId="{F2B84187-37ED-4459-971D-E4FC052BE502}" dt="2021-04-18T09:15:06.233" v="12192" actId="14100"/>
-        <pc:sldMkLst>
-          <pc:docMk/>
-          <pc:sldMk cId="1140682228" sldId="277"/>
-        </pc:sldMkLst>
-        <pc:spChg chg="mod">
-          <ac:chgData name="Malcolm Hayward" userId="fd045f5c-b77a-4191-aa2e-0c5f24668c72" providerId="ADAL" clId="{F2B84187-37ED-4459-971D-E4FC052BE502}" dt="2021-04-16T04:29:08.883" v="8286" actId="20577"/>
-          <ac:spMkLst>
-            <pc:docMk/>
-            <pc:sldMk cId="1140682228" sldId="277"/>
-            <ac:spMk id="2" creationId="{03E37E4E-87BE-4A78-B4CF-4917FBBF32A2}"/>
-          </ac:spMkLst>
-        </pc:spChg>
-        <pc:spChg chg="add mod">
-          <ac:chgData name="Malcolm Hayward" userId="fd045f5c-b77a-4191-aa2e-0c5f24668c72" providerId="ADAL" clId="{F2B84187-37ED-4459-971D-E4FC052BE502}" dt="2021-04-16T04:29:30.268" v="8288" actId="14100"/>
-          <ac:spMkLst>
-            <pc:docMk/>
-            <pc:sldMk cId="1140682228" sldId="277"/>
-            <ac:spMk id="3" creationId="{55D4CD6F-1ED4-47D5-9A83-06C197CD3E94}"/>
-          </ac:spMkLst>
-        </pc:spChg>
-        <pc:spChg chg="mod">
-          <ac:chgData name="Malcolm Hayward" userId="fd045f5c-b77a-4191-aa2e-0c5f24668c72" providerId="ADAL" clId="{F2B84187-37ED-4459-971D-E4FC052BE502}" dt="2021-03-29T03:06:45.629" v="4727" actId="20577"/>
-          <ac:spMkLst>
-            <pc:docMk/>
-            <pc:sldMk cId="1140682228" sldId="277"/>
-            <ac:spMk id="3" creationId="{ADD91F6A-CC28-440A-B5E8-DC933AEB421D}"/>
-          </ac:spMkLst>
-        </pc:spChg>
-        <pc:picChg chg="mod">
-          <ac:chgData name="Malcolm Hayward" userId="fd045f5c-b77a-4191-aa2e-0c5f24668c72" providerId="ADAL" clId="{F2B84187-37ED-4459-971D-E4FC052BE502}" dt="2021-04-18T09:15:06.233" v="12192" actId="14100"/>
-          <ac:picMkLst>
-            <pc:docMk/>
-            <pc:sldMk cId="1140682228" sldId="277"/>
-            <ac:picMk id="9" creationId="{4B3FEE71-0619-4549-8813-4DE2B8B9DFBE}"/>
-          </ac:picMkLst>
-        </pc:picChg>
-      </pc:sldChg>
-      <pc:sldChg chg="new del">
-        <pc:chgData name="Malcolm Hayward" userId="fd045f5c-b77a-4191-aa2e-0c5f24668c72" providerId="ADAL" clId="{F2B84187-37ED-4459-971D-E4FC052BE502}" dt="2021-03-29T03:28:29.868" v="5083" actId="680"/>
-        <pc:sldMkLst>
-          <pc:docMk/>
-          <pc:sldMk cId="2034423005" sldId="278"/>
-        </pc:sldMkLst>
-      </pc:sldChg>
-      <pc:sldChg chg="addSp delSp modSp new mod">
-        <pc:chgData name="Malcolm Hayward" userId="fd045f5c-b77a-4191-aa2e-0c5f24668c72" providerId="ADAL" clId="{F2B84187-37ED-4459-971D-E4FC052BE502}" dt="2021-04-17T08:32:03.182" v="11843" actId="1076"/>
-        <pc:sldMkLst>
-          <pc:docMk/>
-          <pc:sldMk cId="2238744396" sldId="278"/>
-        </pc:sldMkLst>
-        <pc:spChg chg="mod">
-          <ac:chgData name="Malcolm Hayward" userId="fd045f5c-b77a-4191-aa2e-0c5f24668c72" providerId="ADAL" clId="{F2B84187-37ED-4459-971D-E4FC052BE502}" dt="2021-04-17T08:31:44.321" v="11842" actId="20577"/>
-          <ac:spMkLst>
-            <pc:docMk/>
-            <pc:sldMk cId="2238744396" sldId="278"/>
-            <ac:spMk id="2" creationId="{A27652C0-7A7F-4776-B286-472A3C2F0871}"/>
-          </ac:spMkLst>
-        </pc:spChg>
-        <pc:spChg chg="del">
-          <ac:chgData name="Malcolm Hayward" userId="fd045f5c-b77a-4191-aa2e-0c5f24668c72" providerId="ADAL" clId="{F2B84187-37ED-4459-971D-E4FC052BE502}" dt="2021-03-29T03:36:35.585" v="5447" actId="22"/>
-          <ac:spMkLst>
-            <pc:docMk/>
-            <pc:sldMk cId="2238744396" sldId="278"/>
-            <ac:spMk id="3" creationId="{88BE9213-4BAA-4288-90BE-88718F69DC09}"/>
-          </ac:spMkLst>
-        </pc:spChg>
-        <pc:spChg chg="add del mod">
-          <ac:chgData name="Malcolm Hayward" userId="fd045f5c-b77a-4191-aa2e-0c5f24668c72" providerId="ADAL" clId="{F2B84187-37ED-4459-971D-E4FC052BE502}" dt="2021-03-29T03:39:59.698" v="5500" actId="22"/>
-          <ac:spMkLst>
-            <pc:docMk/>
-            <pc:sldMk cId="2238744396" sldId="278"/>
-            <ac:spMk id="7" creationId="{520402CA-7584-461B-A7E6-1AFF82BE8B56}"/>
-          </ac:spMkLst>
-        </pc:spChg>
-        <pc:picChg chg="add del mod ord">
-          <ac:chgData name="Malcolm Hayward" userId="fd045f5c-b77a-4191-aa2e-0c5f24668c72" providerId="ADAL" clId="{F2B84187-37ED-4459-971D-E4FC052BE502}" dt="2021-03-29T03:39:57.853" v="5499" actId="478"/>
-          <ac:picMkLst>
-            <pc:docMk/>
-            <pc:sldMk cId="2238744396" sldId="278"/>
-            <ac:picMk id="5" creationId="{0133DEE5-60BC-4BDD-8434-E4C559BEF7FF}"/>
-          </ac:picMkLst>
-        </pc:picChg>
-        <pc:picChg chg="add mod ord">
-          <ac:chgData name="Malcolm Hayward" userId="fd045f5c-b77a-4191-aa2e-0c5f24668c72" providerId="ADAL" clId="{F2B84187-37ED-4459-971D-E4FC052BE502}" dt="2021-04-17T08:32:03.182" v="11843" actId="1076"/>
-          <ac:picMkLst>
-            <pc:docMk/>
-            <pc:sldMk cId="2238744396" sldId="278"/>
-            <ac:picMk id="9" creationId="{20FB56B1-400F-4945-9985-FD934DD65ED1}"/>
-          </ac:picMkLst>
-        </pc:picChg>
-      </pc:sldChg>
-      <pc:sldChg chg="addSp delSp modSp new mod">
-        <pc:chgData name="Malcolm Hayward" userId="fd045f5c-b77a-4191-aa2e-0c5f24668c72" providerId="ADAL" clId="{F2B84187-37ED-4459-971D-E4FC052BE502}" dt="2021-04-17T08:32:25.222" v="11875" actId="1076"/>
-        <pc:sldMkLst>
-          <pc:docMk/>
-          <pc:sldMk cId="334425312" sldId="279"/>
-        </pc:sldMkLst>
-        <pc:spChg chg="mod">
-          <ac:chgData name="Malcolm Hayward" userId="fd045f5c-b77a-4191-aa2e-0c5f24668c72" providerId="ADAL" clId="{F2B84187-37ED-4459-971D-E4FC052BE502}" dt="2021-04-17T08:32:18.376" v="11874" actId="20577"/>
-          <ac:spMkLst>
-            <pc:docMk/>
-            <pc:sldMk cId="334425312" sldId="279"/>
-            <ac:spMk id="2" creationId="{B60B3F95-6244-43F7-B16C-198F20FD2102}"/>
-          </ac:spMkLst>
-        </pc:spChg>
-        <pc:spChg chg="del">
-          <ac:chgData name="Malcolm Hayward" userId="fd045f5c-b77a-4191-aa2e-0c5f24668c72" providerId="ADAL" clId="{F2B84187-37ED-4459-971D-E4FC052BE502}" dt="2021-03-29T03:42:56.077" v="5504" actId="22"/>
-          <ac:spMkLst>
-            <pc:docMk/>
-            <pc:sldMk cId="334425312" sldId="279"/>
-            <ac:spMk id="3" creationId="{189F6B65-E542-45FE-A205-3282FD9760ED}"/>
-          </ac:spMkLst>
-        </pc:spChg>
-        <pc:picChg chg="add mod ord">
-          <ac:chgData name="Malcolm Hayward" userId="fd045f5c-b77a-4191-aa2e-0c5f24668c72" providerId="ADAL" clId="{F2B84187-37ED-4459-971D-E4FC052BE502}" dt="2021-04-17T08:32:25.222" v="11875" actId="1076"/>
-          <ac:picMkLst>
-            <pc:docMk/>
-            <pc:sldMk cId="334425312" sldId="279"/>
-            <ac:picMk id="5" creationId="{C7D96507-FC5E-4741-ADD4-D447329D3933}"/>
-          </ac:picMkLst>
-        </pc:picChg>
-      </pc:sldChg>
-      <pc:sldChg chg="addSp delSp modSp new mod ord">
-        <pc:chgData name="Malcolm Hayward" userId="fd045f5c-b77a-4191-aa2e-0c5f24668c72" providerId="ADAL" clId="{F2B84187-37ED-4459-971D-E4FC052BE502}" dt="2021-04-17T08:27:54.261" v="11711" actId="1076"/>
-        <pc:sldMkLst>
-          <pc:docMk/>
-          <pc:sldMk cId="2855457371" sldId="280"/>
-        </pc:sldMkLst>
-        <pc:spChg chg="mod">
-          <ac:chgData name="Malcolm Hayward" userId="fd045f5c-b77a-4191-aa2e-0c5f24668c72" providerId="ADAL" clId="{F2B84187-37ED-4459-971D-E4FC052BE502}" dt="2021-03-29T03:45:55.335" v="5574" actId="20577"/>
-          <ac:spMkLst>
-            <pc:docMk/>
-            <pc:sldMk cId="2855457371" sldId="280"/>
-            <ac:spMk id="2" creationId="{29C07C8B-D26D-4536-9BBB-DE5DF8596AED}"/>
-          </ac:spMkLst>
-        </pc:spChg>
-        <pc:spChg chg="del">
-          <ac:chgData name="Malcolm Hayward" userId="fd045f5c-b77a-4191-aa2e-0c5f24668c72" providerId="ADAL" clId="{F2B84187-37ED-4459-971D-E4FC052BE502}" dt="2021-03-29T03:45:46.813" v="5539" actId="22"/>
-          <ac:spMkLst>
-            <pc:docMk/>
-            <pc:sldMk cId="2855457371" sldId="280"/>
-            <ac:spMk id="3" creationId="{7B38F789-044A-4187-B069-C4477766AF0B}"/>
-          </ac:spMkLst>
-        </pc:spChg>
-        <pc:spChg chg="add del mod">
-          <ac:chgData name="Malcolm Hayward" userId="fd045f5c-b77a-4191-aa2e-0c5f24668c72" providerId="ADAL" clId="{F2B84187-37ED-4459-971D-E4FC052BE502}" dt="2021-04-16T04:00:56.357" v="7925" actId="478"/>
-          <ac:spMkLst>
-            <pc:docMk/>
-            <pc:sldMk cId="2855457371" sldId="280"/>
-            <ac:spMk id="3" creationId="{E379FDDD-FF22-41CE-8D2E-0E96CC99FA43}"/>
-          </ac:spMkLst>
-        </pc:spChg>
-        <pc:spChg chg="add mod">
-          <ac:chgData name="Malcolm Hayward" userId="fd045f5c-b77a-4191-aa2e-0c5f24668c72" providerId="ADAL" clId="{F2B84187-37ED-4459-971D-E4FC052BE502}" dt="2021-04-17T08:27:54.261" v="11711" actId="1076"/>
-          <ac:spMkLst>
-            <pc:docMk/>
-            <pc:sldMk cId="2855457371" sldId="280"/>
-            <ac:spMk id="4" creationId="{242010A5-2A6D-4901-B056-3883936A3FD8}"/>
-          </ac:spMkLst>
-        </pc:spChg>
-        <pc:spChg chg="add del mod">
-          <ac:chgData name="Malcolm Hayward" userId="fd045f5c-b77a-4191-aa2e-0c5f24668c72" providerId="ADAL" clId="{F2B84187-37ED-4459-971D-E4FC052BE502}" dt="2021-04-16T04:01:19.203" v="7931" actId="478"/>
-          <ac:spMkLst>
-            <pc:docMk/>
-            <pc:sldMk cId="2855457371" sldId="280"/>
-            <ac:spMk id="6" creationId="{861B5EF8-E207-4B34-8B90-36E3E4780661}"/>
-          </ac:spMkLst>
-        </pc:spChg>
-        <pc:picChg chg="add mod ord">
-          <ac:chgData name="Malcolm Hayward" userId="fd045f5c-b77a-4191-aa2e-0c5f24668c72" providerId="ADAL" clId="{F2B84187-37ED-4459-971D-E4FC052BE502}" dt="2021-04-17T08:27:50.501" v="11710" actId="1076"/>
-          <ac:picMkLst>
-            <pc:docMk/>
-            <pc:sldMk cId="2855457371" sldId="280"/>
-            <ac:picMk id="5" creationId="{9B348F33-D554-47FF-BE6E-10FDB2B0E6E6}"/>
-          </ac:picMkLst>
-        </pc:picChg>
-      </pc:sldChg>
-      <pc:sldChg chg="addSp delSp modSp new mod">
-        <pc:chgData name="Malcolm Hayward" userId="fd045f5c-b77a-4191-aa2e-0c5f24668c72" providerId="ADAL" clId="{F2B84187-37ED-4459-971D-E4FC052BE502}" dt="2021-04-16T03:54:52.897" v="7679" actId="1076"/>
-        <pc:sldMkLst>
-          <pc:docMk/>
-          <pc:sldMk cId="312878233" sldId="281"/>
-        </pc:sldMkLst>
-        <pc:spChg chg="mod">
-          <ac:chgData name="Malcolm Hayward" userId="fd045f5c-b77a-4191-aa2e-0c5f24668c72" providerId="ADAL" clId="{F2B84187-37ED-4459-971D-E4FC052BE502}" dt="2021-03-29T04:27:53.084" v="6565" actId="120"/>
-          <ac:spMkLst>
-            <pc:docMk/>
-            <pc:sldMk cId="312878233" sldId="281"/>
-            <ac:spMk id="2" creationId="{936869A1-4263-48A9-8324-B372B976B56A}"/>
-          </ac:spMkLst>
-        </pc:spChg>
-        <pc:spChg chg="del">
-          <ac:chgData name="Malcolm Hayward" userId="fd045f5c-b77a-4191-aa2e-0c5f24668c72" providerId="ADAL" clId="{F2B84187-37ED-4459-971D-E4FC052BE502}" dt="2021-03-29T03:51:57.173" v="5593" actId="22"/>
-          <ac:spMkLst>
-            <pc:docMk/>
-            <pc:sldMk cId="312878233" sldId="281"/>
-            <ac:spMk id="3" creationId="{41CBB064-4BAC-42DE-932B-066491822591}"/>
-          </ac:spMkLst>
-        </pc:spChg>
-        <pc:spChg chg="add del mod">
-          <ac:chgData name="Malcolm Hayward" userId="fd045f5c-b77a-4191-aa2e-0c5f24668c72" providerId="ADAL" clId="{F2B84187-37ED-4459-971D-E4FC052BE502}" dt="2021-04-16T03:52:25.747" v="7642" actId="478"/>
-          <ac:spMkLst>
-            <pc:docMk/>
-            <pc:sldMk cId="312878233" sldId="281"/>
-            <ac:spMk id="4" creationId="{295DF3B3-240E-42E4-8E20-0648EB4C864C}"/>
-          </ac:spMkLst>
-        </pc:spChg>
-        <pc:spChg chg="add mod">
-          <ac:chgData name="Malcolm Hayward" userId="fd045f5c-b77a-4191-aa2e-0c5f24668c72" providerId="ADAL" clId="{F2B84187-37ED-4459-971D-E4FC052BE502}" dt="2021-04-16T03:54:51.745" v="7678" actId="1076"/>
-          <ac:spMkLst>
-            <pc:docMk/>
-            <pc:sldMk cId="312878233" sldId="281"/>
-            <ac:spMk id="8" creationId="{4A04850C-75F4-4C87-A217-AF238CFAC90B}"/>
-          </ac:spMkLst>
-        </pc:spChg>
-        <pc:spChg chg="add del mod">
-          <ac:chgData name="Malcolm Hayward" userId="fd045f5c-b77a-4191-aa2e-0c5f24668c72" providerId="ADAL" clId="{F2B84187-37ED-4459-971D-E4FC052BE502}" dt="2021-04-16T03:52:27.586" v="7643" actId="478"/>
-          <ac:spMkLst>
-            <pc:docMk/>
-            <pc:sldMk cId="312878233" sldId="281"/>
-            <ac:spMk id="9" creationId="{0BE7E352-EDFF-4BFE-B47D-8E6CD282B955}"/>
-          </ac:spMkLst>
-        </pc:spChg>
-        <pc:picChg chg="add del mod ord">
-          <ac:chgData name="Malcolm Hayward" userId="fd045f5c-b77a-4191-aa2e-0c5f24668c72" providerId="ADAL" clId="{F2B84187-37ED-4459-971D-E4FC052BE502}" dt="2021-04-16T03:52:21.091" v="7641" actId="478"/>
-          <ac:picMkLst>
-            <pc:docMk/>
-            <pc:sldMk cId="312878233" sldId="281"/>
-            <ac:picMk id="5" creationId="{4CD61613-8C65-473E-B257-2307673C3C60}"/>
-          </ac:picMkLst>
-        </pc:picChg>
-        <pc:picChg chg="add mod">
-          <ac:chgData name="Malcolm Hayward" userId="fd045f5c-b77a-4191-aa2e-0c5f24668c72" providerId="ADAL" clId="{F2B84187-37ED-4459-971D-E4FC052BE502}" dt="2021-04-16T03:54:52.897" v="7679" actId="1076"/>
-          <ac:picMkLst>
-            <pc:docMk/>
-            <pc:sldMk cId="312878233" sldId="281"/>
-            <ac:picMk id="7" creationId="{EEF6522E-BBC0-461E-BAF5-8B047F4F2184}"/>
-          </ac:picMkLst>
-        </pc:picChg>
-      </pc:sldChg>
-      <pc:sldChg chg="addSp delSp modSp new mod">
-        <pc:chgData name="Malcolm Hayward" userId="fd045f5c-b77a-4191-aa2e-0c5f24668c72" providerId="ADAL" clId="{F2B84187-37ED-4459-971D-E4FC052BE502}" dt="2021-04-17T08:35:14.028" v="12132" actId="14100"/>
-        <pc:sldMkLst>
-          <pc:docMk/>
-          <pc:sldMk cId="3626365319" sldId="282"/>
-        </pc:sldMkLst>
-        <pc:spChg chg="mod">
-          <ac:chgData name="Malcolm Hayward" userId="fd045f5c-b77a-4191-aa2e-0c5f24668c72" providerId="ADAL" clId="{F2B84187-37ED-4459-971D-E4FC052BE502}" dt="2021-03-29T03:53:40.183" v="5650" actId="20577"/>
-          <ac:spMkLst>
-            <pc:docMk/>
-            <pc:sldMk cId="3626365319" sldId="282"/>
-            <ac:spMk id="2" creationId="{74E2A155-C11A-41DB-B80D-5633F14051EC}"/>
-          </ac:spMkLst>
-        </pc:spChg>
-        <pc:spChg chg="del">
-          <ac:chgData name="Malcolm Hayward" userId="fd045f5c-b77a-4191-aa2e-0c5f24668c72" providerId="ADAL" clId="{F2B84187-37ED-4459-971D-E4FC052BE502}" dt="2021-03-29T03:54:34.404" v="5651" actId="22"/>
-          <ac:spMkLst>
-            <pc:docMk/>
-            <pc:sldMk cId="3626365319" sldId="282"/>
-            <ac:spMk id="3" creationId="{3FE4F222-E677-4A0D-8A1D-76A526E4380F}"/>
-          </ac:spMkLst>
-        </pc:spChg>
-        <pc:spChg chg="add mod">
-          <ac:chgData name="Malcolm Hayward" userId="fd045f5c-b77a-4191-aa2e-0c5f24668c72" providerId="ADAL" clId="{F2B84187-37ED-4459-971D-E4FC052BE502}" dt="2021-04-17T08:35:06.561" v="12130" actId="1076"/>
-          <ac:spMkLst>
-            <pc:docMk/>
-            <pc:sldMk cId="3626365319" sldId="282"/>
-            <ac:spMk id="3" creationId="{41DBD695-2A86-4ADF-A197-2BAD045E2782}"/>
-          </ac:spMkLst>
-        </pc:spChg>
-        <pc:picChg chg="add mod ord">
-          <ac:chgData name="Malcolm Hayward" userId="fd045f5c-b77a-4191-aa2e-0c5f24668c72" providerId="ADAL" clId="{F2B84187-37ED-4459-971D-E4FC052BE502}" dt="2021-04-17T08:35:14.028" v="12132" actId="14100"/>
-          <ac:picMkLst>
-            <pc:docMk/>
-            <pc:sldMk cId="3626365319" sldId="282"/>
-            <ac:picMk id="5" creationId="{33048E9C-E1E5-4400-939F-B1A3CD704484}"/>
-          </ac:picMkLst>
-        </pc:picChg>
-      </pc:sldChg>
-      <pc:sldChg chg="addSp delSp modSp new mod ord">
-        <pc:chgData name="Malcolm Hayward" userId="fd045f5c-b77a-4191-aa2e-0c5f24668c72" providerId="ADAL" clId="{F2B84187-37ED-4459-971D-E4FC052BE502}" dt="2021-04-17T08:18:05.620" v="11388" actId="14100"/>
-        <pc:sldMkLst>
-          <pc:docMk/>
-          <pc:sldMk cId="4007241215" sldId="283"/>
-        </pc:sldMkLst>
-        <pc:spChg chg="mod">
-          <ac:chgData name="Malcolm Hayward" userId="fd045f5c-b77a-4191-aa2e-0c5f24668c72" providerId="ADAL" clId="{F2B84187-37ED-4459-971D-E4FC052BE502}" dt="2021-03-29T03:57:36.478" v="5726" actId="20577"/>
-          <ac:spMkLst>
-            <pc:docMk/>
-            <pc:sldMk cId="4007241215" sldId="283"/>
-            <ac:spMk id="2" creationId="{02574D71-F0B2-4270-AA58-D42F39D7BC63}"/>
-          </ac:spMkLst>
-        </pc:spChg>
-        <pc:spChg chg="del mod">
-          <ac:chgData name="Malcolm Hayward" userId="fd045f5c-b77a-4191-aa2e-0c5f24668c72" providerId="ADAL" clId="{F2B84187-37ED-4459-971D-E4FC052BE502}" dt="2021-03-29T13:53:44.978" v="6988" actId="22"/>
-          <ac:spMkLst>
-            <pc:docMk/>
-            <pc:sldMk cId="4007241215" sldId="283"/>
-            <ac:spMk id="3" creationId="{9EF77FD0-93B8-4186-B68E-1F6310B3428C}"/>
-          </ac:spMkLst>
-        </pc:spChg>
-        <pc:picChg chg="add mod ord">
-          <ac:chgData name="Malcolm Hayward" userId="fd045f5c-b77a-4191-aa2e-0c5f24668c72" providerId="ADAL" clId="{F2B84187-37ED-4459-971D-E4FC052BE502}" dt="2021-04-17T08:18:05.620" v="11388" actId="14100"/>
-          <ac:picMkLst>
-            <pc:docMk/>
-            <pc:sldMk cId="4007241215" sldId="283"/>
-            <ac:picMk id="5" creationId="{642CC9D8-4285-4B46-9F62-EC6DBC4A32CF}"/>
-          </ac:picMkLst>
-        </pc:picChg>
-      </pc:sldChg>
-      <pc:sldChg chg="addSp delSp modSp new mod ord">
-        <pc:chgData name="Malcolm Hayward" userId="fd045f5c-b77a-4191-aa2e-0c5f24668c72" providerId="ADAL" clId="{F2B84187-37ED-4459-971D-E4FC052BE502}" dt="2021-04-17T08:24:30.341" v="11559" actId="1076"/>
-        <pc:sldMkLst>
-          <pc:docMk/>
-          <pc:sldMk cId="3159775641" sldId="284"/>
-        </pc:sldMkLst>
-        <pc:spChg chg="mod">
-          <ac:chgData name="Malcolm Hayward" userId="fd045f5c-b77a-4191-aa2e-0c5f24668c72" providerId="ADAL" clId="{F2B84187-37ED-4459-971D-E4FC052BE502}" dt="2021-03-29T04:30:28.560" v="6602" actId="20577"/>
-          <ac:spMkLst>
-            <pc:docMk/>
-            <pc:sldMk cId="3159775641" sldId="284"/>
-            <ac:spMk id="2" creationId="{1BD8FAD5-D659-4DF1-A682-29D8619E2BED}"/>
-          </ac:spMkLst>
-        </pc:spChg>
-        <pc:spChg chg="add mod">
-          <ac:chgData name="Malcolm Hayward" userId="fd045f5c-b77a-4191-aa2e-0c5f24668c72" providerId="ADAL" clId="{F2B84187-37ED-4459-971D-E4FC052BE502}" dt="2021-04-17T08:23:33.429" v="11457" actId="20577"/>
-          <ac:spMkLst>
-            <pc:docMk/>
-            <pc:sldMk cId="3159775641" sldId="284"/>
-            <ac:spMk id="3" creationId="{892BD556-80CC-45AA-AD59-41E155BB8CAB}"/>
-          </ac:spMkLst>
-        </pc:spChg>
-        <pc:spChg chg="del">
-          <ac:chgData name="Malcolm Hayward" userId="fd045f5c-b77a-4191-aa2e-0c5f24668c72" providerId="ADAL" clId="{F2B84187-37ED-4459-971D-E4FC052BE502}" dt="2021-03-30T20:18:47.944" v="7035" actId="22"/>
-          <ac:spMkLst>
-            <pc:docMk/>
-            <pc:sldMk cId="3159775641" sldId="284"/>
-            <ac:spMk id="3" creationId="{D43C9CC2-2FB9-4A6B-BF3C-FFD68358A30E}"/>
-          </ac:spMkLst>
-        </pc:spChg>
-        <pc:spChg chg="add mod">
-          <ac:chgData name="Malcolm Hayward" userId="fd045f5c-b77a-4191-aa2e-0c5f24668c72" providerId="ADAL" clId="{F2B84187-37ED-4459-971D-E4FC052BE502}" dt="2021-04-17T08:24:30.341" v="11559" actId="1076"/>
-          <ac:spMkLst>
-            <pc:docMk/>
-            <pc:sldMk cId="3159775641" sldId="284"/>
-            <ac:spMk id="4" creationId="{4A4BD6FE-0D87-41F1-823E-F8688BAFDEC5}"/>
-          </ac:spMkLst>
-        </pc:spChg>
-        <pc:spChg chg="add del mod">
-          <ac:chgData name="Malcolm Hayward" userId="fd045f5c-b77a-4191-aa2e-0c5f24668c72" providerId="ADAL" clId="{F2B84187-37ED-4459-971D-E4FC052BE502}" dt="2021-03-30T20:51:19.326" v="7286" actId="22"/>
-          <ac:spMkLst>
-            <pc:docMk/>
-            <pc:sldMk cId="3159775641" sldId="284"/>
-            <ac:spMk id="4" creationId="{AC43D15D-148B-4EE1-8958-9DA2CF3A928D}"/>
-          </ac:spMkLst>
-        </pc:spChg>
-        <pc:picChg chg="add del mod ord">
-          <ac:chgData name="Malcolm Hayward" userId="fd045f5c-b77a-4191-aa2e-0c5f24668c72" providerId="ADAL" clId="{F2B84187-37ED-4459-971D-E4FC052BE502}" dt="2021-03-30T20:50:41.760" v="7285" actId="478"/>
-          <ac:picMkLst>
-            <pc:docMk/>
-            <pc:sldMk cId="3159775641" sldId="284"/>
-            <ac:picMk id="5" creationId="{14E64031-7814-442F-A0AC-521B667BF4E8}"/>
-          </ac:picMkLst>
-        </pc:picChg>
-        <pc:picChg chg="add mod ord">
-          <ac:chgData name="Malcolm Hayward" userId="fd045f5c-b77a-4191-aa2e-0c5f24668c72" providerId="ADAL" clId="{F2B84187-37ED-4459-971D-E4FC052BE502}" dt="2021-04-17T08:24:27.520" v="11558" actId="1076"/>
-          <ac:picMkLst>
-            <pc:docMk/>
-            <pc:sldMk cId="3159775641" sldId="284"/>
-            <ac:picMk id="7" creationId="{7DB1626A-A340-48AD-B01A-F4165DC223FA}"/>
-          </ac:picMkLst>
-        </pc:picChg>
-      </pc:sldChg>
-      <pc:sldChg chg="del">
-        <pc:chgData name="Malcolm Hayward" userId="fd045f5c-b77a-4191-aa2e-0c5f24668c72" providerId="ADAL" clId="{F2B84187-37ED-4459-971D-E4FC052BE502}" dt="2021-03-30T20:42:49.483" v="7172" actId="2696"/>
-        <pc:sldMkLst>
-          <pc:docMk/>
-          <pc:sldMk cId="3033189543" sldId="285"/>
-        </pc:sldMkLst>
-      </pc:sldChg>
-      <pc:sldChg chg="modSp mod">
-        <pc:chgData name="Malcolm Hayward" userId="fd045f5c-b77a-4191-aa2e-0c5f24668c72" providerId="ADAL" clId="{F2B84187-37ED-4459-971D-E4FC052BE502}" dt="2021-04-17T08:18:27.636" v="11389" actId="14100"/>
-        <pc:sldMkLst>
-          <pc:docMk/>
-          <pc:sldMk cId="1300467158" sldId="286"/>
-        </pc:sldMkLst>
-        <pc:picChg chg="mod">
-          <ac:chgData name="Malcolm Hayward" userId="fd045f5c-b77a-4191-aa2e-0c5f24668c72" providerId="ADAL" clId="{F2B84187-37ED-4459-971D-E4FC052BE502}" dt="2021-04-17T08:18:27.636" v="11389" actId="14100"/>
-          <ac:picMkLst>
-            <pc:docMk/>
-            <pc:sldMk cId="1300467158" sldId="286"/>
-            <ac:picMk id="5" creationId="{4638485C-F2C5-4C31-A95B-28FBBDA2BD20}"/>
-          </ac:picMkLst>
-        </pc:picChg>
-      </pc:sldChg>
-      <pc:sldChg chg="modSp mod">
-        <pc:chgData name="Malcolm Hayward" userId="fd045f5c-b77a-4191-aa2e-0c5f24668c72" providerId="ADAL" clId="{F2B84187-37ED-4459-971D-E4FC052BE502}" dt="2021-04-16T06:11:53.691" v="9964" actId="14100"/>
-        <pc:sldMkLst>
-          <pc:docMk/>
-          <pc:sldMk cId="1827431044" sldId="287"/>
-        </pc:sldMkLst>
-        <pc:spChg chg="mod">
-          <ac:chgData name="Malcolm Hayward" userId="fd045f5c-b77a-4191-aa2e-0c5f24668c72" providerId="ADAL" clId="{F2B84187-37ED-4459-971D-E4FC052BE502}" dt="2021-04-12T14:52:36.435" v="7627" actId="20577"/>
-          <ac:spMkLst>
-            <pc:docMk/>
-            <pc:sldMk cId="1827431044" sldId="287"/>
-            <ac:spMk id="2" creationId="{03E818AA-76A1-4237-8749-6DAC56FD30E3}"/>
-          </ac:spMkLst>
-        </pc:spChg>
-        <pc:picChg chg="mod">
-          <ac:chgData name="Malcolm Hayward" userId="fd045f5c-b77a-4191-aa2e-0c5f24668c72" providerId="ADAL" clId="{F2B84187-37ED-4459-971D-E4FC052BE502}" dt="2021-04-16T06:11:53.691" v="9964" actId="14100"/>
-          <ac:picMkLst>
-            <pc:docMk/>
-            <pc:sldMk cId="1827431044" sldId="287"/>
-            <ac:picMk id="5" creationId="{A3FE2B94-FEFF-4641-ADC0-028062380727}"/>
-          </ac:picMkLst>
-        </pc:picChg>
-      </pc:sldChg>
-      <pc:sldChg chg="addSp delSp modSp new mod">
-        <pc:chgData name="Malcolm Hayward" userId="fd045f5c-b77a-4191-aa2e-0c5f24668c72" providerId="ADAL" clId="{F2B84187-37ED-4459-971D-E4FC052BE502}" dt="2021-04-17T08:24:56.478" v="11607" actId="1076"/>
-        <pc:sldMkLst>
-          <pc:docMk/>
-          <pc:sldMk cId="1943220090" sldId="288"/>
-        </pc:sldMkLst>
-        <pc:spChg chg="mod">
-          <ac:chgData name="Malcolm Hayward" userId="fd045f5c-b77a-4191-aa2e-0c5f24668c72" providerId="ADAL" clId="{F2B84187-37ED-4459-971D-E4FC052BE502}" dt="2021-04-17T08:24:49.920" v="11606" actId="20577"/>
-          <ac:spMkLst>
-            <pc:docMk/>
-            <pc:sldMk cId="1943220090" sldId="288"/>
-            <ac:spMk id="2" creationId="{2B32DB9A-A8F7-403D-AC75-3E7187DEF4C8}"/>
-          </ac:spMkLst>
-        </pc:spChg>
-        <pc:spChg chg="del">
-          <ac:chgData name="Malcolm Hayward" userId="fd045f5c-b77a-4191-aa2e-0c5f24668c72" providerId="ADAL" clId="{F2B84187-37ED-4459-971D-E4FC052BE502}" dt="2021-03-30T20:38:25.225" v="7075" actId="22"/>
-          <ac:spMkLst>
-            <pc:docMk/>
-            <pc:sldMk cId="1943220090" sldId="288"/>
-            <ac:spMk id="3" creationId="{F9EF2CFA-A0E7-4E0C-9132-104AA5CA798F}"/>
-          </ac:spMkLst>
-        </pc:spChg>
-        <pc:picChg chg="add mod ord">
-          <ac:chgData name="Malcolm Hayward" userId="fd045f5c-b77a-4191-aa2e-0c5f24668c72" providerId="ADAL" clId="{F2B84187-37ED-4459-971D-E4FC052BE502}" dt="2021-04-17T08:24:56.478" v="11607" actId="1076"/>
-          <ac:picMkLst>
-            <pc:docMk/>
-            <pc:sldMk cId="1943220090" sldId="288"/>
-            <ac:picMk id="5" creationId="{4B30F89A-9F93-43D6-B426-E7C95664376A}"/>
-          </ac:picMkLst>
-        </pc:picChg>
-      </pc:sldChg>
-      <pc:sldChg chg="modSp mod">
-        <pc:chgData name="Malcolm Hayward" userId="fd045f5c-b77a-4191-aa2e-0c5f24668c72" providerId="ADAL" clId="{F2B84187-37ED-4459-971D-E4FC052BE502}" dt="2021-04-17T07:36:06.144" v="11025" actId="20577"/>
-        <pc:sldMkLst>
-          <pc:docMk/>
-          <pc:sldMk cId="3329615997" sldId="289"/>
-        </pc:sldMkLst>
-        <pc:spChg chg="mod">
-          <ac:chgData name="Malcolm Hayward" userId="fd045f5c-b77a-4191-aa2e-0c5f24668c72" providerId="ADAL" clId="{F2B84187-37ED-4459-971D-E4FC052BE502}" dt="2021-04-17T07:36:06.144" v="11025" actId="20577"/>
-          <ac:spMkLst>
-            <pc:docMk/>
-            <pc:sldMk cId="3329615997" sldId="289"/>
-            <ac:spMk id="2" creationId="{C549C308-6FBC-42AB-ADEA-73F8A238A190}"/>
-          </ac:spMkLst>
-        </pc:spChg>
-        <pc:spChg chg="mod">
-          <ac:chgData name="Malcolm Hayward" userId="fd045f5c-b77a-4191-aa2e-0c5f24668c72" providerId="ADAL" clId="{F2B84187-37ED-4459-971D-E4FC052BE502}" dt="2021-04-17T05:43:33.337" v="10164" actId="20577"/>
-          <ac:spMkLst>
-            <pc:docMk/>
-            <pc:sldMk cId="3329615997" sldId="289"/>
-            <ac:spMk id="3" creationId="{FBACFB0F-0E9A-48D4-97A7-27723CDED9AC}"/>
-          </ac:spMkLst>
-        </pc:spChg>
-      </pc:sldChg>
-      <pc:sldChg chg="addSp delSp modSp new mod">
-        <pc:chgData name="Malcolm Hayward" userId="fd045f5c-b77a-4191-aa2e-0c5f24668c72" providerId="ADAL" clId="{F2B84187-37ED-4459-971D-E4FC052BE502}" dt="2021-04-16T03:55:02.307" v="7681" actId="14100"/>
-        <pc:sldMkLst>
-          <pc:docMk/>
-          <pc:sldMk cId="3818593411" sldId="290"/>
-        </pc:sldMkLst>
-        <pc:spChg chg="mod">
-          <ac:chgData name="Malcolm Hayward" userId="fd045f5c-b77a-4191-aa2e-0c5f24668c72" providerId="ADAL" clId="{F2B84187-37ED-4459-971D-E4FC052BE502}" dt="2021-04-16T03:52:54.909" v="7650"/>
-          <ac:spMkLst>
-            <pc:docMk/>
-            <pc:sldMk cId="3818593411" sldId="290"/>
-            <ac:spMk id="2" creationId="{1881E8A8-25A2-45AF-8239-21A81C633A08}"/>
-          </ac:spMkLst>
-        </pc:spChg>
-        <pc:spChg chg="del">
-          <ac:chgData name="Malcolm Hayward" userId="fd045f5c-b77a-4191-aa2e-0c5f24668c72" providerId="ADAL" clId="{F2B84187-37ED-4459-971D-E4FC052BE502}" dt="2021-04-16T03:52:05.893" v="7635"/>
-          <ac:spMkLst>
-            <pc:docMk/>
-            <pc:sldMk cId="3818593411" sldId="290"/>
-            <ac:spMk id="3" creationId="{43B78EFC-D879-42B4-A821-85D0D3BE718D}"/>
-          </ac:spMkLst>
-        </pc:spChg>
-        <pc:spChg chg="add mod">
-          <ac:chgData name="Malcolm Hayward" userId="fd045f5c-b77a-4191-aa2e-0c5f24668c72" providerId="ADAL" clId="{F2B84187-37ED-4459-971D-E4FC052BE502}" dt="2021-04-16T03:55:00.488" v="7680" actId="1076"/>
-          <ac:spMkLst>
-            <pc:docMk/>
-            <pc:sldMk cId="3818593411" sldId="290"/>
-            <ac:spMk id="5" creationId="{418DAA15-6F0C-4684-8345-34967CD6EA50}"/>
-          </ac:spMkLst>
-        </pc:spChg>
-        <pc:picChg chg="add mod">
-          <ac:chgData name="Malcolm Hayward" userId="fd045f5c-b77a-4191-aa2e-0c5f24668c72" providerId="ADAL" clId="{F2B84187-37ED-4459-971D-E4FC052BE502}" dt="2021-04-16T03:55:02.307" v="7681" actId="14100"/>
-          <ac:picMkLst>
-            <pc:docMk/>
-            <pc:sldMk cId="3818593411" sldId="290"/>
-            <ac:picMk id="4" creationId="{FD3413AE-BC36-47EF-B157-8D4DBFFE9058}"/>
-          </ac:picMkLst>
-        </pc:picChg>
-      </pc:sldChg>
-      <pc:sldChg chg="modSp new mod">
-        <pc:chgData name="Malcolm Hayward" userId="fd045f5c-b77a-4191-aa2e-0c5f24668c72" providerId="ADAL" clId="{F2B84187-37ED-4459-971D-E4FC052BE502}" dt="2021-04-16T04:39:54.126" v="8597" actId="20577"/>
-        <pc:sldMkLst>
-          <pc:docMk/>
-          <pc:sldMk cId="4225937240" sldId="291"/>
-        </pc:sldMkLst>
-        <pc:spChg chg="mod">
-          <ac:chgData name="Malcolm Hayward" userId="fd045f5c-b77a-4191-aa2e-0c5f24668c72" providerId="ADAL" clId="{F2B84187-37ED-4459-971D-E4FC052BE502}" dt="2021-04-16T04:30:57.730" v="8344" actId="20577"/>
-          <ac:spMkLst>
-            <pc:docMk/>
-            <pc:sldMk cId="4225937240" sldId="291"/>
-            <ac:spMk id="2" creationId="{4EF2DC42-2162-4C4C-B946-7CA5791A0E11}"/>
-          </ac:spMkLst>
-        </pc:spChg>
-        <pc:spChg chg="mod">
-          <ac:chgData name="Malcolm Hayward" userId="fd045f5c-b77a-4191-aa2e-0c5f24668c72" providerId="ADAL" clId="{F2B84187-37ED-4459-971D-E4FC052BE502}" dt="2021-04-16T04:39:54.126" v="8597" actId="20577"/>
-          <ac:spMkLst>
-            <pc:docMk/>
-            <pc:sldMk cId="4225937240" sldId="291"/>
-            <ac:spMk id="3" creationId="{10CA2D5F-B982-474D-9CEC-641A3EA41B7A}"/>
-          </ac:spMkLst>
-        </pc:spChg>
-      </pc:sldChg>
-      <pc:sldChg chg="modSp new mod">
-        <pc:chgData name="Malcolm Hayward" userId="fd045f5c-b77a-4191-aa2e-0c5f24668c72" providerId="ADAL" clId="{F2B84187-37ED-4459-971D-E4FC052BE502}" dt="2021-04-16T05:01:40.385" v="9831" actId="5793"/>
-        <pc:sldMkLst>
-          <pc:docMk/>
-          <pc:sldMk cId="3162552374" sldId="292"/>
-        </pc:sldMkLst>
-        <pc:spChg chg="mod">
-          <ac:chgData name="Malcolm Hayward" userId="fd045f5c-b77a-4191-aa2e-0c5f24668c72" providerId="ADAL" clId="{F2B84187-37ED-4459-971D-E4FC052BE502}" dt="2021-04-16T04:44:32.509" v="8641" actId="20577"/>
-          <ac:spMkLst>
-            <pc:docMk/>
-            <pc:sldMk cId="3162552374" sldId="292"/>
-            <ac:spMk id="2" creationId="{45E0CBCD-C010-4DF3-937C-02B8731F050F}"/>
-          </ac:spMkLst>
-        </pc:spChg>
-        <pc:spChg chg="mod">
-          <ac:chgData name="Malcolm Hayward" userId="fd045f5c-b77a-4191-aa2e-0c5f24668c72" providerId="ADAL" clId="{F2B84187-37ED-4459-971D-E4FC052BE502}" dt="2021-04-16T05:01:40.385" v="9831" actId="5793"/>
-          <ac:spMkLst>
-            <pc:docMk/>
-            <pc:sldMk cId="3162552374" sldId="292"/>
-            <ac:spMk id="3" creationId="{7EE42915-297B-4033-B516-4B845B3BAAA3}"/>
-          </ac:spMkLst>
-        </pc:spChg>
-      </pc:sldChg>
-      <pc:sldChg chg="addSp delSp modSp new mod">
-        <pc:chgData name="Malcolm Hayward" userId="fd045f5c-b77a-4191-aa2e-0c5f24668c72" providerId="ADAL" clId="{F2B84187-37ED-4459-971D-E4FC052BE502}" dt="2021-04-16T04:53:45.648" v="9067" actId="20577"/>
-        <pc:sldMkLst>
-          <pc:docMk/>
-          <pc:sldMk cId="1627882353" sldId="293"/>
-        </pc:sldMkLst>
-        <pc:spChg chg="mod">
-          <ac:chgData name="Malcolm Hayward" userId="fd045f5c-b77a-4191-aa2e-0c5f24668c72" providerId="ADAL" clId="{F2B84187-37ED-4459-971D-E4FC052BE502}" dt="2021-04-16T04:53:45.648" v="9067" actId="20577"/>
-          <ac:spMkLst>
-            <pc:docMk/>
-            <pc:sldMk cId="1627882353" sldId="293"/>
-            <ac:spMk id="2" creationId="{34FC2CF9-9DBF-4289-95B4-D724F130E63F}"/>
-          </ac:spMkLst>
-        </pc:spChg>
-        <pc:spChg chg="del">
-          <ac:chgData name="Malcolm Hayward" userId="fd045f5c-b77a-4191-aa2e-0c5f24668c72" providerId="ADAL" clId="{F2B84187-37ED-4459-971D-E4FC052BE502}" dt="2021-04-16T04:53:09.440" v="8989" actId="22"/>
-          <ac:spMkLst>
-            <pc:docMk/>
-            <pc:sldMk cId="1627882353" sldId="293"/>
-            <ac:spMk id="3" creationId="{F32D27E9-878F-42D2-8E88-0A9FC6A7FCCB}"/>
-          </ac:spMkLst>
-        </pc:spChg>
-        <pc:picChg chg="add mod ord">
-          <ac:chgData name="Malcolm Hayward" userId="fd045f5c-b77a-4191-aa2e-0c5f24668c72" providerId="ADAL" clId="{F2B84187-37ED-4459-971D-E4FC052BE502}" dt="2021-04-16T04:53:30.877" v="9000" actId="14100"/>
-          <ac:picMkLst>
-            <pc:docMk/>
-            <pc:sldMk cId="1627882353" sldId="293"/>
-            <ac:picMk id="5" creationId="{3EFD3DFB-E647-4E4A-AEFE-39FD2CF323E5}"/>
-          </ac:picMkLst>
-        </pc:picChg>
-      </pc:sldChg>
-      <pc:sldChg chg="modSp new mod addCm modCm">
-        <pc:chgData name="Malcolm Hayward" userId="fd045f5c-b77a-4191-aa2e-0c5f24668c72" providerId="ADAL" clId="{F2B84187-37ED-4459-971D-E4FC052BE502}" dt="2021-04-23T23:42:48.079" v="12531" actId="20577"/>
-        <pc:sldMkLst>
-          <pc:docMk/>
-          <pc:sldMk cId="379489396" sldId="294"/>
-        </pc:sldMkLst>
-        <pc:spChg chg="mod">
-          <ac:chgData name="Malcolm Hayward" userId="fd045f5c-b77a-4191-aa2e-0c5f24668c72" providerId="ADAL" clId="{F2B84187-37ED-4459-971D-E4FC052BE502}" dt="2021-04-17T08:39:41.396" v="12140" actId="20577"/>
-          <ac:spMkLst>
-            <pc:docMk/>
-            <pc:sldMk cId="379489396" sldId="294"/>
-            <ac:spMk id="2" creationId="{76611BE4-E132-440C-B0E7-390037577EC0}"/>
-          </ac:spMkLst>
-        </pc:spChg>
-        <pc:spChg chg="mod">
-          <ac:chgData name="Malcolm Hayward" userId="fd045f5c-b77a-4191-aa2e-0c5f24668c72" providerId="ADAL" clId="{F2B84187-37ED-4459-971D-E4FC052BE502}" dt="2021-04-23T23:42:48.079" v="12531" actId="20577"/>
-          <ac:spMkLst>
-            <pc:docMk/>
-            <pc:sldMk cId="379489396" sldId="294"/>
-            <ac:spMk id="3" creationId="{92BC5D98-647B-42E8-8F8C-27308D61790E}"/>
-          </ac:spMkLst>
-        </pc:spChg>
-      </pc:sldChg>
-      <pc:sldChg chg="modSp new mod">
-        <pc:chgData name="Malcolm Hayward" userId="fd045f5c-b77a-4191-aa2e-0c5f24668c72" providerId="ADAL" clId="{F2B84187-37ED-4459-971D-E4FC052BE502}" dt="2021-04-19T13:15:34.603" v="12202" actId="20577"/>
-        <pc:sldMkLst>
-          <pc:docMk/>
-          <pc:sldMk cId="4210512842" sldId="295"/>
-        </pc:sldMkLst>
-        <pc:spChg chg="mod">
-          <ac:chgData name="Malcolm Hayward" userId="fd045f5c-b77a-4191-aa2e-0c5f24668c72" providerId="ADAL" clId="{F2B84187-37ED-4459-971D-E4FC052BE502}" dt="2021-04-17T07:38:18.468" v="11265" actId="20577"/>
-          <ac:spMkLst>
-            <pc:docMk/>
-            <pc:sldMk cId="4210512842" sldId="295"/>
-            <ac:spMk id="2" creationId="{CE1305A4-E685-4446-93A4-C74617E621BE}"/>
-          </ac:spMkLst>
-        </pc:spChg>
-        <pc:spChg chg="mod">
-          <ac:chgData name="Malcolm Hayward" userId="fd045f5c-b77a-4191-aa2e-0c5f24668c72" providerId="ADAL" clId="{F2B84187-37ED-4459-971D-E4FC052BE502}" dt="2021-04-19T13:15:34.603" v="12202" actId="20577"/>
-          <ac:spMkLst>
-            <pc:docMk/>
-            <pc:sldMk cId="4210512842" sldId="295"/>
-            <ac:spMk id="3" creationId="{D217E6F4-051D-40AC-89C8-1EB66596D46B}"/>
-          </ac:spMkLst>
-        </pc:spChg>
-      </pc:sldChg>
-    </pc:docChg>
-  </pc:docChgLst>
-  <pc:docChgLst>
-    <pc:chgData name="Weifeng Xu" userId="e7aed605-a3dd-4d5a-a692-a87037af107b" providerId="ADAL" clId="{1F4F5B84-491D-43A0-805D-265CDB221584}"/>
-    <pc:docChg chg="undo custSel addSld modSld">
-      <pc:chgData name="Weifeng Xu" userId="e7aed605-a3dd-4d5a-a692-a87037af107b" providerId="ADAL" clId="{1F4F5B84-491D-43A0-805D-265CDB221584}" dt="2021-06-25T18:57:40.790" v="1203" actId="20577"/>
-      <pc:docMkLst>
-        <pc:docMk/>
-      </pc:docMkLst>
-      <pc:sldChg chg="modSp mod">
-        <pc:chgData name="Weifeng Xu" userId="e7aed605-a3dd-4d5a-a692-a87037af107b" providerId="ADAL" clId="{1F4F5B84-491D-43A0-805D-265CDB221584}" dt="2021-06-23T12:29:00.335" v="351" actId="20577"/>
-        <pc:sldMkLst>
-          <pc:docMk/>
-          <pc:sldMk cId="3994808847" sldId="256"/>
-        </pc:sldMkLst>
-        <pc:spChg chg="mod">
-          <ac:chgData name="Weifeng Xu" userId="e7aed605-a3dd-4d5a-a692-a87037af107b" providerId="ADAL" clId="{1F4F5B84-491D-43A0-805D-265CDB221584}" dt="2021-06-23T12:29:00.335" v="351" actId="20577"/>
-          <ac:spMkLst>
-            <pc:docMk/>
-            <pc:sldMk cId="3994808847" sldId="256"/>
-            <ac:spMk id="2" creationId="{70237326-DEB0-48BC-A677-FA9640B9C967}"/>
-          </ac:spMkLst>
-        </pc:spChg>
-      </pc:sldChg>
-      <pc:sldChg chg="addSp modSp mod">
-        <pc:chgData name="Weifeng Xu" userId="e7aed605-a3dd-4d5a-a692-a87037af107b" providerId="ADAL" clId="{1F4F5B84-491D-43A0-805D-265CDB221584}" dt="2021-06-22T14:30:40.798" v="184" actId="1076"/>
-        <pc:sldMkLst>
-          <pc:docMk/>
-          <pc:sldMk cId="330888168" sldId="258"/>
-        </pc:sldMkLst>
-        <pc:spChg chg="mod">
-          <ac:chgData name="Weifeng Xu" userId="e7aed605-a3dd-4d5a-a692-a87037af107b" providerId="ADAL" clId="{1F4F5B84-491D-43A0-805D-265CDB221584}" dt="2021-06-22T14:15:26.098" v="146" actId="6549"/>
-          <ac:spMkLst>
-            <pc:docMk/>
-            <pc:sldMk cId="330888168" sldId="258"/>
-            <ac:spMk id="2" creationId="{1D3B01B3-DBAD-4764-BF44-57D5C2C3E788}"/>
-          </ac:spMkLst>
-        </pc:spChg>
-        <pc:spChg chg="add mod">
-          <ac:chgData name="Weifeng Xu" userId="e7aed605-a3dd-4d5a-a692-a87037af107b" providerId="ADAL" clId="{1F4F5B84-491D-43A0-805D-265CDB221584}" dt="2021-06-22T14:30:40.798" v="184" actId="1076"/>
-          <ac:spMkLst>
-            <pc:docMk/>
-            <pc:sldMk cId="330888168" sldId="258"/>
-            <ac:spMk id="3" creationId="{069C2D5A-DC52-4846-84FA-BA354714EACC}"/>
-          </ac:spMkLst>
-        </pc:spChg>
-        <pc:picChg chg="mod">
-          <ac:chgData name="Weifeng Xu" userId="e7aed605-a3dd-4d5a-a692-a87037af107b" providerId="ADAL" clId="{1F4F5B84-491D-43A0-805D-265CDB221584}" dt="2021-06-22T14:30:38.848" v="183" actId="1076"/>
-          <ac:picMkLst>
-            <pc:docMk/>
-            <pc:sldMk cId="330888168" sldId="258"/>
-            <ac:picMk id="6" creationId="{B9289351-22B6-4B47-9EAA-52F38ADFF92F}"/>
-          </ac:picMkLst>
-        </pc:picChg>
-      </pc:sldChg>
-      <pc:sldChg chg="modSp mod">
-        <pc:chgData name="Weifeng Xu" userId="e7aed605-a3dd-4d5a-a692-a87037af107b" providerId="ADAL" clId="{1F4F5B84-491D-43A0-805D-265CDB221584}" dt="2021-06-22T15:51:56.161" v="323" actId="207"/>
-        <pc:sldMkLst>
-          <pc:docMk/>
-          <pc:sldMk cId="2554469295" sldId="260"/>
-        </pc:sldMkLst>
-        <pc:spChg chg="mod">
-          <ac:chgData name="Weifeng Xu" userId="e7aed605-a3dd-4d5a-a692-a87037af107b" providerId="ADAL" clId="{1F4F5B84-491D-43A0-805D-265CDB221584}" dt="2021-06-22T15:51:56.161" v="323" actId="207"/>
-          <ac:spMkLst>
-            <pc:docMk/>
-            <pc:sldMk cId="2554469295" sldId="260"/>
-            <ac:spMk id="3" creationId="{3BA30A2E-1BF0-49E4-80D5-BB47E80CBD3E}"/>
-          </ac:spMkLst>
-        </pc:spChg>
-      </pc:sldChg>
-      <pc:sldChg chg="modSp mod">
-        <pc:chgData name="Weifeng Xu" userId="e7aed605-a3dd-4d5a-a692-a87037af107b" providerId="ADAL" clId="{1F4F5B84-491D-43A0-805D-265CDB221584}" dt="2021-06-25T18:57:40.790" v="1203" actId="20577"/>
-        <pc:sldMkLst>
-          <pc:docMk/>
-          <pc:sldMk cId="1758211574" sldId="261"/>
-        </pc:sldMkLst>
-        <pc:spChg chg="mod">
-          <ac:chgData name="Weifeng Xu" userId="e7aed605-a3dd-4d5a-a692-a87037af107b" providerId="ADAL" clId="{1F4F5B84-491D-43A0-805D-265CDB221584}" dt="2021-06-25T18:57:40.790" v="1203" actId="20577"/>
-          <ac:spMkLst>
-            <pc:docMk/>
-            <pc:sldMk cId="1758211574" sldId="261"/>
-            <ac:spMk id="3" creationId="{689D8F08-8365-4E2C-BFB6-D1790294648E}"/>
-          </ac:spMkLst>
-        </pc:spChg>
-      </pc:sldChg>
-      <pc:sldChg chg="modSp mod">
-        <pc:chgData name="Weifeng Xu" userId="e7aed605-a3dd-4d5a-a692-a87037af107b" providerId="ADAL" clId="{1F4F5B84-491D-43A0-805D-265CDB221584}" dt="2021-06-22T15:24:55.645" v="233" actId="114"/>
-        <pc:sldMkLst>
-          <pc:docMk/>
-          <pc:sldMk cId="3257189420" sldId="273"/>
-        </pc:sldMkLst>
-        <pc:spChg chg="mod">
-          <ac:chgData name="Weifeng Xu" userId="e7aed605-a3dd-4d5a-a692-a87037af107b" providerId="ADAL" clId="{1F4F5B84-491D-43A0-805D-265CDB221584}" dt="2021-06-22T15:24:55.645" v="233" actId="114"/>
-          <ac:spMkLst>
-            <pc:docMk/>
-            <pc:sldMk cId="3257189420" sldId="273"/>
-            <ac:spMk id="2" creationId="{2FB4D46D-2B22-4B4D-804B-E8F7854B2E48}"/>
-          </ac:spMkLst>
-        </pc:spChg>
-        <pc:spChg chg="mod">
-          <ac:chgData name="Weifeng Xu" userId="e7aed605-a3dd-4d5a-a692-a87037af107b" providerId="ADAL" clId="{1F4F5B84-491D-43A0-805D-265CDB221584}" dt="2021-06-22T15:24:52.008" v="232" actId="114"/>
-          <ac:spMkLst>
-            <pc:docMk/>
-            <pc:sldMk cId="3257189420" sldId="273"/>
-            <ac:spMk id="3" creationId="{7BBDBB4A-588A-4008-B72F-87A2EC36E6FA}"/>
-          </ac:spMkLst>
-        </pc:spChg>
-      </pc:sldChg>
-      <pc:sldChg chg="modSp mod">
-        <pc:chgData name="Weifeng Xu" userId="e7aed605-a3dd-4d5a-a692-a87037af107b" providerId="ADAL" clId="{1F4F5B84-491D-43A0-805D-265CDB221584}" dt="2021-06-22T15:17:35.757" v="215" actId="114"/>
-        <pc:sldMkLst>
-          <pc:docMk/>
-          <pc:sldMk cId="2714755137" sldId="274"/>
-        </pc:sldMkLst>
-        <pc:spChg chg="mod">
-          <ac:chgData name="Weifeng Xu" userId="e7aed605-a3dd-4d5a-a692-a87037af107b" providerId="ADAL" clId="{1F4F5B84-491D-43A0-805D-265CDB221584}" dt="2021-06-22T15:17:35.757" v="215" actId="114"/>
-          <ac:spMkLst>
-            <pc:docMk/>
-            <pc:sldMk cId="2714755137" sldId="274"/>
-            <ac:spMk id="8" creationId="{504FEAC0-5C5A-4996-AC9E-813751E42B47}"/>
-          </ac:spMkLst>
-        </pc:spChg>
-      </pc:sldChg>
-      <pc:sldChg chg="modSp mod">
-        <pc:chgData name="Weifeng Xu" userId="e7aed605-a3dd-4d5a-a692-a87037af107b" providerId="ADAL" clId="{1F4F5B84-491D-43A0-805D-265CDB221584}" dt="2021-06-22T15:19:12.898" v="217" actId="114"/>
-        <pc:sldMkLst>
-          <pc:docMk/>
-          <pc:sldMk cId="1140682228" sldId="277"/>
-        </pc:sldMkLst>
-        <pc:spChg chg="mod">
-          <ac:chgData name="Weifeng Xu" userId="e7aed605-a3dd-4d5a-a692-a87037af107b" providerId="ADAL" clId="{1F4F5B84-491D-43A0-805D-265CDB221584}" dt="2021-06-22T15:19:12.898" v="217" actId="114"/>
-          <ac:spMkLst>
-            <pc:docMk/>
-            <pc:sldMk cId="1140682228" sldId="277"/>
-            <ac:spMk id="2" creationId="{03E37E4E-87BE-4A78-B4CF-4917FBBF32A2}"/>
-          </ac:spMkLst>
-        </pc:spChg>
-      </pc:sldChg>
-      <pc:sldChg chg="modSp mod">
-        <pc:chgData name="Weifeng Xu" userId="e7aed605-a3dd-4d5a-a692-a87037af107b" providerId="ADAL" clId="{1F4F5B84-491D-43A0-805D-265CDB221584}" dt="2021-06-22T15:41:23.425" v="256" actId="114"/>
-        <pc:sldMkLst>
-          <pc:docMk/>
-          <pc:sldMk cId="2238744396" sldId="278"/>
-        </pc:sldMkLst>
-        <pc:spChg chg="mod">
-          <ac:chgData name="Weifeng Xu" userId="e7aed605-a3dd-4d5a-a692-a87037af107b" providerId="ADAL" clId="{1F4F5B84-491D-43A0-805D-265CDB221584}" dt="2021-06-22T15:41:23.425" v="256" actId="114"/>
-          <ac:spMkLst>
-            <pc:docMk/>
-            <pc:sldMk cId="2238744396" sldId="278"/>
-            <ac:spMk id="2" creationId="{A27652C0-7A7F-4776-B286-472A3C2F0871}"/>
-          </ac:spMkLst>
-        </pc:spChg>
-      </pc:sldChg>
-      <pc:sldChg chg="modSp mod">
-        <pc:chgData name="Weifeng Xu" userId="e7aed605-a3dd-4d5a-a692-a87037af107b" providerId="ADAL" clId="{1F4F5B84-491D-43A0-805D-265CDB221584}" dt="2021-06-22T15:41:55.968" v="260" actId="114"/>
-        <pc:sldMkLst>
-          <pc:docMk/>
-          <pc:sldMk cId="334425312" sldId="279"/>
-        </pc:sldMkLst>
-        <pc:spChg chg="mod">
-          <ac:chgData name="Weifeng Xu" userId="e7aed605-a3dd-4d5a-a692-a87037af107b" providerId="ADAL" clId="{1F4F5B84-491D-43A0-805D-265CDB221584}" dt="2021-06-22T15:41:55.968" v="260" actId="114"/>
-          <ac:spMkLst>
-            <pc:docMk/>
-            <pc:sldMk cId="334425312" sldId="279"/>
-            <ac:spMk id="2" creationId="{B60B3F95-6244-43F7-B16C-198F20FD2102}"/>
-          </ac:spMkLst>
-        </pc:spChg>
-      </pc:sldChg>
-      <pc:sldChg chg="modSp mod">
-        <pc:chgData name="Weifeng Xu" userId="e7aed605-a3dd-4d5a-a692-a87037af107b" providerId="ADAL" clId="{1F4F5B84-491D-43A0-805D-265CDB221584}" dt="2021-06-22T15:40:01.900" v="252" actId="20577"/>
-        <pc:sldMkLst>
-          <pc:docMk/>
-          <pc:sldMk cId="2855457371" sldId="280"/>
-        </pc:sldMkLst>
-        <pc:spChg chg="mod">
-          <ac:chgData name="Weifeng Xu" userId="e7aed605-a3dd-4d5a-a692-a87037af107b" providerId="ADAL" clId="{1F4F5B84-491D-43A0-805D-265CDB221584}" dt="2021-06-22T15:40:01.900" v="252" actId="20577"/>
-          <ac:spMkLst>
-            <pc:docMk/>
-            <pc:sldMk cId="2855457371" sldId="280"/>
-            <ac:spMk id="4" creationId="{242010A5-2A6D-4901-B056-3883936A3FD8}"/>
-          </ac:spMkLst>
-        </pc:spChg>
-        <pc:picChg chg="mod modCrop">
-          <ac:chgData name="Weifeng Xu" userId="e7aed605-a3dd-4d5a-a692-a87037af107b" providerId="ADAL" clId="{1F4F5B84-491D-43A0-805D-265CDB221584}" dt="2021-06-22T15:38:04.164" v="234" actId="732"/>
-          <ac:picMkLst>
-            <pc:docMk/>
-            <pc:sldMk cId="2855457371" sldId="280"/>
-            <ac:picMk id="8" creationId="{BB1D64D1-035F-4688-9BBE-B70E84A25A72}"/>
-          </ac:picMkLst>
-        </pc:picChg>
-      </pc:sldChg>
-      <pc:sldChg chg="modSp mod">
-        <pc:chgData name="Weifeng Xu" userId="e7aed605-a3dd-4d5a-a692-a87037af107b" providerId="ADAL" clId="{1F4F5B84-491D-43A0-805D-265CDB221584}" dt="2021-06-22T15:46:06.518" v="268" actId="114"/>
-        <pc:sldMkLst>
-          <pc:docMk/>
-          <pc:sldMk cId="3626365319" sldId="282"/>
-        </pc:sldMkLst>
-        <pc:spChg chg="mod">
-          <ac:chgData name="Weifeng Xu" userId="e7aed605-a3dd-4d5a-a692-a87037af107b" providerId="ADAL" clId="{1F4F5B84-491D-43A0-805D-265CDB221584}" dt="2021-06-22T15:45:49.054" v="264" actId="114"/>
-          <ac:spMkLst>
-            <pc:docMk/>
-            <pc:sldMk cId="3626365319" sldId="282"/>
-            <ac:spMk id="2" creationId="{74E2A155-C11A-41DB-B80D-5633F14051EC}"/>
-          </ac:spMkLst>
-        </pc:spChg>
-        <pc:spChg chg="mod">
-          <ac:chgData name="Weifeng Xu" userId="e7aed605-a3dd-4d5a-a692-a87037af107b" providerId="ADAL" clId="{1F4F5B84-491D-43A0-805D-265CDB221584}" dt="2021-06-22T15:46:06.518" v="268" actId="114"/>
-          <ac:spMkLst>
-            <pc:docMk/>
-            <pc:sldMk cId="3626365319" sldId="282"/>
-            <ac:spMk id="3" creationId="{41DBD695-2A86-4ADF-A197-2BAD045E2782}"/>
-          </ac:spMkLst>
-        </pc:spChg>
-      </pc:sldChg>
-      <pc:sldChg chg="modSp mod">
-        <pc:chgData name="Weifeng Xu" userId="e7aed605-a3dd-4d5a-a692-a87037af107b" providerId="ADAL" clId="{1F4F5B84-491D-43A0-805D-265CDB221584}" dt="2021-06-22T13:22:33.103" v="113" actId="207"/>
-        <pc:sldMkLst>
-          <pc:docMk/>
-          <pc:sldMk cId="1827431044" sldId="287"/>
-        </pc:sldMkLst>
-        <pc:spChg chg="mod">
-          <ac:chgData name="Weifeng Xu" userId="e7aed605-a3dd-4d5a-a692-a87037af107b" providerId="ADAL" clId="{1F4F5B84-491D-43A0-805D-265CDB221584}" dt="2021-06-22T13:22:33.103" v="113" actId="207"/>
-          <ac:spMkLst>
-            <pc:docMk/>
-            <pc:sldMk cId="1827431044" sldId="287"/>
-            <ac:spMk id="2" creationId="{03E818AA-76A1-4237-8749-6DAC56FD30E3}"/>
-          </ac:spMkLst>
-        </pc:spChg>
-      </pc:sldChg>
-      <pc:sldChg chg="modNotesTx">
-        <pc:chgData name="Weifeng Xu" userId="e7aed605-a3dd-4d5a-a692-a87037af107b" providerId="ADAL" clId="{1F4F5B84-491D-43A0-805D-265CDB221584}" dt="2021-06-23T13:05:52.756" v="409"/>
-        <pc:sldMkLst>
-          <pc:docMk/>
-          <pc:sldMk cId="1943220090" sldId="288"/>
-        </pc:sldMkLst>
-      </pc:sldChg>
-      <pc:sldChg chg="modSp mod modNotesTx">
-        <pc:chgData name="Weifeng Xu" userId="e7aed605-a3dd-4d5a-a692-a87037af107b" providerId="ADAL" clId="{1F4F5B84-491D-43A0-805D-265CDB221584}" dt="2021-06-22T14:55:03.727" v="211" actId="114"/>
-        <pc:sldMkLst>
-          <pc:docMk/>
-          <pc:sldMk cId="3162552374" sldId="292"/>
-        </pc:sldMkLst>
-        <pc:spChg chg="mod">
-          <ac:chgData name="Weifeng Xu" userId="e7aed605-a3dd-4d5a-a692-a87037af107b" providerId="ADAL" clId="{1F4F5B84-491D-43A0-805D-265CDB221584}" dt="2021-06-22T13:21:59.791" v="111" actId="6549"/>
-          <ac:spMkLst>
-            <pc:docMk/>
-            <pc:sldMk cId="3162552374" sldId="292"/>
-            <ac:spMk id="2" creationId="{45E0CBCD-C010-4DF3-937C-02B8731F050F}"/>
-          </ac:spMkLst>
-        </pc:spChg>
-        <pc:spChg chg="mod">
-          <ac:chgData name="Weifeng Xu" userId="e7aed605-a3dd-4d5a-a692-a87037af107b" providerId="ADAL" clId="{1F4F5B84-491D-43A0-805D-265CDB221584}" dt="2021-06-22T14:55:03.727" v="211" actId="114"/>
-          <ac:spMkLst>
-            <pc:docMk/>
-            <pc:sldMk cId="3162552374" sldId="292"/>
-            <ac:spMk id="3" creationId="{7EE42915-297B-4033-B516-4B845B3BAAA3}"/>
-          </ac:spMkLst>
-        </pc:spChg>
-      </pc:sldChg>
-      <pc:sldChg chg="addSp modSp">
-        <pc:chgData name="Weifeng Xu" userId="e7aed605-a3dd-4d5a-a692-a87037af107b" providerId="ADAL" clId="{1F4F5B84-491D-43A0-805D-265CDB221584}" dt="2021-06-22T13:29:30.499" v="126" actId="1076"/>
-        <pc:sldMkLst>
-          <pc:docMk/>
-          <pc:sldMk cId="379489396" sldId="294"/>
-        </pc:sldMkLst>
-        <pc:picChg chg="add mod">
-          <ac:chgData name="Weifeng Xu" userId="e7aed605-a3dd-4d5a-a692-a87037af107b" providerId="ADAL" clId="{1F4F5B84-491D-43A0-805D-265CDB221584}" dt="2021-06-22T13:25:51.054" v="116" actId="1076"/>
-          <ac:picMkLst>
-            <pc:docMk/>
-            <pc:sldMk cId="379489396" sldId="294"/>
-            <ac:picMk id="1026" creationId="{6B2A3740-B731-4C7C-9164-6EFC58F43D8E}"/>
-          </ac:picMkLst>
-        </pc:picChg>
-        <pc:picChg chg="add mod">
-          <ac:chgData name="Weifeng Xu" userId="e7aed605-a3dd-4d5a-a692-a87037af107b" providerId="ADAL" clId="{1F4F5B84-491D-43A0-805D-265CDB221584}" dt="2021-06-22T13:26:15.291" v="122" actId="1076"/>
-          <ac:picMkLst>
-            <pc:docMk/>
-            <pc:sldMk cId="379489396" sldId="294"/>
-            <ac:picMk id="1028" creationId="{F3D6E8EE-1F95-40C8-A79F-703922B526ED}"/>
-          </ac:picMkLst>
-        </pc:picChg>
-        <pc:picChg chg="add mod">
-          <ac:chgData name="Weifeng Xu" userId="e7aed605-a3dd-4d5a-a692-a87037af107b" providerId="ADAL" clId="{1F4F5B84-491D-43A0-805D-265CDB221584}" dt="2021-06-22T13:29:30.499" v="126" actId="1076"/>
-          <ac:picMkLst>
-            <pc:docMk/>
-            <pc:sldMk cId="379489396" sldId="294"/>
-            <ac:picMk id="1030" creationId="{6DB7CDE2-F3FE-4A54-9FFD-1D57173DF431}"/>
-          </ac:picMkLst>
-        </pc:picChg>
-      </pc:sldChg>
-      <pc:sldChg chg="modSp mod">
-        <pc:chgData name="Weifeng Xu" userId="e7aed605-a3dd-4d5a-a692-a87037af107b" providerId="ADAL" clId="{1F4F5B84-491D-43A0-805D-265CDB221584}" dt="2021-06-22T13:53:14.272" v="133" actId="207"/>
-        <pc:sldMkLst>
-          <pc:docMk/>
-          <pc:sldMk cId="2866903223" sldId="296"/>
-        </pc:sldMkLst>
-        <pc:spChg chg="mod">
-          <ac:chgData name="Weifeng Xu" userId="e7aed605-a3dd-4d5a-a692-a87037af107b" providerId="ADAL" clId="{1F4F5B84-491D-43A0-805D-265CDB221584}" dt="2021-06-22T13:53:14.272" v="133" actId="207"/>
-          <ac:spMkLst>
-            <pc:docMk/>
-            <pc:sldMk cId="2866903223" sldId="296"/>
-            <ac:spMk id="3" creationId="{12EECF59-D087-4334-A3AD-C30FC1FC5222}"/>
-          </ac:spMkLst>
-        </pc:spChg>
-      </pc:sldChg>
-      <pc:sldChg chg="modSp mod">
-        <pc:chgData name="Weifeng Xu" userId="e7aed605-a3dd-4d5a-a692-a87037af107b" providerId="ADAL" clId="{1F4F5B84-491D-43A0-805D-265CDB221584}" dt="2021-06-24T21:48:05.784" v="1096" actId="20577"/>
-        <pc:sldMkLst>
-          <pc:docMk/>
-          <pc:sldMk cId="2598178450" sldId="298"/>
-        </pc:sldMkLst>
-        <pc:spChg chg="mod">
-          <ac:chgData name="Weifeng Xu" userId="e7aed605-a3dd-4d5a-a692-a87037af107b" providerId="ADAL" clId="{1F4F5B84-491D-43A0-805D-265CDB221584}" dt="2021-06-24T21:48:05.784" v="1096" actId="20577"/>
-          <ac:spMkLst>
-            <pc:docMk/>
-            <pc:sldMk cId="2598178450" sldId="298"/>
-            <ac:spMk id="3" creationId="{6E8C0C4A-EE9E-4BE5-BE22-D346A92B4B65}"/>
-          </ac:spMkLst>
-        </pc:spChg>
-      </pc:sldChg>
-      <pc:sldChg chg="modSp mod">
-        <pc:chgData name="Weifeng Xu" userId="e7aed605-a3dd-4d5a-a692-a87037af107b" providerId="ADAL" clId="{1F4F5B84-491D-43A0-805D-265CDB221584}" dt="2021-06-25T11:48:33.320" v="1137" actId="27636"/>
-        <pc:sldMkLst>
-          <pc:docMk/>
-          <pc:sldMk cId="4108355451" sldId="299"/>
-        </pc:sldMkLst>
-        <pc:spChg chg="mod">
-          <ac:chgData name="Weifeng Xu" userId="e7aed605-a3dd-4d5a-a692-a87037af107b" providerId="ADAL" clId="{1F4F5B84-491D-43A0-805D-265CDB221584}" dt="2021-06-25T11:48:33.320" v="1137" actId="27636"/>
-          <ac:spMkLst>
-            <pc:docMk/>
-            <pc:sldMk cId="4108355451" sldId="299"/>
-            <ac:spMk id="3" creationId="{1A5AF07E-27F2-437F-AE26-3E0C4A83F6DF}"/>
-          </ac:spMkLst>
-        </pc:spChg>
-      </pc:sldChg>
-      <pc:sldChg chg="modSp mod">
-        <pc:chgData name="Weifeng Xu" userId="e7aed605-a3dd-4d5a-a692-a87037af107b" providerId="ADAL" clId="{1F4F5B84-491D-43A0-805D-265CDB221584}" dt="2021-06-22T14:38:29.606" v="186" actId="207"/>
-        <pc:sldMkLst>
-          <pc:docMk/>
-          <pc:sldMk cId="1660567586" sldId="300"/>
-        </pc:sldMkLst>
-        <pc:spChg chg="mod">
-          <ac:chgData name="Weifeng Xu" userId="e7aed605-a3dd-4d5a-a692-a87037af107b" providerId="ADAL" clId="{1F4F5B84-491D-43A0-805D-265CDB221584}" dt="2021-06-22T14:38:29.606" v="186" actId="207"/>
-          <ac:spMkLst>
-            <pc:docMk/>
-            <pc:sldMk cId="1660567586" sldId="300"/>
-            <ac:spMk id="2" creationId="{5A428FDF-B1C8-4F01-BD77-C6B0B4564695}"/>
-          </ac:spMkLst>
-        </pc:spChg>
-      </pc:sldChg>
-      <pc:sldChg chg="modSp mod">
-        <pc:chgData name="Weifeng Xu" userId="e7aed605-a3dd-4d5a-a692-a87037af107b" providerId="ADAL" clId="{1F4F5B84-491D-43A0-805D-265CDB221584}" dt="2021-06-22T14:44:59.326" v="188" actId="114"/>
-        <pc:sldMkLst>
-          <pc:docMk/>
-          <pc:sldMk cId="4031451362" sldId="301"/>
-        </pc:sldMkLst>
-        <pc:spChg chg="mod">
-          <ac:chgData name="Weifeng Xu" userId="e7aed605-a3dd-4d5a-a692-a87037af107b" providerId="ADAL" clId="{1F4F5B84-491D-43A0-805D-265CDB221584}" dt="2021-06-22T14:44:59.326" v="188" actId="114"/>
-          <ac:spMkLst>
-            <pc:docMk/>
-            <pc:sldMk cId="4031451362" sldId="301"/>
-            <ac:spMk id="2" creationId="{9427C24E-AADE-40F8-B0FF-8A108A6D7289}"/>
-          </ac:spMkLst>
-        </pc:spChg>
-      </pc:sldChg>
-      <pc:sldChg chg="modSp mod">
-        <pc:chgData name="Weifeng Xu" userId="e7aed605-a3dd-4d5a-a692-a87037af107b" providerId="ADAL" clId="{1F4F5B84-491D-43A0-805D-265CDB221584}" dt="2021-06-22T14:51:51.418" v="199" actId="114"/>
-        <pc:sldMkLst>
-          <pc:docMk/>
-          <pc:sldMk cId="2386719427" sldId="304"/>
-        </pc:sldMkLst>
-        <pc:spChg chg="mod">
-          <ac:chgData name="Weifeng Xu" userId="e7aed605-a3dd-4d5a-a692-a87037af107b" providerId="ADAL" clId="{1F4F5B84-491D-43A0-805D-265CDB221584}" dt="2021-06-22T14:51:51.418" v="199" actId="114"/>
-          <ac:spMkLst>
-            <pc:docMk/>
-            <pc:sldMk cId="2386719427" sldId="304"/>
-            <ac:spMk id="2" creationId="{89C9E81F-0386-4493-8A46-A2E56985CF8F}"/>
-          </ac:spMkLst>
-        </pc:spChg>
-        <pc:spChg chg="mod">
-          <ac:chgData name="Weifeng Xu" userId="e7aed605-a3dd-4d5a-a692-a87037af107b" providerId="ADAL" clId="{1F4F5B84-491D-43A0-805D-265CDB221584}" dt="2021-06-22T14:51:48.635" v="197" actId="114"/>
-          <ac:spMkLst>
-            <pc:docMk/>
-            <pc:sldMk cId="2386719427" sldId="304"/>
-            <ac:spMk id="3" creationId="{AE804E77-71DD-452B-9B99-E681DBE2714E}"/>
-          </ac:spMkLst>
-        </pc:spChg>
-      </pc:sldChg>
-      <pc:sldChg chg="modSp mod">
-        <pc:chgData name="Weifeng Xu" userId="e7aed605-a3dd-4d5a-a692-a87037af107b" providerId="ADAL" clId="{1F4F5B84-491D-43A0-805D-265CDB221584}" dt="2021-06-22T15:49:18.778" v="317" actId="114"/>
-        <pc:sldMkLst>
-          <pc:docMk/>
-          <pc:sldMk cId="1657819105" sldId="305"/>
-        </pc:sldMkLst>
-        <pc:spChg chg="mod">
-          <ac:chgData name="Weifeng Xu" userId="e7aed605-a3dd-4d5a-a692-a87037af107b" providerId="ADAL" clId="{1F4F5B84-491D-43A0-805D-265CDB221584}" dt="2021-06-22T15:48:23.684" v="309" actId="114"/>
-          <ac:spMkLst>
-            <pc:docMk/>
-            <pc:sldMk cId="1657819105" sldId="305"/>
-            <ac:spMk id="2" creationId="{81B2B962-623B-47A5-AF65-DAA8AC4CB808}"/>
-          </ac:spMkLst>
-        </pc:spChg>
-        <pc:spChg chg="mod">
-          <ac:chgData name="Weifeng Xu" userId="e7aed605-a3dd-4d5a-a692-a87037af107b" providerId="ADAL" clId="{1F4F5B84-491D-43A0-805D-265CDB221584}" dt="2021-06-22T15:49:18.778" v="317" actId="114"/>
-          <ac:spMkLst>
-            <pc:docMk/>
-            <pc:sldMk cId="1657819105" sldId="305"/>
-            <ac:spMk id="3" creationId="{1574B035-BAAD-4460-B1C6-DD9CD59F73C1}"/>
-          </ac:spMkLst>
-        </pc:spChg>
-      </pc:sldChg>
-      <pc:sldChg chg="modSp new mod">
-        <pc:chgData name="Weifeng Xu" userId="e7aed605-a3dd-4d5a-a692-a87037af107b" providerId="ADAL" clId="{1F4F5B84-491D-43A0-805D-265CDB221584}" dt="2021-06-23T18:59:13.957" v="848" actId="20577"/>
-        <pc:sldMkLst>
-          <pc:docMk/>
-          <pc:sldMk cId="4198338688" sldId="307"/>
-        </pc:sldMkLst>
-        <pc:spChg chg="mod">
-          <ac:chgData name="Weifeng Xu" userId="e7aed605-a3dd-4d5a-a692-a87037af107b" providerId="ADAL" clId="{1F4F5B84-491D-43A0-805D-265CDB221584}" dt="2021-06-23T18:57:36.461" v="728"/>
-          <ac:spMkLst>
-            <pc:docMk/>
-            <pc:sldMk cId="4198338688" sldId="307"/>
-            <ac:spMk id="2" creationId="{EF5ADFAF-0651-459A-802B-8BB0CBC5A4A3}"/>
-          </ac:spMkLst>
-        </pc:spChg>
-        <pc:spChg chg="mod">
-          <ac:chgData name="Weifeng Xu" userId="e7aed605-a3dd-4d5a-a692-a87037af107b" providerId="ADAL" clId="{1F4F5B84-491D-43A0-805D-265CDB221584}" dt="2021-06-23T18:59:13.957" v="848" actId="20577"/>
-          <ac:spMkLst>
-            <pc:docMk/>
-            <pc:sldMk cId="4198338688" sldId="307"/>
-            <ac:spMk id="3" creationId="{22CDBE13-DF05-44D1-9DDC-860C8F19E8B2}"/>
-          </ac:spMkLst>
-        </pc:spChg>
       </pc:sldChg>
     </pc:docChg>
   </pc:docChgLst>
@@ -2885,7 +2885,7 @@
           <a:p>
             <a:fld id="{EE41F6E3-57F9-402E-BDBA-5B2DE11C8530}" type="datetimeFigureOut">
               <a:rPr lang="en-US" smtClean="0"/>
-              <a:t>6/25/2021</a:t>
+              <a:t>9/15/2026</a:t>
             </a:fld>
             <a:endParaRPr lang="en-US" dirty="0"/>
           </a:p>
@@ -4424,7 +4424,7 @@
           <a:p>
             <a:fld id="{4263717A-E3C1-4BED-ABE0-B7069385E023}" type="datetimeFigureOut">
               <a:rPr lang="en-US" smtClean="0"/>
-              <a:t>6/25/2021</a:t>
+              <a:t>9/15/2026</a:t>
             </a:fld>
             <a:endParaRPr lang="en-US" dirty="0"/>
           </a:p>
@@ -4597,7 +4597,7 @@
           <a:p>
             <a:fld id="{4263717A-E3C1-4BED-ABE0-B7069385E023}" type="datetimeFigureOut">
               <a:rPr lang="en-US" smtClean="0"/>
-              <a:t>6/25/2021</a:t>
+              <a:t>9/15/2026</a:t>
             </a:fld>
             <a:endParaRPr lang="en-US" dirty="0"/>
           </a:p>
@@ -4775,7 +4775,7 @@
           <a:p>
             <a:fld id="{4263717A-E3C1-4BED-ABE0-B7069385E023}" type="datetimeFigureOut">
               <a:rPr lang="en-US" smtClean="0"/>
-              <a:t>6/25/2021</a:t>
+              <a:t>9/15/2026</a:t>
             </a:fld>
             <a:endParaRPr lang="en-US" dirty="0"/>
           </a:p>
@@ -4943,7 +4943,7 @@
           <a:p>
             <a:fld id="{4263717A-E3C1-4BED-ABE0-B7069385E023}" type="datetimeFigureOut">
               <a:rPr lang="en-US" smtClean="0"/>
-              <a:t>6/25/2021</a:t>
+              <a:t>9/15/2026</a:t>
             </a:fld>
             <a:endParaRPr lang="en-US" dirty="0"/>
           </a:p>
@@ -5188,7 +5188,7 @@
           <a:p>
             <a:fld id="{4263717A-E3C1-4BED-ABE0-B7069385E023}" type="datetimeFigureOut">
               <a:rPr lang="en-US" smtClean="0"/>
-              <a:t>6/25/2021</a:t>
+              <a:t>9/15/2026</a:t>
             </a:fld>
             <a:endParaRPr lang="en-US" dirty="0"/>
           </a:p>
@@ -5417,7 +5417,7 @@
           <a:p>
             <a:fld id="{4263717A-E3C1-4BED-ABE0-B7069385E023}" type="datetimeFigureOut">
               <a:rPr lang="en-US" smtClean="0"/>
-              <a:t>6/25/2021</a:t>
+              <a:t>9/15/2026</a:t>
             </a:fld>
             <a:endParaRPr lang="en-US" dirty="0"/>
           </a:p>
@@ -5781,7 +5781,7 @@
           <a:p>
             <a:fld id="{4263717A-E3C1-4BED-ABE0-B7069385E023}" type="datetimeFigureOut">
               <a:rPr lang="en-US" smtClean="0"/>
-              <a:t>6/25/2021</a:t>
+              <a:t>9/15/2026</a:t>
             </a:fld>
             <a:endParaRPr lang="en-US" dirty="0"/>
           </a:p>
@@ -5898,7 +5898,7 @@
           <a:p>
             <a:fld id="{4263717A-E3C1-4BED-ABE0-B7069385E023}" type="datetimeFigureOut">
               <a:rPr lang="en-US" smtClean="0"/>
-              <a:t>6/25/2021</a:t>
+              <a:t>9/15/2026</a:t>
             </a:fld>
             <a:endParaRPr lang="en-US" dirty="0"/>
           </a:p>
@@ -5993,7 +5993,7 @@
           <a:p>
             <a:fld id="{4263717A-E3C1-4BED-ABE0-B7069385E023}" type="datetimeFigureOut">
               <a:rPr lang="en-US" smtClean="0"/>
-              <a:t>6/25/2021</a:t>
+              <a:t>9/15/2026</a:t>
             </a:fld>
             <a:endParaRPr lang="en-US" dirty="0"/>
           </a:p>
@@ -6268,7 +6268,7 @@
           <a:p>
             <a:fld id="{4263717A-E3C1-4BED-ABE0-B7069385E023}" type="datetimeFigureOut">
               <a:rPr lang="en-US" smtClean="0"/>
-              <a:t>6/25/2021</a:t>
+              <a:t>9/15/2026</a:t>
             </a:fld>
             <a:endParaRPr lang="en-US" dirty="0"/>
           </a:p>
@@ -6523,7 +6523,7 @@
           <a:p>
             <a:fld id="{4263717A-E3C1-4BED-ABE0-B7069385E023}" type="datetimeFigureOut">
               <a:rPr lang="en-US" smtClean="0"/>
-              <a:t>6/25/2021</a:t>
+              <a:t>9/15/2026</a:t>
             </a:fld>
             <a:endParaRPr lang="en-US" dirty="0"/>
           </a:p>
@@ -6734,7 +6734,7 @@
           <a:p>
             <a:fld id="{4263717A-E3C1-4BED-ABE0-B7069385E023}" type="datetimeFigureOut">
               <a:rPr lang="en-US" smtClean="0"/>
-              <a:t>6/25/2021</a:t>
+              <a:t>9/15/2026</a:t>
             </a:fld>
             <a:endParaRPr lang="en-US" dirty="0"/>
           </a:p>
@@ -8392,6 +8392,62 @@
           </a:xfrm>
         </p:spPr>
       </p:pic>
+      <p:sp>
+        <p:nvSpPr>
+          <p:cNvPr id="4" name="TextBox 3">
+            <a:extLst>
+              <a:ext uri="{FF2B5EF4-FFF2-40B4-BE49-F238E27FC236}">
+                <a16:creationId xmlns:a16="http://schemas.microsoft.com/office/drawing/2014/main" id="{985F4ADE-513D-62EB-36AC-22D5F7E089EB}"/>
+              </a:ext>
+            </a:extLst>
+          </p:cNvPr>
+          <p:cNvSpPr txBox="1"/>
+          <p:nvPr/>
+        </p:nvSpPr>
+        <p:spPr>
+          <a:xfrm>
+            <a:off x="2615784" y="3525559"/>
+            <a:ext cx="6175946" cy="923330"/>
+          </a:xfrm>
+          <a:prstGeom prst="rect">
+            <a:avLst/>
+          </a:prstGeom>
+          <a:noFill/>
+        </p:spPr>
+        <p:txBody>
+          <a:bodyPr wrap="square">
+            <a:spAutoFit/>
+          </a:bodyPr>
+          <a:lstStyle/>
+          <a:p>
+            <a:r>
+              <a:rPr lang="en-US" dirty="0">
+                <a:solidFill>
+                  <a:srgbClr val="FF0000"/>
+                </a:solidFill>
+              </a:rPr>
+              <a:t>Try </a:t>
+            </a:r>
+            <a:r>
+              <a:rPr lang="en-US" dirty="0">
+                <a:solidFill>
+                  <a:srgbClr val="FF0000"/>
+                </a:solidFill>
+                <a:hlinkClick r:id="rId5"/>
+              </a:rPr>
+              <a:t>https://drive.google.com/drive/folders/16UdO-QXIg1RTNsRJ595U24VG6WI-RSgx?usp=sharing</a:t>
+            </a:r>
+            <a:r>
+              <a:rPr lang="en-US" dirty="0">
+                <a:solidFill>
+                  <a:srgbClr val="FF0000"/>
+                </a:solidFill>
+              </a:rPr>
+              <a:t> if the above link is blocked</a:t>
+            </a:r>
+          </a:p>
+        </p:txBody>
+      </p:sp>
     </p:spTree>
     <p:extLst>
       <p:ext uri="{BB962C8B-B14F-4D97-AF65-F5344CB8AC3E}">
@@ -8856,7 +8912,7 @@
           <p:nvPr/>
         </p:nvPicPr>
         <p:blipFill>
-          <a:blip r:embed="rId2">
+          <a:blip r:embed="rId2" cstate="print">
             <a:extLst>
               <a:ext uri="{28A0092B-C50C-407E-A947-70E740481C1C}">
                 <a14:useLocalDpi xmlns:a14="http://schemas.microsoft.com/office/drawing/2010/main" val="0"/>
@@ -8950,7 +9006,7 @@
           <p:nvPr/>
         </p:nvPicPr>
         <p:blipFill>
-          <a:blip r:embed="rId4">
+          <a:blip r:embed="rId4" cstate="print">
             <a:extLst>
               <a:ext uri="{28A0092B-C50C-407E-A947-70E740481C1C}">
                 <a14:useLocalDpi xmlns:a14="http://schemas.microsoft.com/office/drawing/2010/main" val="0"/>

</xml_diff>